<commit_message>
Support new concepts in classroom start assignments
</commit_message>
<xml_diff>
--- a/Boek 2 - Kosten, opbrengsten, elasticiteit en surplus/edities/chat-2026/bronnen/H1/paragrafen/2.1.1 Kostenstructuren/2.1.1 Kostenstructuren – presentatie.pptx
+++ b/Boek 2 - Kosten, opbrengsten, elasticiteit en surplus/edities/chat-2026/bronnen/H1/paragrafen/2.1.1 Kostenstructuren/2.1.1 Kostenstructuren – presentatie.pptx
@@ -2,35 +2,35 @@
 <file path=ppt/presentation.xml><?xml version="1.0" encoding="utf-8"?>
 <p:presentation xmlns:p="http://schemas.openxmlformats.org/presentationml/2006/main">
   <p:sldMasterIdLst>
-    <p:sldMasterId xmlns:r="http://schemas.openxmlformats.org/officeDocument/2006/relationships" id="2147483648" r:id="R3be6c66c3f4d463f"/>
+    <p:sldMasterId xmlns:r="http://schemas.openxmlformats.org/officeDocument/2006/relationships" id="2147483648" r:id="R5fe2b01e8d0049cf"/>
   </p:sldMasterIdLst>
   <p:notesMasterIdLst>
-    <p:notesMasterId xmlns:r="http://schemas.openxmlformats.org/officeDocument/2006/relationships" r:id="R27713187235345c7"/>
+    <p:notesMasterId xmlns:r="http://schemas.openxmlformats.org/officeDocument/2006/relationships" r:id="R69e4b48dc258441a"/>
   </p:notesMasterIdLst>
   <p:sldIdLst>
-    <p:sldId xmlns:r="http://schemas.openxmlformats.org/officeDocument/2006/relationships" id="256" r:id="R9aa528a1adae4655"/>
-    <p:sldId xmlns:r="http://schemas.openxmlformats.org/officeDocument/2006/relationships" id="257" r:id="R62bb0f6b95ec4d2b"/>
-    <p:sldId xmlns:r="http://schemas.openxmlformats.org/officeDocument/2006/relationships" id="258" r:id="R3b4b9e4db3964029"/>
-    <p:sldId xmlns:r="http://schemas.openxmlformats.org/officeDocument/2006/relationships" id="259" r:id="R33c59503af814d3e"/>
-    <p:sldId xmlns:r="http://schemas.openxmlformats.org/officeDocument/2006/relationships" id="260" r:id="R023e0ab1870d44c8"/>
-    <p:sldId xmlns:r="http://schemas.openxmlformats.org/officeDocument/2006/relationships" id="261" r:id="R3ffe88aaf1644ec5"/>
-    <p:sldId xmlns:r="http://schemas.openxmlformats.org/officeDocument/2006/relationships" id="262" r:id="Rf5670c9252664bc0"/>
-    <p:sldId xmlns:r="http://schemas.openxmlformats.org/officeDocument/2006/relationships" id="263" r:id="R4ee0577f3d804adb"/>
-    <p:sldId xmlns:r="http://schemas.openxmlformats.org/officeDocument/2006/relationships" id="264" r:id="R02d78bb4e94645a7"/>
-    <p:sldId xmlns:r="http://schemas.openxmlformats.org/officeDocument/2006/relationships" id="265" r:id="R8de919bc37e242c3"/>
-    <p:sldId xmlns:r="http://schemas.openxmlformats.org/officeDocument/2006/relationships" id="266" r:id="Rd7eb99e0710c40d0"/>
-    <p:sldId xmlns:r="http://schemas.openxmlformats.org/officeDocument/2006/relationships" id="267" r:id="R1e4fc1523efc4081"/>
-    <p:sldId xmlns:r="http://schemas.openxmlformats.org/officeDocument/2006/relationships" id="268" r:id="R51e9a44acf354ef7"/>
-    <p:sldId xmlns:r="http://schemas.openxmlformats.org/officeDocument/2006/relationships" id="269" r:id="Re817d3407e1143e6"/>
-    <p:sldId xmlns:r="http://schemas.openxmlformats.org/officeDocument/2006/relationships" id="270" r:id="R5acf205a41814595"/>
-    <p:sldId xmlns:r="http://schemas.openxmlformats.org/officeDocument/2006/relationships" id="271" r:id="Rf35d83f1695f4683"/>
-    <p:sldId xmlns:r="http://schemas.openxmlformats.org/officeDocument/2006/relationships" id="272" r:id="R8f01f96bd6ca4b27"/>
-    <p:sldId xmlns:r="http://schemas.openxmlformats.org/officeDocument/2006/relationships" id="273" r:id="R19a507cc448f4d64"/>
-    <p:sldId xmlns:r="http://schemas.openxmlformats.org/officeDocument/2006/relationships" id="274" r:id="Rb658ee5281814d34"/>
-    <p:sldId xmlns:r="http://schemas.openxmlformats.org/officeDocument/2006/relationships" id="275" r:id="R8b853ba3d3db4652"/>
-    <p:sldId xmlns:r="http://schemas.openxmlformats.org/officeDocument/2006/relationships" id="276" r:id="R60b0ca6031434a48"/>
-    <p:sldId xmlns:r="http://schemas.openxmlformats.org/officeDocument/2006/relationships" id="277" r:id="R340a2eafc25c488e"/>
-    <p:sldId xmlns:r="http://schemas.openxmlformats.org/officeDocument/2006/relationships" id="278" r:id="R1a3a98762f7c45e0"/>
+    <p:sldId xmlns:r="http://schemas.openxmlformats.org/officeDocument/2006/relationships" id="256" r:id="Ra53b53c19a4e4e30"/>
+    <p:sldId xmlns:r="http://schemas.openxmlformats.org/officeDocument/2006/relationships" id="257" r:id="R9936fc74aae44817"/>
+    <p:sldId xmlns:r="http://schemas.openxmlformats.org/officeDocument/2006/relationships" id="258" r:id="Rff56c83509554d0c"/>
+    <p:sldId xmlns:r="http://schemas.openxmlformats.org/officeDocument/2006/relationships" id="259" r:id="Rdbba363ed5cd48c5"/>
+    <p:sldId xmlns:r="http://schemas.openxmlformats.org/officeDocument/2006/relationships" id="260" r:id="R25b3226d9de94474"/>
+    <p:sldId xmlns:r="http://schemas.openxmlformats.org/officeDocument/2006/relationships" id="261" r:id="Rf35d10e3175c48cb"/>
+    <p:sldId xmlns:r="http://schemas.openxmlformats.org/officeDocument/2006/relationships" id="262" r:id="R7ec6fdb47a5c4b59"/>
+    <p:sldId xmlns:r="http://schemas.openxmlformats.org/officeDocument/2006/relationships" id="263" r:id="R1562a3d155674cd8"/>
+    <p:sldId xmlns:r="http://schemas.openxmlformats.org/officeDocument/2006/relationships" id="264" r:id="R9f988f05db9b4bd4"/>
+    <p:sldId xmlns:r="http://schemas.openxmlformats.org/officeDocument/2006/relationships" id="265" r:id="Rf89c6d54a9cf4c37"/>
+    <p:sldId xmlns:r="http://schemas.openxmlformats.org/officeDocument/2006/relationships" id="266" r:id="R082d804bef36466a"/>
+    <p:sldId xmlns:r="http://schemas.openxmlformats.org/officeDocument/2006/relationships" id="267" r:id="R760c5ad2020843dd"/>
+    <p:sldId xmlns:r="http://schemas.openxmlformats.org/officeDocument/2006/relationships" id="268" r:id="Rd6fb1213e10c4185"/>
+    <p:sldId xmlns:r="http://schemas.openxmlformats.org/officeDocument/2006/relationships" id="269" r:id="Ra4c893bfeb5049ff"/>
+    <p:sldId xmlns:r="http://schemas.openxmlformats.org/officeDocument/2006/relationships" id="270" r:id="R607b4416eff747b6"/>
+    <p:sldId xmlns:r="http://schemas.openxmlformats.org/officeDocument/2006/relationships" id="271" r:id="R1b0884da9be8499a"/>
+    <p:sldId xmlns:r="http://schemas.openxmlformats.org/officeDocument/2006/relationships" id="272" r:id="R59b71c1838e64535"/>
+    <p:sldId xmlns:r="http://schemas.openxmlformats.org/officeDocument/2006/relationships" id="273" r:id="Rfed4746be0224eea"/>
+    <p:sldId xmlns:r="http://schemas.openxmlformats.org/officeDocument/2006/relationships" id="274" r:id="R86dcd21860c4472c"/>
+    <p:sldId xmlns:r="http://schemas.openxmlformats.org/officeDocument/2006/relationships" id="275" r:id="R54d5db1cd2084b0f"/>
+    <p:sldId xmlns:r="http://schemas.openxmlformats.org/officeDocument/2006/relationships" id="276" r:id="R2345be4fb5904a9d"/>
+    <p:sldId xmlns:r="http://schemas.openxmlformats.org/officeDocument/2006/relationships" id="277" r:id="R45b134fa991c471e"/>
+    <p:sldId xmlns:r="http://schemas.openxmlformats.org/officeDocument/2006/relationships" id="278" r:id="R2c6932df958f4567"/>
   </p:sldIdLst>
   <p:sldSz cx="15240000" cy="8572500"/>
   <p:notesSz cx="6858000" cy="9144000"/>
@@ -220,16 +220,16 @@
         <a:srgbClr val="96607D"/>
       </a:folHlink>
     </a:clrScheme>
-    <a:fontScheme name="Office">
+    <a:fontScheme name="">
       <a:majorFont>
-        <a:latin typeface="Calibri Light"/>
-        <a:ea typeface="Calibri Light"/>
-        <a:cs typeface="Calibri Light"/>
+        <a:latin typeface="Aptos"/>
+        <a:ea typeface=""/>
+        <a:cs typeface=""/>
       </a:majorFont>
       <a:minorFont>
-        <a:latin typeface="Calibri"/>
-        <a:ea typeface="Calibri"/>
-        <a:cs typeface="Calibri"/>
+        <a:latin typeface="Aptos"/>
+        <a:ea typeface=""/>
+        <a:cs typeface=""/>
       </a:minorFont>
     </a:fontScheme>
     <a:fmtScheme name="ChatGPT">
@@ -489,6 +489,18 @@
           <a:p xmlns:a="http://schemas.openxmlformats.org/drawingml/2006/main">
             <a:r>
               <a:rPr sz="1400"/>
+              <a:t>Start en terugblik: Opgave 1 haalt invullen in een gegeven formule en verdelen op; de formule en betekenissen staan in de opgave. Kostenindeling en vooral TCK tegenover GCK zijn nieuw. Lees bij opgave 2 eerst de uitleg over constante en variabele kosten op p. 2 en over gemiddelde kosten op p. 4. Laat leerlingen bij deze verkenning aanwijzen welke uitleg zij gebruiken en hun twijfel noteren. Verwacht de nieuwe bewerking nog niet zonder steun. Bij terugkeer naar dit overzicht vóór het basiswerk: laat leerlingen opgave 2 opnieuw proberen na de uitleg, bespreek hun redenering en geef zo nodig extra steun. Dit is een verkennende start, geen toets van al beheerste nieuwe leerstof.</a:t>
+            </a:r>
+          </a:p>
+          <a:p xmlns:a="http://schemas.openxmlformats.org/drawingml/2006/main">
+            <a:r>
+              <a:rPr sz="1400"/>
+              <a:t/>
+            </a:r>
+          </a:p>
+          <a:p xmlns:a="http://schemas.openxmlformats.org/drawingml/2006/main">
+            <a:r>
+              <a:rPr sz="1400"/>
               <a:t>Misvatting: Gebruik het gedrukte paginanummer: pagina 6 is de achtste fysieke pagina van het complete PDF-bestand.</a:t>
             </a:r>
           </a:p>
@@ -882,6 +894,18 @@
           <a:p xmlns:a="http://schemas.openxmlformats.org/drawingml/2006/main">
             <a:r>
               <a:rPr sz="1400"/>
+              <a:t>Start en terugblik: Opgave 1 haalt invullen in een gegeven formule en verdelen op; de formule en betekenissen staan in de opgave. Kostenindeling en vooral TCK tegenover GCK zijn nieuw. Lees bij opgave 2 eerst de uitleg over constante en variabele kosten op p. 2 en over gemiddelde kosten op p. 4. Laat leerlingen bij deze verkenning aanwijzen welke uitleg zij gebruiken en hun twijfel noteren. Verwacht de nieuwe bewerking nog niet zonder steun. Bij terugkeer naar dit overzicht vóór het basiswerk: laat leerlingen opgave 2 opnieuw proberen na de uitleg, bespreek hun redenering en geef zo nodig extra steun. Dit is een verkennende start, geen toets van al beheerste nieuwe leerstof.</a:t>
+            </a:r>
+          </a:p>
+          <a:p xmlns:a="http://schemas.openxmlformats.org/drawingml/2006/main">
+            <a:r>
+              <a:rPr sz="1400"/>
+              <a:t/>
+            </a:r>
+          </a:p>
+          <a:p xmlns:a="http://schemas.openxmlformats.org/drawingml/2006/main">
+            <a:r>
+              <a:rPr sz="1400"/>
               <a:t>Misvatting: Gebruik het gedrukte paginanummer: pagina 6 is de achtste fysieke pagina van het complete PDF-bestand.</a:t>
             </a:r>
           </a:p>
@@ -2443,6 +2467,18 @@
             <a:r>
               <a:rPr sz="1400"/>
               <a:t>Uitleg: Laat deze dia staan tijdens afsluiting / huiswerk. De docent heeft expliciet gekozen voor opgaven 1 en 2 als startopdracht. Opgaven 3 en 4 zijn basis, 5 en 6 zelfstandig, 7 doel. Huiswerk: 3, 4, 5, 6 en 7 maken en nakijken. Start 1–2 en basis 3 staan op pagina 6; basis 4 en zelfstandig 5–6 staan op pagina 7; doel 7 op pagina 8. De volledige oefenroute hoeft niet binnen één les af te zijn.</a:t>
+            </a:r>
+          </a:p>
+          <a:p xmlns:a="http://schemas.openxmlformats.org/drawingml/2006/main">
+            <a:r>
+              <a:rPr sz="1400"/>
+              <a:t/>
+            </a:r>
+          </a:p>
+          <a:p xmlns:a="http://schemas.openxmlformats.org/drawingml/2006/main">
+            <a:r>
+              <a:rPr sz="1400"/>
+              <a:t>Start en terugblik: Opgave 1 haalt invullen in een gegeven formule en verdelen op; de formule en betekenissen staan in de opgave. Kostenindeling en vooral TCK tegenover GCK zijn nieuw. Lees bij opgave 2 eerst de uitleg over constante en variabele kosten op p. 2 en over gemiddelde kosten op p. 4. Laat leerlingen bij deze verkenning aanwijzen welke uitleg zij gebruiken en hun twijfel noteren. Verwacht de nieuwe bewerking nog niet zonder steun. Bij terugkeer naar dit overzicht vóór het basiswerk: laat leerlingen opgave 2 opnieuw proberen na de uitleg, bespreek hun redenering en geef zo nodig extra steun. Dit is een verkennende start, geen toets van al beheerste nieuwe leerstof.</a:t>
             </a:r>
           </a:p>
           <a:p xmlns:a="http://schemas.openxmlformats.org/drawingml/2006/main">
@@ -3475,7 +3511,7 @@
   </p:cSld>
   <p:clrMap bg1="lt1" tx1="dk1" bg2="lt2" tx2="dk2" accent1="accent1" accent2="accent2" accent3="accent3" accent4="accent4" accent5="accent5" accent6="accent6" hlink="hlink" folHlink="folHlink"/>
   <p:sldLayoutIdLst>
-    <p:sldLayoutId xmlns:r="http://schemas.openxmlformats.org/officeDocument/2006/relationships" id="2147483649" r:id="Rcab465cde5eb4403"/>
+    <p:sldLayoutId xmlns:r="http://schemas.openxmlformats.org/officeDocument/2006/relationships" id="2147483649" r:id="R0af1817689274fca"/>
   </p:sldLayoutIdLst>
   <p:txStyles>
     <p:titleStyle>
@@ -3798,16 +3834,16 @@
         <a:srgbClr val="96607D"/>
       </a:folHlink>
     </a:clrScheme>
-    <a:fontScheme name="Office">
+    <a:fontScheme name="">
       <a:majorFont>
-        <a:latin typeface="Calibri Light"/>
-        <a:ea typeface="Calibri Light"/>
-        <a:cs typeface="Calibri Light"/>
+        <a:latin typeface="Aptos"/>
+        <a:ea typeface=""/>
+        <a:cs typeface=""/>
       </a:majorFont>
       <a:minorFont>
-        <a:latin typeface="Calibri"/>
-        <a:ea typeface="Calibri"/>
-        <a:cs typeface="Calibri"/>
+        <a:latin typeface="Aptos"/>
+        <a:ea typeface=""/>
+        <a:cs typeface=""/>
       </a:minorFont>
     </a:fontScheme>
     <a:fmtScheme name="ChatGPT">
@@ -4817,7 +4853,7 @@
           <p:cNvPr id="29" name="Deze les: §2.1.1 Kostenstructuren">
             <a:extLst xmlns:a="http://schemas.openxmlformats.org/drawingml/2006/main">
               <a:ext uri="{FF2B5EF4-FFF2-40B4-BE49-F238E27FC236}">
-                <a16:creationId xmlns:a16="http://schemas.microsoft.com/office/drawing/2014/main" id="{B3AB244A-0A34-4D4D-A4DA-34BC58B83F4C}"/>
+                <a16:creationId xmlns:a16="http://schemas.microsoft.com/office/drawing/2014/main" id="{A5D38FAE-B3A7-4C87-A78A-0105D85ED153}"/>
               </a:ext>
             </a:extLst>
           </p:cNvPr>
@@ -4874,7 +4910,7 @@
           <p:cNvPr id="2" name="">
             <a:extLst xmlns:a="http://schemas.openxmlformats.org/drawingml/2006/main">
               <a:ext uri="{FF2B5EF4-FFF2-40B4-BE49-F238E27FC236}">
-                <a16:creationId xmlns:a16="http://schemas.microsoft.com/office/drawing/2014/main" id="{FAA64E04-0ABB-40F2-8FE8-3D8EDB01AEB1}"/>
+                <a16:creationId xmlns:a16="http://schemas.microsoft.com/office/drawing/2014/main" id="{09683213-9F84-45E3-B239-6F3A9FCE77E7}"/>
               </a:ext>
             </a:extLst>
           </p:cNvPr>
@@ -4903,7 +4939,7 @@
           <p:cNvPr id="3" name="§2.1.1 Kostenstructuren">
             <a:extLst xmlns:a="http://schemas.openxmlformats.org/drawingml/2006/main">
               <a:ext uri="{FF2B5EF4-FFF2-40B4-BE49-F238E27FC236}">
-                <a16:creationId xmlns:a16="http://schemas.microsoft.com/office/drawing/2014/main" id="{399939AF-6C55-4745-9F96-13BB5B9E1522}"/>
+                <a16:creationId xmlns:a16="http://schemas.microsoft.com/office/drawing/2014/main" id="{79B4E1B8-1B50-4C7D-ABC9-EDF6612F448D}"/>
               </a:ext>
             </a:extLst>
           </p:cNvPr>
@@ -4960,7 +4996,7 @@
           <p:cNvPr id="4" name="1">
             <a:extLst xmlns:a="http://schemas.openxmlformats.org/drawingml/2006/main">
               <a:ext uri="{FF2B5EF4-FFF2-40B4-BE49-F238E27FC236}">
-                <a16:creationId xmlns:a16="http://schemas.microsoft.com/office/drawing/2014/main" id="{CBC1B141-3661-4310-B6C9-B0D1E5A9D042}"/>
+                <a16:creationId xmlns:a16="http://schemas.microsoft.com/office/drawing/2014/main" id="{1CF77472-C69C-414E-8F87-28AA57448608}"/>
               </a:ext>
             </a:extLst>
           </p:cNvPr>
@@ -5017,7 +5053,7 @@
           <p:cNvPr id="5" name="phase">
             <a:extLst xmlns:a="http://schemas.openxmlformats.org/drawingml/2006/main">
               <a:ext uri="{FF2B5EF4-FFF2-40B4-BE49-F238E27FC236}">
-                <a16:creationId xmlns:a16="http://schemas.microsoft.com/office/drawing/2014/main" id="{95DE5170-0B1C-4A0F-BE6D-F7E74486CCBB}"/>
+                <a16:creationId xmlns:a16="http://schemas.microsoft.com/office/drawing/2014/main" id="{37043238-6926-4D07-B149-1CC2892B85BC}"/>
               </a:ext>
             </a:extLst>
           </p:cNvPr>
@@ -5074,7 +5110,7 @@
           <p:cNvPr id="6" name="Lesroute">
             <a:extLst xmlns:a="http://schemas.openxmlformats.org/drawingml/2006/main">
               <a:ext uri="{FF2B5EF4-FFF2-40B4-BE49-F238E27FC236}">
-                <a16:creationId xmlns:a16="http://schemas.microsoft.com/office/drawing/2014/main" id="{8C79C3D6-DBA3-4AFE-8A0D-595C37B09956}"/>
+                <a16:creationId xmlns:a16="http://schemas.microsoft.com/office/drawing/2014/main" id="{53DCDE4C-2CFB-4B85-ADFD-BA59E6855F7E}"/>
               </a:ext>
             </a:extLst>
           </p:cNvPr>
@@ -5131,7 +5167,7 @@
           <p:cNvPr id="7" name="route-number-1">
             <a:extLst xmlns:a="http://schemas.openxmlformats.org/drawingml/2006/main">
               <a:ext uri="{FF2B5EF4-FFF2-40B4-BE49-F238E27FC236}">
-                <a16:creationId xmlns:a16="http://schemas.microsoft.com/office/drawing/2014/main" id="{ECF5D03E-ADF3-4882-8085-77C426BBAFA3}"/>
+                <a16:creationId xmlns:a16="http://schemas.microsoft.com/office/drawing/2014/main" id="{4921B922-C2C4-4400-A88D-B8A721F66CF3}"/>
               </a:ext>
             </a:extLst>
           </p:cNvPr>
@@ -5188,7 +5224,7 @@
           <p:cNvPr id="8" name="route-1">
             <a:extLst xmlns:a="http://schemas.openxmlformats.org/drawingml/2006/main">
               <a:ext uri="{FF2B5EF4-FFF2-40B4-BE49-F238E27FC236}">
-                <a16:creationId xmlns:a16="http://schemas.microsoft.com/office/drawing/2014/main" id="{3CB8659F-0FD7-458F-A269-E65EAB770680}"/>
+                <a16:creationId xmlns:a16="http://schemas.microsoft.com/office/drawing/2014/main" id="{B51B364B-0605-482D-BCED-70376B17F404}"/>
               </a:ext>
             </a:extLst>
           </p:cNvPr>
@@ -5245,7 +5281,7 @@
           <p:cNvPr id="9" name="route-number-2">
             <a:extLst xmlns:a="http://schemas.openxmlformats.org/drawingml/2006/main">
               <a:ext uri="{FF2B5EF4-FFF2-40B4-BE49-F238E27FC236}">
-                <a16:creationId xmlns:a16="http://schemas.microsoft.com/office/drawing/2014/main" id="{52B72B83-7702-4968-B6F9-EF08298B4E5E}"/>
+                <a16:creationId xmlns:a16="http://schemas.microsoft.com/office/drawing/2014/main" id="{9C6805F8-9AB9-4CCF-B38B-E88208CC01E7}"/>
               </a:ext>
             </a:extLst>
           </p:cNvPr>
@@ -5302,7 +5338,7 @@
           <p:cNvPr id="10" name="route-2">
             <a:extLst xmlns:a="http://schemas.openxmlformats.org/drawingml/2006/main">
               <a:ext uri="{FF2B5EF4-FFF2-40B4-BE49-F238E27FC236}">
-                <a16:creationId xmlns:a16="http://schemas.microsoft.com/office/drawing/2014/main" id="{CF00A358-6868-45C4-98BD-72659C297A69}"/>
+                <a16:creationId xmlns:a16="http://schemas.microsoft.com/office/drawing/2014/main" id="{2226C412-18A1-4D07-9C82-099FC7E6E749}"/>
               </a:ext>
             </a:extLst>
           </p:cNvPr>
@@ -5359,7 +5395,7 @@
           <p:cNvPr id="11" name="route-number-3">
             <a:extLst xmlns:a="http://schemas.openxmlformats.org/drawingml/2006/main">
               <a:ext uri="{FF2B5EF4-FFF2-40B4-BE49-F238E27FC236}">
-                <a16:creationId xmlns:a16="http://schemas.microsoft.com/office/drawing/2014/main" id="{B683538F-D2DB-4B9F-A6F2-B35E3A7336D1}"/>
+                <a16:creationId xmlns:a16="http://schemas.microsoft.com/office/drawing/2014/main" id="{771BB11F-3A66-4ACD-BDA4-556E8D7FE1FF}"/>
               </a:ext>
             </a:extLst>
           </p:cNvPr>
@@ -5416,7 +5452,7 @@
           <p:cNvPr id="12" name="route-3">
             <a:extLst xmlns:a="http://schemas.openxmlformats.org/drawingml/2006/main">
               <a:ext uri="{FF2B5EF4-FFF2-40B4-BE49-F238E27FC236}">
-                <a16:creationId xmlns:a16="http://schemas.microsoft.com/office/drawing/2014/main" id="{FC76EF9A-F633-4E03-A139-DD700AC446D7}"/>
+                <a16:creationId xmlns:a16="http://schemas.microsoft.com/office/drawing/2014/main" id="{688C48AC-E0F6-44B9-9655-F39F9FE1DE0B}"/>
               </a:ext>
             </a:extLst>
           </p:cNvPr>
@@ -5473,7 +5509,7 @@
           <p:cNvPr id="13" name="route-number-4">
             <a:extLst xmlns:a="http://schemas.openxmlformats.org/drawingml/2006/main">
               <a:ext uri="{FF2B5EF4-FFF2-40B4-BE49-F238E27FC236}">
-                <a16:creationId xmlns:a16="http://schemas.microsoft.com/office/drawing/2014/main" id="{60E6FD43-E9EC-4E31-BAA9-991DB6FFAED2}"/>
+                <a16:creationId xmlns:a16="http://schemas.microsoft.com/office/drawing/2014/main" id="{331FB3A6-E22D-4180-AA0E-64836A55A0E1}"/>
               </a:ext>
             </a:extLst>
           </p:cNvPr>
@@ -5530,7 +5566,7 @@
           <p:cNvPr id="14" name="route-4">
             <a:extLst xmlns:a="http://schemas.openxmlformats.org/drawingml/2006/main">
               <a:ext uri="{FF2B5EF4-FFF2-40B4-BE49-F238E27FC236}">
-                <a16:creationId xmlns:a16="http://schemas.microsoft.com/office/drawing/2014/main" id="{81486C3B-23EB-4B46-90C3-48EEB4A93B5A}"/>
+                <a16:creationId xmlns:a16="http://schemas.microsoft.com/office/drawing/2014/main" id="{E931FCAA-FFAA-4C1A-A049-4A56885C431E}"/>
               </a:ext>
             </a:extLst>
           </p:cNvPr>
@@ -5587,7 +5623,7 @@
           <p:cNvPr id="15" name="route-number-5">
             <a:extLst xmlns:a="http://schemas.openxmlformats.org/drawingml/2006/main">
               <a:ext uri="{FF2B5EF4-FFF2-40B4-BE49-F238E27FC236}">
-                <a16:creationId xmlns:a16="http://schemas.microsoft.com/office/drawing/2014/main" id="{AEA08F60-5F57-44F4-80B0-3439A79B7C08}"/>
+                <a16:creationId xmlns:a16="http://schemas.microsoft.com/office/drawing/2014/main" id="{4E96A388-C7C9-459D-A771-3F5B401CB259}"/>
               </a:ext>
             </a:extLst>
           </p:cNvPr>
@@ -5644,7 +5680,7 @@
           <p:cNvPr id="16" name="route-5">
             <a:extLst xmlns:a="http://schemas.openxmlformats.org/drawingml/2006/main">
               <a:ext uri="{FF2B5EF4-FFF2-40B4-BE49-F238E27FC236}">
-                <a16:creationId xmlns:a16="http://schemas.microsoft.com/office/drawing/2014/main" id="{0E0FC6F3-B701-44AF-AB39-A5D33407920D}"/>
+                <a16:creationId xmlns:a16="http://schemas.microsoft.com/office/drawing/2014/main" id="{6CFE2454-EBCF-4326-B227-D69993A3F248}"/>
               </a:ext>
             </a:extLst>
           </p:cNvPr>
@@ -5701,7 +5737,7 @@
           <p:cNvPr id="17" name="route-number-6">
             <a:extLst xmlns:a="http://schemas.openxmlformats.org/drawingml/2006/main">
               <a:ext uri="{FF2B5EF4-FFF2-40B4-BE49-F238E27FC236}">
-                <a16:creationId xmlns:a16="http://schemas.microsoft.com/office/drawing/2014/main" id="{997BA096-581E-4DBC-9750-C4EEEC35780E}"/>
+                <a16:creationId xmlns:a16="http://schemas.microsoft.com/office/drawing/2014/main" id="{0AFFD25C-C321-4613-AC07-D54DB434628C}"/>
               </a:ext>
             </a:extLst>
           </p:cNvPr>
@@ -5758,7 +5794,7 @@
           <p:cNvPr id="18" name="route-6">
             <a:extLst xmlns:a="http://schemas.openxmlformats.org/drawingml/2006/main">
               <a:ext uri="{FF2B5EF4-FFF2-40B4-BE49-F238E27FC236}">
-                <a16:creationId xmlns:a16="http://schemas.microsoft.com/office/drawing/2014/main" id="{D941DF7A-1D07-4402-B1B3-377678DBBD60}"/>
+                <a16:creationId xmlns:a16="http://schemas.microsoft.com/office/drawing/2014/main" id="{76D4ED73-09AF-436A-A0F3-A380CB96597C}"/>
               </a:ext>
             </a:extLst>
           </p:cNvPr>
@@ -5815,7 +5851,7 @@
           <p:cNvPr id="19" name="route-number-7">
             <a:extLst xmlns:a="http://schemas.openxmlformats.org/drawingml/2006/main">
               <a:ext uri="{FF2B5EF4-FFF2-40B4-BE49-F238E27FC236}">
-                <a16:creationId xmlns:a16="http://schemas.microsoft.com/office/drawing/2014/main" id="{91A7B22B-6B82-4E99-AD0D-197FD1CBEAAC}"/>
+                <a16:creationId xmlns:a16="http://schemas.microsoft.com/office/drawing/2014/main" id="{C5CA4957-7470-4E6B-8599-D54B296AF6FC}"/>
               </a:ext>
             </a:extLst>
           </p:cNvPr>
@@ -5872,7 +5908,7 @@
           <p:cNvPr id="20" name="route-7">
             <a:extLst xmlns:a="http://schemas.openxmlformats.org/drawingml/2006/main">
               <a:ext uri="{FF2B5EF4-FFF2-40B4-BE49-F238E27FC236}">
-                <a16:creationId xmlns:a16="http://schemas.microsoft.com/office/drawing/2014/main" id="{0F9152E1-1E3A-4E15-803B-81005610E6F8}"/>
+                <a16:creationId xmlns:a16="http://schemas.microsoft.com/office/drawing/2014/main" id="{FD9DDE3A-B4A5-4C63-8B2C-54E6536B2484}"/>
               </a:ext>
             </a:extLst>
           </p:cNvPr>
@@ -5929,7 +5965,7 @@
           <p:cNvPr id="21" name="Lesdoelen">
             <a:extLst xmlns:a="http://schemas.openxmlformats.org/drawingml/2006/main">
               <a:ext uri="{FF2B5EF4-FFF2-40B4-BE49-F238E27FC236}">
-                <a16:creationId xmlns:a16="http://schemas.microsoft.com/office/drawing/2014/main" id="{14973DFE-5100-4432-BB0E-343BC34E4E2F}"/>
+                <a16:creationId xmlns:a16="http://schemas.microsoft.com/office/drawing/2014/main" id="{261D33FD-C7A0-40D8-874F-4E6DE46A3C13}"/>
               </a:ext>
             </a:extLst>
           </p:cNvPr>
@@ -5986,7 +6022,7 @@
           <p:cNvPr id="22" name="overview-goals">
             <a:extLst xmlns:a="http://schemas.openxmlformats.org/drawingml/2006/main">
               <a:ext uri="{FF2B5EF4-FFF2-40B4-BE49-F238E27FC236}">
-                <a16:creationId xmlns:a16="http://schemas.microsoft.com/office/drawing/2014/main" id="{DFF6092B-1CAD-484D-B47F-7FED78F2415A}"/>
+                <a16:creationId xmlns:a16="http://schemas.microsoft.com/office/drawing/2014/main" id="{48A1E8FF-897C-47AA-BEF7-F8739FA2DA3D}"/>
               </a:ext>
             </a:extLst>
           </p:cNvPr>
@@ -6089,7 +6125,7 @@
           <p:cNvPr id="23" name="">
             <a:extLst xmlns:a="http://schemas.openxmlformats.org/drawingml/2006/main">
               <a:ext uri="{FF2B5EF4-FFF2-40B4-BE49-F238E27FC236}">
-                <a16:creationId xmlns:a16="http://schemas.microsoft.com/office/drawing/2014/main" id="{B91FDD66-9F04-47E5-B0B7-867342123476}"/>
+                <a16:creationId xmlns:a16="http://schemas.microsoft.com/office/drawing/2014/main" id="{187A1A10-AC0F-44FF-A7CD-85CEFB65A27A}"/>
               </a:ext>
             </a:extLst>
           </p:cNvPr>
@@ -6118,7 +6154,7 @@
           <p:cNvPr id="24" name="Startopdracht">
             <a:extLst xmlns:a="http://schemas.openxmlformats.org/drawingml/2006/main">
               <a:ext uri="{FF2B5EF4-FFF2-40B4-BE49-F238E27FC236}">
-                <a16:creationId xmlns:a16="http://schemas.microsoft.com/office/drawing/2014/main" id="{9EFE9EC2-B02C-42D0-8CEF-536261E464C3}"/>
+                <a16:creationId xmlns:a16="http://schemas.microsoft.com/office/drawing/2014/main" id="{86933CB1-11EB-4AB6-B414-F210EA91E303}"/>
               </a:ext>
             </a:extLst>
           </p:cNvPr>
@@ -6175,7 +6211,7 @@
           <p:cNvPr id="25" name="overview-start">
             <a:extLst xmlns:a="http://schemas.openxmlformats.org/drawingml/2006/main">
               <a:ext uri="{FF2B5EF4-FFF2-40B4-BE49-F238E27FC236}">
-                <a16:creationId xmlns:a16="http://schemas.microsoft.com/office/drawing/2014/main" id="{EC2BBE51-8ED9-4708-9BBC-9FF4D124EE8B}"/>
+                <a16:creationId xmlns:a16="http://schemas.microsoft.com/office/drawing/2014/main" id="{54B5D8C1-E008-4334-A900-46909792561A}"/>
               </a:ext>
             </a:extLst>
           </p:cNvPr>
@@ -6204,48 +6240,48 @@
           <a:lstStyle xmlns:a="http://schemas.openxmlformats.org/drawingml/2006/main"/>
           <a:p xmlns:a="http://schemas.openxmlformats.org/drawingml/2006/main">
             <a:pPr algn="l">
-              <a:defRPr sz="2475" b="1">
-                <a:solidFill>
-                  <a:srgbClr val="183247"/>
-                </a:solidFill>
-                <a:latin typeface="Arial"/>
-                <a:ea typeface="Arial"/>
-                <a:cs typeface="Arial"/>
-              </a:defRPr>
-            </a:pPr>
-            <a:r>
-              <a:rPr sz="2475" b="1">
-                <a:solidFill>
-                  <a:srgbClr val="183247"/>
-                </a:solidFill>
-                <a:latin typeface="Arial"/>
-                <a:ea typeface="Arial"/>
-                <a:cs typeface="Arial"/>
-              </a:rPr>
-              <a:t>Pagina 6</a:t>
-            </a:r>
-          </a:p>
-          <a:p xmlns:a="http://schemas.openxmlformats.org/drawingml/2006/main">
-            <a:pPr algn="l">
-              <a:defRPr sz="2475" b="1">
-                <a:solidFill>
-                  <a:srgbClr val="183247"/>
-                </a:solidFill>
-                <a:latin typeface="Arial"/>
-                <a:ea typeface="Arial"/>
-                <a:cs typeface="Arial"/>
-              </a:defRPr>
-            </a:pPr>
-            <a:r>
-              <a:rPr sz="2475" b="1">
-                <a:solidFill>
-                  <a:srgbClr val="183247"/>
-                </a:solidFill>
-                <a:latin typeface="Arial"/>
-                <a:ea typeface="Arial"/>
-                <a:cs typeface="Arial"/>
-              </a:rPr>
-              <a:t>Opgaven 1 en 2</a:t>
+              <a:defRPr sz="2250" b="1">
+                <a:solidFill>
+                  <a:srgbClr val="183247"/>
+                </a:solidFill>
+                <a:latin typeface="Arial"/>
+                <a:ea typeface="Arial"/>
+                <a:cs typeface="Arial"/>
+              </a:defRPr>
+            </a:pPr>
+            <a:r>
+              <a:rPr sz="2250" b="1">
+                <a:solidFill>
+                  <a:srgbClr val="183247"/>
+                </a:solidFill>
+                <a:latin typeface="Arial"/>
+                <a:ea typeface="Arial"/>
+                <a:cs typeface="Arial"/>
+              </a:rPr>
+              <a:t>Pagina 6 · Opgaven 1 en 2</a:t>
+            </a:r>
+          </a:p>
+          <a:p xmlns:a="http://schemas.openxmlformats.org/drawingml/2006/main">
+            <a:pPr algn="l">
+              <a:defRPr sz="2250" b="1">
+                <a:solidFill>
+                  <a:srgbClr val="183247"/>
+                </a:solidFill>
+                <a:latin typeface="Arial"/>
+                <a:ea typeface="Arial"/>
+                <a:cs typeface="Arial"/>
+              </a:defRPr>
+            </a:pPr>
+            <a:r>
+              <a:rPr sz="2250" b="1">
+                <a:solidFill>
+                  <a:srgbClr val="183247"/>
+                </a:solidFill>
+                <a:latin typeface="Arial"/>
+                <a:ea typeface="Arial"/>
+                <a:cs typeface="Arial"/>
+              </a:rPr>
+              <a:t>2: verkennen, theorie p. 2–4</a:t>
             </a:r>
           </a:p>
         </p:txBody>
@@ -6255,7 +6291,7 @@
           <p:cNvPr id="26" name="">
             <a:extLst xmlns:a="http://schemas.openxmlformats.org/drawingml/2006/main">
               <a:ext uri="{FF2B5EF4-FFF2-40B4-BE49-F238E27FC236}">
-                <a16:creationId xmlns:a16="http://schemas.microsoft.com/office/drawing/2014/main" id="{721D49D4-8261-4A74-BF14-8816970AD97E}"/>
+                <a16:creationId xmlns:a16="http://schemas.microsoft.com/office/drawing/2014/main" id="{9C05DE55-3F66-4CF7-8B68-B5DCE0807894}"/>
               </a:ext>
             </a:extLst>
           </p:cNvPr>
@@ -6284,7 +6320,7 @@
           <p:cNvPr id="27" name="Huiswerk">
             <a:extLst xmlns:a="http://schemas.openxmlformats.org/drawingml/2006/main">
               <a:ext uri="{FF2B5EF4-FFF2-40B4-BE49-F238E27FC236}">
-                <a16:creationId xmlns:a16="http://schemas.microsoft.com/office/drawing/2014/main" id="{68CF65E1-AADC-48C1-BEA2-DE2962FCF843}"/>
+                <a16:creationId xmlns:a16="http://schemas.microsoft.com/office/drawing/2014/main" id="{534D7D48-570B-482C-95E7-18B5874099DF}"/>
               </a:ext>
             </a:extLst>
           </p:cNvPr>
@@ -6341,7 +6377,7 @@
           <p:cNvPr id="28" name="overview-homework">
             <a:extLst xmlns:a="http://schemas.openxmlformats.org/drawingml/2006/main">
               <a:ext uri="{FF2B5EF4-FFF2-40B4-BE49-F238E27FC236}">
-                <a16:creationId xmlns:a16="http://schemas.microsoft.com/office/drawing/2014/main" id="{42152A15-33E6-4203-A528-0230C1DF9AF0}"/>
+                <a16:creationId xmlns:a16="http://schemas.microsoft.com/office/drawing/2014/main" id="{6B1E034A-7A52-4FF6-AAE6-A9B3826AE20E}"/>
               </a:ext>
             </a:extLst>
           </p:cNvPr>
@@ -6488,7 +6524,7 @@
     </p:spTree>
     <p:extLst>
       <p:ext uri="{BB962C8B-B14F-4D97-AF65-F5344CB8AC3E}">
-        <p14:creationId xmlns:p14="http://schemas.microsoft.com/office/powerpoint/2010/main" val="1437912497"/>
+        <p14:creationId xmlns:p14="http://schemas.microsoft.com/office/powerpoint/2010/main" val="556687175"/>
       </p:ext>
     </p:extLst>
   </p:cSld>
@@ -6519,7 +6555,7 @@
           <p:cNvPr id="8" name="Korte controle">
             <a:extLst xmlns:a="http://schemas.openxmlformats.org/drawingml/2006/main">
               <a:ext uri="{FF2B5EF4-FFF2-40B4-BE49-F238E27FC236}">
-                <a16:creationId xmlns:a16="http://schemas.microsoft.com/office/drawing/2014/main" id="{F661F010-D2EA-418C-9D7E-FE256A203818}"/>
+                <a16:creationId xmlns:a16="http://schemas.microsoft.com/office/drawing/2014/main" id="{91055A14-8833-47C4-91B3-0F0753926659}"/>
               </a:ext>
             </a:extLst>
           </p:cNvPr>
@@ -6576,7 +6612,7 @@
           <p:cNvPr id="2" name="">
             <a:extLst xmlns:a="http://schemas.openxmlformats.org/drawingml/2006/main">
               <a:ext uri="{FF2B5EF4-FFF2-40B4-BE49-F238E27FC236}">
-                <a16:creationId xmlns:a16="http://schemas.microsoft.com/office/drawing/2014/main" id="{0CF2863E-D263-41A2-B036-AE6EF9B65A70}"/>
+                <a16:creationId xmlns:a16="http://schemas.microsoft.com/office/drawing/2014/main" id="{750EE75C-7E82-4CB1-B24B-490E7B8A175F}"/>
               </a:ext>
             </a:extLst>
           </p:cNvPr>
@@ -6605,7 +6641,7 @@
           <p:cNvPr id="3" name="§2.1.1 Kostenstructuren">
             <a:extLst xmlns:a="http://schemas.openxmlformats.org/drawingml/2006/main">
               <a:ext uri="{FF2B5EF4-FFF2-40B4-BE49-F238E27FC236}">
-                <a16:creationId xmlns:a16="http://schemas.microsoft.com/office/drawing/2014/main" id="{73505CB7-F227-4277-AB00-C98671EE0A71}"/>
+                <a16:creationId xmlns:a16="http://schemas.microsoft.com/office/drawing/2014/main" id="{CCEE91CA-8341-4416-A65C-FCD038B3DF11}"/>
               </a:ext>
             </a:extLst>
           </p:cNvPr>
@@ -6662,7 +6698,7 @@
           <p:cNvPr id="4" name="10">
             <a:extLst xmlns:a="http://schemas.openxmlformats.org/drawingml/2006/main">
               <a:ext uri="{FF2B5EF4-FFF2-40B4-BE49-F238E27FC236}">
-                <a16:creationId xmlns:a16="http://schemas.microsoft.com/office/drawing/2014/main" id="{C1B2CB5B-36BD-4302-A520-F768686DF54B}"/>
+                <a16:creationId xmlns:a16="http://schemas.microsoft.com/office/drawing/2014/main" id="{4C6E4B0C-2EA9-459B-A2B2-FF929736406B}"/>
               </a:ext>
             </a:extLst>
           </p:cNvPr>
@@ -6719,7 +6755,7 @@
           <p:cNvPr id="5" name="Bij Fles &amp; Co verdubbelt Q van 200 naar 400 flesse">
             <a:extLst xmlns:a="http://schemas.openxmlformats.org/drawingml/2006/main">
               <a:ext uri="{FF2B5EF4-FFF2-40B4-BE49-F238E27FC236}">
-                <a16:creationId xmlns:a16="http://schemas.microsoft.com/office/drawing/2014/main" id="{A4208E61-D3C6-4EF5-B510-FFA9C9CBC986}"/>
+                <a16:creationId xmlns:a16="http://schemas.microsoft.com/office/drawing/2014/main" id="{013C005A-A06B-4158-915B-7D96198DB4EB}"/>
               </a:ext>
             </a:extLst>
           </p:cNvPr>
@@ -6776,7 +6812,7 @@
           <p:cNvPr id="6" name="“Dan verdubbelt TK en halveert GTK.”">
             <a:extLst xmlns:a="http://schemas.openxmlformats.org/drawingml/2006/main">
               <a:ext uri="{FF2B5EF4-FFF2-40B4-BE49-F238E27FC236}">
-                <a16:creationId xmlns:a16="http://schemas.microsoft.com/office/drawing/2014/main" id="{45F486A2-39B6-4E49-9B08-3A6F3DE6FB6F}"/>
+                <a16:creationId xmlns:a16="http://schemas.microsoft.com/office/drawing/2014/main" id="{A8D05191-33E1-4CAD-8BE3-48235654C138}"/>
               </a:ext>
             </a:extLst>
           </p:cNvPr>
@@ -6833,7 +6869,7 @@
           <p:cNvPr id="7" name="Klopt deze uitspraak?&#10;Gebruik de huur en de materi">
             <a:extLst xmlns:a="http://schemas.openxmlformats.org/drawingml/2006/main">
               <a:ext uri="{FF2B5EF4-FFF2-40B4-BE49-F238E27FC236}">
-                <a16:creationId xmlns:a16="http://schemas.microsoft.com/office/drawing/2014/main" id="{050525F1-69A0-4E92-9F6B-63B9013A8DB9}"/>
+                <a16:creationId xmlns:a16="http://schemas.microsoft.com/office/drawing/2014/main" id="{6122F3C8-62C9-47D7-B4CF-4B3E2B006BB9}"/>
               </a:ext>
             </a:extLst>
           </p:cNvPr>
@@ -6911,7 +6947,7 @@
     </p:spTree>
     <p:extLst>
       <p:ext uri="{BB962C8B-B14F-4D97-AF65-F5344CB8AC3E}">
-        <p14:creationId xmlns:p14="http://schemas.microsoft.com/office/powerpoint/2010/main" val="1141799003"/>
+        <p14:creationId xmlns:p14="http://schemas.microsoft.com/office/powerpoint/2010/main" val="1292912318"/>
       </p:ext>
     </p:extLst>
   </p:cSld>
@@ -6942,7 +6978,7 @@
           <p:cNvPr id="9" name="Korte controle">
             <a:extLst xmlns:a="http://schemas.openxmlformats.org/drawingml/2006/main">
               <a:ext uri="{FF2B5EF4-FFF2-40B4-BE49-F238E27FC236}">
-                <a16:creationId xmlns:a16="http://schemas.microsoft.com/office/drawing/2014/main" id="{50BDFE68-83C4-4F67-8544-C0ACA2AA3369}"/>
+                <a16:creationId xmlns:a16="http://schemas.microsoft.com/office/drawing/2014/main" id="{A1F8C392-6EB3-42B1-B25B-7E6E5DB00063}"/>
               </a:ext>
             </a:extLst>
           </p:cNvPr>
@@ -6999,7 +7035,7 @@
           <p:cNvPr id="2" name="">
             <a:extLst xmlns:a="http://schemas.openxmlformats.org/drawingml/2006/main">
               <a:ext uri="{FF2B5EF4-FFF2-40B4-BE49-F238E27FC236}">
-                <a16:creationId xmlns:a16="http://schemas.microsoft.com/office/drawing/2014/main" id="{61C8A345-D7C4-4AEB-A452-6A757C559391}"/>
+                <a16:creationId xmlns:a16="http://schemas.microsoft.com/office/drawing/2014/main" id="{4AE7C033-73DA-48E0-9364-C2D56C6A9EEF}"/>
               </a:ext>
             </a:extLst>
           </p:cNvPr>
@@ -7028,7 +7064,7 @@
           <p:cNvPr id="3" name="§2.1.1 Kostenstructuren">
             <a:extLst xmlns:a="http://schemas.openxmlformats.org/drawingml/2006/main">
               <a:ext uri="{FF2B5EF4-FFF2-40B4-BE49-F238E27FC236}">
-                <a16:creationId xmlns:a16="http://schemas.microsoft.com/office/drawing/2014/main" id="{2A9759D1-5816-4085-89DB-14E9F8EEC7F4}"/>
+                <a16:creationId xmlns:a16="http://schemas.microsoft.com/office/drawing/2014/main" id="{6FF150B8-C538-4DD5-8704-D3A03F0ED0BB}"/>
               </a:ext>
             </a:extLst>
           </p:cNvPr>
@@ -7085,7 +7121,7 @@
           <p:cNvPr id="4" name="11">
             <a:extLst xmlns:a="http://schemas.openxmlformats.org/drawingml/2006/main">
               <a:ext uri="{FF2B5EF4-FFF2-40B4-BE49-F238E27FC236}">
-                <a16:creationId xmlns:a16="http://schemas.microsoft.com/office/drawing/2014/main" id="{7218FB07-7ECA-4029-878F-D85F7F78865A}"/>
+                <a16:creationId xmlns:a16="http://schemas.microsoft.com/office/drawing/2014/main" id="{186657B4-7A5D-446C-A893-F78F13F6A8C2}"/>
               </a:ext>
             </a:extLst>
           </p:cNvPr>
@@ -7142,7 +7178,7 @@
           <p:cNvPr id="5" name="Bij Fles &amp; Co verdubbelt Q van 200 naar 400 flesse">
             <a:extLst xmlns:a="http://schemas.openxmlformats.org/drawingml/2006/main">
               <a:ext uri="{FF2B5EF4-FFF2-40B4-BE49-F238E27FC236}">
-                <a16:creationId xmlns:a16="http://schemas.microsoft.com/office/drawing/2014/main" id="{2AF5E61C-5BE8-4475-8715-4A069D13BB75}"/>
+                <a16:creationId xmlns:a16="http://schemas.microsoft.com/office/drawing/2014/main" id="{A396C27C-0F64-4A6F-829D-82C2EF1334D2}"/>
               </a:ext>
             </a:extLst>
           </p:cNvPr>
@@ -7199,7 +7235,7 @@
           <p:cNvPr id="6" name="“Dan verdubbelt TK en halveert GTK.”">
             <a:extLst xmlns:a="http://schemas.openxmlformats.org/drawingml/2006/main">
               <a:ext uri="{FF2B5EF4-FFF2-40B4-BE49-F238E27FC236}">
-                <a16:creationId xmlns:a16="http://schemas.microsoft.com/office/drawing/2014/main" id="{C77EBC0E-F615-4CDB-AC49-737B24FE66BF}"/>
+                <a16:creationId xmlns:a16="http://schemas.microsoft.com/office/drawing/2014/main" id="{07FBCC72-B65B-4AF3-A6F7-A28359CD47DD}"/>
               </a:ext>
             </a:extLst>
           </p:cNvPr>
@@ -7501,7 +7537,7 @@
           <p:cNvPr id="8" name="Alleen TVK verdubbelt en GCK halveert.">
             <a:extLst xmlns:a="http://schemas.openxmlformats.org/drawingml/2006/main">
               <a:ext uri="{FF2B5EF4-FFF2-40B4-BE49-F238E27FC236}">
-                <a16:creationId xmlns:a16="http://schemas.microsoft.com/office/drawing/2014/main" id="{FE5095CB-4FBF-4F15-A1C9-25C6161E18BD}"/>
+                <a16:creationId xmlns:a16="http://schemas.microsoft.com/office/drawing/2014/main" id="{0D7A85B1-1B05-43C4-8DA2-1416CC17087F}"/>
               </a:ext>
             </a:extLst>
           </p:cNvPr>
@@ -7556,7 +7592,7 @@
     </p:spTree>
     <p:extLst>
       <p:ext uri="{BB962C8B-B14F-4D97-AF65-F5344CB8AC3E}">
-        <p14:creationId xmlns:p14="http://schemas.microsoft.com/office/powerpoint/2010/main" val="1734194144"/>
+        <p14:creationId xmlns:p14="http://schemas.microsoft.com/office/powerpoint/2010/main" val="1647127559"/>
       </p:ext>
     </p:extLst>
   </p:cSld>
@@ -7587,7 +7623,7 @@
           <p:cNvPr id="29" name="Deze les: §2.1.1 Kostenstructuren">
             <a:extLst xmlns:a="http://schemas.openxmlformats.org/drawingml/2006/main">
               <a:ext uri="{FF2B5EF4-FFF2-40B4-BE49-F238E27FC236}">
-                <a16:creationId xmlns:a16="http://schemas.microsoft.com/office/drawing/2014/main" id="{656CC02E-FBF7-457B-A668-F8AAD49108C4}"/>
+                <a16:creationId xmlns:a16="http://schemas.microsoft.com/office/drawing/2014/main" id="{75EC1ACB-C841-49ED-B0A1-2DFEF1757763}"/>
               </a:ext>
             </a:extLst>
           </p:cNvPr>
@@ -7644,7 +7680,7 @@
           <p:cNvPr id="2" name="">
             <a:extLst xmlns:a="http://schemas.openxmlformats.org/drawingml/2006/main">
               <a:ext uri="{FF2B5EF4-FFF2-40B4-BE49-F238E27FC236}">
-                <a16:creationId xmlns:a16="http://schemas.microsoft.com/office/drawing/2014/main" id="{F0CF52F2-2D3D-4AE0-AA64-D1FCCA15C0E5}"/>
+                <a16:creationId xmlns:a16="http://schemas.microsoft.com/office/drawing/2014/main" id="{041CA96B-1831-45EA-8CA3-BF74CC30E574}"/>
               </a:ext>
             </a:extLst>
           </p:cNvPr>
@@ -7673,7 +7709,7 @@
           <p:cNvPr id="3" name="§2.1.1 Kostenstructuren">
             <a:extLst xmlns:a="http://schemas.openxmlformats.org/drawingml/2006/main">
               <a:ext uri="{FF2B5EF4-FFF2-40B4-BE49-F238E27FC236}">
-                <a16:creationId xmlns:a16="http://schemas.microsoft.com/office/drawing/2014/main" id="{85FC574D-B8E7-4ECA-9997-315977912DEE}"/>
+                <a16:creationId xmlns:a16="http://schemas.microsoft.com/office/drawing/2014/main" id="{3EFD0812-228C-4949-99E6-C206E0FF918B}"/>
               </a:ext>
             </a:extLst>
           </p:cNvPr>
@@ -7730,7 +7766,7 @@
           <p:cNvPr id="4" name="12">
             <a:extLst xmlns:a="http://schemas.openxmlformats.org/drawingml/2006/main">
               <a:ext uri="{FF2B5EF4-FFF2-40B4-BE49-F238E27FC236}">
-                <a16:creationId xmlns:a16="http://schemas.microsoft.com/office/drawing/2014/main" id="{53C9E189-BAB8-4544-AAF5-9C72215885B3}"/>
+                <a16:creationId xmlns:a16="http://schemas.microsoft.com/office/drawing/2014/main" id="{C3D2B166-C6D0-4818-B46E-869ECF41BFE1}"/>
               </a:ext>
             </a:extLst>
           </p:cNvPr>
@@ -7787,7 +7823,7 @@
           <p:cNvPr id="5" name="phase">
             <a:extLst xmlns:a="http://schemas.openxmlformats.org/drawingml/2006/main">
               <a:ext uri="{FF2B5EF4-FFF2-40B4-BE49-F238E27FC236}">
-                <a16:creationId xmlns:a16="http://schemas.microsoft.com/office/drawing/2014/main" id="{F0217DB1-24CD-49C3-A20D-23E9DC417363}"/>
+                <a16:creationId xmlns:a16="http://schemas.microsoft.com/office/drawing/2014/main" id="{65C0AD55-338E-44AE-954A-E5FA01BC1756}"/>
               </a:ext>
             </a:extLst>
           </p:cNvPr>
@@ -7844,7 +7880,7 @@
           <p:cNvPr id="6" name="Lesroute">
             <a:extLst xmlns:a="http://schemas.openxmlformats.org/drawingml/2006/main">
               <a:ext uri="{FF2B5EF4-FFF2-40B4-BE49-F238E27FC236}">
-                <a16:creationId xmlns:a16="http://schemas.microsoft.com/office/drawing/2014/main" id="{7C396E81-00F1-418B-8035-3EBE8E55EE0E}"/>
+                <a16:creationId xmlns:a16="http://schemas.microsoft.com/office/drawing/2014/main" id="{9CBEEBBF-6C4E-433E-A3DC-5502DD7A53C4}"/>
               </a:ext>
             </a:extLst>
           </p:cNvPr>
@@ -7901,7 +7937,7 @@
           <p:cNvPr id="7" name="route-number-1">
             <a:extLst xmlns:a="http://schemas.openxmlformats.org/drawingml/2006/main">
               <a:ext uri="{FF2B5EF4-FFF2-40B4-BE49-F238E27FC236}">
-                <a16:creationId xmlns:a16="http://schemas.microsoft.com/office/drawing/2014/main" id="{18536316-5E11-44DF-90BF-D6E1FC1A2E48}"/>
+                <a16:creationId xmlns:a16="http://schemas.microsoft.com/office/drawing/2014/main" id="{B6067D18-E38D-4745-876D-E91A083B90B8}"/>
               </a:ext>
             </a:extLst>
           </p:cNvPr>
@@ -7958,7 +7994,7 @@
           <p:cNvPr id="8" name="route-1">
             <a:extLst xmlns:a="http://schemas.openxmlformats.org/drawingml/2006/main">
               <a:ext uri="{FF2B5EF4-FFF2-40B4-BE49-F238E27FC236}">
-                <a16:creationId xmlns:a16="http://schemas.microsoft.com/office/drawing/2014/main" id="{835EA30F-32B2-4F06-AB34-D96BDE771AC4}"/>
+                <a16:creationId xmlns:a16="http://schemas.microsoft.com/office/drawing/2014/main" id="{7DEDE1C2-5159-4065-B7A1-E9249940427E}"/>
               </a:ext>
             </a:extLst>
           </p:cNvPr>
@@ -8015,7 +8051,7 @@
           <p:cNvPr id="9" name="route-number-2">
             <a:extLst xmlns:a="http://schemas.openxmlformats.org/drawingml/2006/main">
               <a:ext uri="{FF2B5EF4-FFF2-40B4-BE49-F238E27FC236}">
-                <a16:creationId xmlns:a16="http://schemas.microsoft.com/office/drawing/2014/main" id="{15F5FFC0-A070-4D20-A229-E620BBBE7EA9}"/>
+                <a16:creationId xmlns:a16="http://schemas.microsoft.com/office/drawing/2014/main" id="{AEFEEF00-9703-4F6F-ACBC-DE63DA049012}"/>
               </a:ext>
             </a:extLst>
           </p:cNvPr>
@@ -8072,7 +8108,7 @@
           <p:cNvPr id="10" name="route-2">
             <a:extLst xmlns:a="http://schemas.openxmlformats.org/drawingml/2006/main">
               <a:ext uri="{FF2B5EF4-FFF2-40B4-BE49-F238E27FC236}">
-                <a16:creationId xmlns:a16="http://schemas.microsoft.com/office/drawing/2014/main" id="{ABBE1C7A-9137-4FCB-863D-A0ECB897B4B4}"/>
+                <a16:creationId xmlns:a16="http://schemas.microsoft.com/office/drawing/2014/main" id="{320C7506-4686-4890-8D8C-10C729D5CA27}"/>
               </a:ext>
             </a:extLst>
           </p:cNvPr>
@@ -8129,7 +8165,7 @@
           <p:cNvPr id="11" name="route-number-3">
             <a:extLst xmlns:a="http://schemas.openxmlformats.org/drawingml/2006/main">
               <a:ext uri="{FF2B5EF4-FFF2-40B4-BE49-F238E27FC236}">
-                <a16:creationId xmlns:a16="http://schemas.microsoft.com/office/drawing/2014/main" id="{9348FCC6-CC2C-4B21-A4BE-D46E38EC0752}"/>
+                <a16:creationId xmlns:a16="http://schemas.microsoft.com/office/drawing/2014/main" id="{2972CB89-0EE9-4968-9323-D26268AECFA1}"/>
               </a:ext>
             </a:extLst>
           </p:cNvPr>
@@ -8186,7 +8222,7 @@
           <p:cNvPr id="12" name="route-3">
             <a:extLst xmlns:a="http://schemas.openxmlformats.org/drawingml/2006/main">
               <a:ext uri="{FF2B5EF4-FFF2-40B4-BE49-F238E27FC236}">
-                <a16:creationId xmlns:a16="http://schemas.microsoft.com/office/drawing/2014/main" id="{6E504DC0-8F18-40E2-9167-C8880B67DB7E}"/>
+                <a16:creationId xmlns:a16="http://schemas.microsoft.com/office/drawing/2014/main" id="{07F2EDB5-4587-45AB-8634-487498C27DDD}"/>
               </a:ext>
             </a:extLst>
           </p:cNvPr>
@@ -8243,7 +8279,7 @@
           <p:cNvPr id="13" name="route-number-4">
             <a:extLst xmlns:a="http://schemas.openxmlformats.org/drawingml/2006/main">
               <a:ext uri="{FF2B5EF4-FFF2-40B4-BE49-F238E27FC236}">
-                <a16:creationId xmlns:a16="http://schemas.microsoft.com/office/drawing/2014/main" id="{7AC7ABE6-02A3-4753-9073-578BEA6644D4}"/>
+                <a16:creationId xmlns:a16="http://schemas.microsoft.com/office/drawing/2014/main" id="{7BEE86CA-A8A6-43D2-B5BD-50CC60287295}"/>
               </a:ext>
             </a:extLst>
           </p:cNvPr>
@@ -8300,7 +8336,7 @@
           <p:cNvPr id="14" name="route-4">
             <a:extLst xmlns:a="http://schemas.openxmlformats.org/drawingml/2006/main">
               <a:ext uri="{FF2B5EF4-FFF2-40B4-BE49-F238E27FC236}">
-                <a16:creationId xmlns:a16="http://schemas.microsoft.com/office/drawing/2014/main" id="{B05C4770-B393-4AC8-AFB4-F4E8A0D9FFA5}"/>
+                <a16:creationId xmlns:a16="http://schemas.microsoft.com/office/drawing/2014/main" id="{1B8ECCF7-5336-4DC4-A230-A4BC4BE1ED7C}"/>
               </a:ext>
             </a:extLst>
           </p:cNvPr>
@@ -8357,7 +8393,7 @@
           <p:cNvPr id="15" name="route-number-5">
             <a:extLst xmlns:a="http://schemas.openxmlformats.org/drawingml/2006/main">
               <a:ext uri="{FF2B5EF4-FFF2-40B4-BE49-F238E27FC236}">
-                <a16:creationId xmlns:a16="http://schemas.microsoft.com/office/drawing/2014/main" id="{17511640-54DB-42C9-9DCC-59715081AA82}"/>
+                <a16:creationId xmlns:a16="http://schemas.microsoft.com/office/drawing/2014/main" id="{918BB116-2E9E-4984-B66C-0B671E0B5F7A}"/>
               </a:ext>
             </a:extLst>
           </p:cNvPr>
@@ -8414,7 +8450,7 @@
           <p:cNvPr id="16" name="route-5">
             <a:extLst xmlns:a="http://schemas.openxmlformats.org/drawingml/2006/main">
               <a:ext uri="{FF2B5EF4-FFF2-40B4-BE49-F238E27FC236}">
-                <a16:creationId xmlns:a16="http://schemas.microsoft.com/office/drawing/2014/main" id="{3D78F0D6-3881-4B43-AE91-E20B9271EBB4}"/>
+                <a16:creationId xmlns:a16="http://schemas.microsoft.com/office/drawing/2014/main" id="{921D7DD6-78B5-439D-8104-ECFF350A513F}"/>
               </a:ext>
             </a:extLst>
           </p:cNvPr>
@@ -8471,7 +8507,7 @@
           <p:cNvPr id="17" name="route-number-6">
             <a:extLst xmlns:a="http://schemas.openxmlformats.org/drawingml/2006/main">
               <a:ext uri="{FF2B5EF4-FFF2-40B4-BE49-F238E27FC236}">
-                <a16:creationId xmlns:a16="http://schemas.microsoft.com/office/drawing/2014/main" id="{6BD2EFAC-4723-4FD5-A0E9-AA26326B58B1}"/>
+                <a16:creationId xmlns:a16="http://schemas.microsoft.com/office/drawing/2014/main" id="{C95DCCC8-1F5A-441B-8B1C-A37137EF9C45}"/>
               </a:ext>
             </a:extLst>
           </p:cNvPr>
@@ -8528,7 +8564,7 @@
           <p:cNvPr id="18" name="route-6">
             <a:extLst xmlns:a="http://schemas.openxmlformats.org/drawingml/2006/main">
               <a:ext uri="{FF2B5EF4-FFF2-40B4-BE49-F238E27FC236}">
-                <a16:creationId xmlns:a16="http://schemas.microsoft.com/office/drawing/2014/main" id="{64DB4E4A-7107-4967-8D08-6A51158C04CC}"/>
+                <a16:creationId xmlns:a16="http://schemas.microsoft.com/office/drawing/2014/main" id="{EBE1B788-CC09-42FC-9D32-2D46A1FEF30E}"/>
               </a:ext>
             </a:extLst>
           </p:cNvPr>
@@ -8585,7 +8621,7 @@
           <p:cNvPr id="19" name="route-number-7">
             <a:extLst xmlns:a="http://schemas.openxmlformats.org/drawingml/2006/main">
               <a:ext uri="{FF2B5EF4-FFF2-40B4-BE49-F238E27FC236}">
-                <a16:creationId xmlns:a16="http://schemas.microsoft.com/office/drawing/2014/main" id="{DDD639E5-2054-4C42-B0E7-DF5E6AF4AF34}"/>
+                <a16:creationId xmlns:a16="http://schemas.microsoft.com/office/drawing/2014/main" id="{BAF8E133-AC71-4231-AF81-E3D0584C887D}"/>
               </a:ext>
             </a:extLst>
           </p:cNvPr>
@@ -8642,7 +8678,7 @@
           <p:cNvPr id="20" name="route-7">
             <a:extLst xmlns:a="http://schemas.openxmlformats.org/drawingml/2006/main">
               <a:ext uri="{FF2B5EF4-FFF2-40B4-BE49-F238E27FC236}">
-                <a16:creationId xmlns:a16="http://schemas.microsoft.com/office/drawing/2014/main" id="{8DECB584-189C-43EC-87EB-2644263C9209}"/>
+                <a16:creationId xmlns:a16="http://schemas.microsoft.com/office/drawing/2014/main" id="{D0DC7918-3A55-4115-A1A4-8635E6A4EFF1}"/>
               </a:ext>
             </a:extLst>
           </p:cNvPr>
@@ -8699,7 +8735,7 @@
           <p:cNvPr id="21" name="Lesdoelen">
             <a:extLst xmlns:a="http://schemas.openxmlformats.org/drawingml/2006/main">
               <a:ext uri="{FF2B5EF4-FFF2-40B4-BE49-F238E27FC236}">
-                <a16:creationId xmlns:a16="http://schemas.microsoft.com/office/drawing/2014/main" id="{5DF84407-3262-437B-AB29-2E55F2F71ABC}"/>
+                <a16:creationId xmlns:a16="http://schemas.microsoft.com/office/drawing/2014/main" id="{8A1C72C6-D1A4-44E6-A76E-4D3CAB93966A}"/>
               </a:ext>
             </a:extLst>
           </p:cNvPr>
@@ -8756,7 +8792,7 @@
           <p:cNvPr id="22" name="overview-goals">
             <a:extLst xmlns:a="http://schemas.openxmlformats.org/drawingml/2006/main">
               <a:ext uri="{FF2B5EF4-FFF2-40B4-BE49-F238E27FC236}">
-                <a16:creationId xmlns:a16="http://schemas.microsoft.com/office/drawing/2014/main" id="{84174CFB-3C0D-46F0-B027-35B92ADD47F7}"/>
+                <a16:creationId xmlns:a16="http://schemas.microsoft.com/office/drawing/2014/main" id="{0B10F735-8340-4B64-9CC3-ED0754CC9CEB}"/>
               </a:ext>
             </a:extLst>
           </p:cNvPr>
@@ -8859,7 +8895,7 @@
           <p:cNvPr id="23" name="">
             <a:extLst xmlns:a="http://schemas.openxmlformats.org/drawingml/2006/main">
               <a:ext uri="{FF2B5EF4-FFF2-40B4-BE49-F238E27FC236}">
-                <a16:creationId xmlns:a16="http://schemas.microsoft.com/office/drawing/2014/main" id="{35C9657D-A752-4DCC-9011-F1FA441A7CC4}"/>
+                <a16:creationId xmlns:a16="http://schemas.microsoft.com/office/drawing/2014/main" id="{63169BB7-63CA-48DF-86F3-C0B154524CBE}"/>
               </a:ext>
             </a:extLst>
           </p:cNvPr>
@@ -8888,7 +8924,7 @@
           <p:cNvPr id="24" name="Startopdracht">
             <a:extLst xmlns:a="http://schemas.openxmlformats.org/drawingml/2006/main">
               <a:ext uri="{FF2B5EF4-FFF2-40B4-BE49-F238E27FC236}">
-                <a16:creationId xmlns:a16="http://schemas.microsoft.com/office/drawing/2014/main" id="{C1258DBD-0295-4207-AC2F-6F5FBCCB72A7}"/>
+                <a16:creationId xmlns:a16="http://schemas.microsoft.com/office/drawing/2014/main" id="{9306A910-8518-496D-AE84-E37C34274993}"/>
               </a:ext>
             </a:extLst>
           </p:cNvPr>
@@ -8945,7 +8981,7 @@
           <p:cNvPr id="25" name="overview-start">
             <a:extLst xmlns:a="http://schemas.openxmlformats.org/drawingml/2006/main">
               <a:ext uri="{FF2B5EF4-FFF2-40B4-BE49-F238E27FC236}">
-                <a16:creationId xmlns:a16="http://schemas.microsoft.com/office/drawing/2014/main" id="{9F640089-BA9D-4E1B-9177-ED81878C8D0D}"/>
+                <a16:creationId xmlns:a16="http://schemas.microsoft.com/office/drawing/2014/main" id="{F1BA9358-0B29-46CE-BCFB-6259D866AB2F}"/>
               </a:ext>
             </a:extLst>
           </p:cNvPr>
@@ -8974,48 +9010,48 @@
           <a:lstStyle xmlns:a="http://schemas.openxmlformats.org/drawingml/2006/main"/>
           <a:p xmlns:a="http://schemas.openxmlformats.org/drawingml/2006/main">
             <a:pPr algn="l">
-              <a:defRPr sz="2475" b="0">
-                <a:solidFill>
-                  <a:srgbClr val="183247"/>
-                </a:solidFill>
-                <a:latin typeface="Arial"/>
-                <a:ea typeface="Arial"/>
-                <a:cs typeface="Arial"/>
-              </a:defRPr>
-            </a:pPr>
-            <a:r>
-              <a:rPr sz="2475" b="0">
-                <a:solidFill>
-                  <a:srgbClr val="183247"/>
-                </a:solidFill>
-                <a:latin typeface="Arial"/>
-                <a:ea typeface="Arial"/>
-                <a:cs typeface="Arial"/>
-              </a:rPr>
-              <a:t>Pagina 6</a:t>
-            </a:r>
-          </a:p>
-          <a:p xmlns:a="http://schemas.openxmlformats.org/drawingml/2006/main">
-            <a:pPr algn="l">
-              <a:defRPr sz="2475" b="0">
-                <a:solidFill>
-                  <a:srgbClr val="183247"/>
-                </a:solidFill>
-                <a:latin typeface="Arial"/>
-                <a:ea typeface="Arial"/>
-                <a:cs typeface="Arial"/>
-              </a:defRPr>
-            </a:pPr>
-            <a:r>
-              <a:rPr sz="2475" b="0">
-                <a:solidFill>
-                  <a:srgbClr val="183247"/>
-                </a:solidFill>
-                <a:latin typeface="Arial"/>
-                <a:ea typeface="Arial"/>
-                <a:cs typeface="Arial"/>
-              </a:rPr>
-              <a:t>Opgaven 1 en 2</a:t>
+              <a:defRPr sz="2250" b="0">
+                <a:solidFill>
+                  <a:srgbClr val="183247"/>
+                </a:solidFill>
+                <a:latin typeface="Arial"/>
+                <a:ea typeface="Arial"/>
+                <a:cs typeface="Arial"/>
+              </a:defRPr>
+            </a:pPr>
+            <a:r>
+              <a:rPr sz="2250" b="0">
+                <a:solidFill>
+                  <a:srgbClr val="183247"/>
+                </a:solidFill>
+                <a:latin typeface="Arial"/>
+                <a:ea typeface="Arial"/>
+                <a:cs typeface="Arial"/>
+              </a:rPr>
+              <a:t>Pagina 6 · Opgaven 1 en 2</a:t>
+            </a:r>
+          </a:p>
+          <a:p xmlns:a="http://schemas.openxmlformats.org/drawingml/2006/main">
+            <a:pPr algn="l">
+              <a:defRPr sz="2250" b="0">
+                <a:solidFill>
+                  <a:srgbClr val="183247"/>
+                </a:solidFill>
+                <a:latin typeface="Arial"/>
+                <a:ea typeface="Arial"/>
+                <a:cs typeface="Arial"/>
+              </a:defRPr>
+            </a:pPr>
+            <a:r>
+              <a:rPr sz="2250" b="0">
+                <a:solidFill>
+                  <a:srgbClr val="183247"/>
+                </a:solidFill>
+                <a:latin typeface="Arial"/>
+                <a:ea typeface="Arial"/>
+                <a:cs typeface="Arial"/>
+              </a:rPr>
+              <a:t>2: verkennen, theorie p. 2–4</a:t>
             </a:r>
           </a:p>
         </p:txBody>
@@ -9025,7 +9061,7 @@
           <p:cNvPr id="26" name="">
             <a:extLst xmlns:a="http://schemas.openxmlformats.org/drawingml/2006/main">
               <a:ext uri="{FF2B5EF4-FFF2-40B4-BE49-F238E27FC236}">
-                <a16:creationId xmlns:a16="http://schemas.microsoft.com/office/drawing/2014/main" id="{859E410B-A7F4-4D80-AA40-E257B71952B2}"/>
+                <a16:creationId xmlns:a16="http://schemas.microsoft.com/office/drawing/2014/main" id="{D860C637-9BBF-4949-9AC7-96CD918FDEDA}"/>
               </a:ext>
             </a:extLst>
           </p:cNvPr>
@@ -9054,7 +9090,7 @@
           <p:cNvPr id="27" name="Huiswerk">
             <a:extLst xmlns:a="http://schemas.openxmlformats.org/drawingml/2006/main">
               <a:ext uri="{FF2B5EF4-FFF2-40B4-BE49-F238E27FC236}">
-                <a16:creationId xmlns:a16="http://schemas.microsoft.com/office/drawing/2014/main" id="{B6A9B1D7-E3BC-46CE-B627-51214ED7B4B7}"/>
+                <a16:creationId xmlns:a16="http://schemas.microsoft.com/office/drawing/2014/main" id="{FFEE249F-9BB6-4E95-A720-F19DD726858E}"/>
               </a:ext>
             </a:extLst>
           </p:cNvPr>
@@ -9111,7 +9147,7 @@
           <p:cNvPr id="28" name="overview-homework">
             <a:extLst xmlns:a="http://schemas.openxmlformats.org/drawingml/2006/main">
               <a:ext uri="{FF2B5EF4-FFF2-40B4-BE49-F238E27FC236}">
-                <a16:creationId xmlns:a16="http://schemas.microsoft.com/office/drawing/2014/main" id="{9CE3D60B-639B-46AF-944C-4031DECBE0FC}"/>
+                <a16:creationId xmlns:a16="http://schemas.microsoft.com/office/drawing/2014/main" id="{95A24E8A-EC3C-48F6-80BA-DF46658FB443}"/>
               </a:ext>
             </a:extLst>
           </p:cNvPr>
@@ -9258,7 +9294,7 @@
     </p:spTree>
     <p:extLst>
       <p:ext uri="{BB962C8B-B14F-4D97-AF65-F5344CB8AC3E}">
-        <p14:creationId xmlns:p14="http://schemas.microsoft.com/office/powerpoint/2010/main" val="845253153"/>
+        <p14:creationId xmlns:p14="http://schemas.microsoft.com/office/powerpoint/2010/main" val="633497621"/>
       </p:ext>
     </p:extLst>
   </p:cSld>
@@ -9289,7 +9325,7 @@
           <p:cNvPr id="9" name="Opgave 7 · Bakkerij De Korenaar">
             <a:extLst xmlns:a="http://schemas.openxmlformats.org/drawingml/2006/main">
               <a:ext uri="{FF2B5EF4-FFF2-40B4-BE49-F238E27FC236}">
-                <a16:creationId xmlns:a16="http://schemas.microsoft.com/office/drawing/2014/main" id="{0C9CF166-5172-4101-84A0-7E04F538C284}"/>
+                <a16:creationId xmlns:a16="http://schemas.microsoft.com/office/drawing/2014/main" id="{3CC15BAD-ED92-4D10-982E-F1C49DCE42FA}"/>
               </a:ext>
             </a:extLst>
           </p:cNvPr>
@@ -9346,7 +9382,7 @@
           <p:cNvPr id="2" name="">
             <a:extLst xmlns:a="http://schemas.openxmlformats.org/drawingml/2006/main">
               <a:ext uri="{FF2B5EF4-FFF2-40B4-BE49-F238E27FC236}">
-                <a16:creationId xmlns:a16="http://schemas.microsoft.com/office/drawing/2014/main" id="{93CF05D2-948A-4A5E-A17F-47EFD731FDC8}"/>
+                <a16:creationId xmlns:a16="http://schemas.microsoft.com/office/drawing/2014/main" id="{DBCDC776-661F-4CD6-98BB-0ACED5732B0C}"/>
               </a:ext>
             </a:extLst>
           </p:cNvPr>
@@ -9375,7 +9411,7 @@
           <p:cNvPr id="3" name="§2.1.1 Kostenstructuren · Opgave 7 · Boekpagina 8">
             <a:extLst xmlns:a="http://schemas.openxmlformats.org/drawingml/2006/main">
               <a:ext uri="{FF2B5EF4-FFF2-40B4-BE49-F238E27FC236}">
-                <a16:creationId xmlns:a16="http://schemas.microsoft.com/office/drawing/2014/main" id="{C4106C64-E890-4C52-8413-DF11391762D6}"/>
+                <a16:creationId xmlns:a16="http://schemas.microsoft.com/office/drawing/2014/main" id="{55CF139E-CC1C-45E2-BBF7-7ECD29A7305B}"/>
               </a:ext>
             </a:extLst>
           </p:cNvPr>
@@ -9432,7 +9468,7 @@
           <p:cNvPr id="4" name="13">
             <a:extLst xmlns:a="http://schemas.openxmlformats.org/drawingml/2006/main">
               <a:ext uri="{FF2B5EF4-FFF2-40B4-BE49-F238E27FC236}">
-                <a16:creationId xmlns:a16="http://schemas.microsoft.com/office/drawing/2014/main" id="{E5C608BD-C5DA-42DD-9609-313660E87A52}"/>
+                <a16:creationId xmlns:a16="http://schemas.microsoft.com/office/drawing/2014/main" id="{C40179E9-BF3B-408B-9048-4CC68C2379D8}"/>
               </a:ext>
             </a:extLst>
           </p:cNvPr>
@@ -9489,7 +9525,7 @@
           <p:cNvPr id="5" name="Maximaal 1.000 broden per maand. Deze maand blijve">
             <a:extLst xmlns:a="http://schemas.openxmlformats.org/drawingml/2006/main">
               <a:ext uri="{FF2B5EF4-FFF2-40B4-BE49-F238E27FC236}">
-                <a16:creationId xmlns:a16="http://schemas.microsoft.com/office/drawing/2014/main" id="{93929265-62F7-42BF-B09A-60439FDDBFAC}"/>
+                <a16:creationId xmlns:a16="http://schemas.microsoft.com/office/drawing/2014/main" id="{DAB45CA3-7693-46FF-ADD1-787A875010E1}"/>
               </a:ext>
             </a:extLst>
           </p:cNvPr>
@@ -9546,7 +9582,7 @@
           <p:cNvPr id="6" name="Tot en met die capaciteit gelden de volgende koste">
             <a:extLst xmlns:a="http://schemas.openxmlformats.org/drawingml/2006/main">
               <a:ext uri="{FF2B5EF4-FFF2-40B4-BE49-F238E27FC236}">
-                <a16:creationId xmlns:a16="http://schemas.microsoft.com/office/drawing/2014/main" id="{B348E266-0792-47DB-869A-21076DB47D0D}"/>
+                <a16:creationId xmlns:a16="http://schemas.microsoft.com/office/drawing/2014/main" id="{29848F2E-537F-41A9-8FFA-8D58E93E6E6E}"/>
               </a:ext>
             </a:extLst>
           </p:cNvPr>
@@ -9875,7 +9911,7 @@
           <p:cNvPr id="8" name="Q is het aantal broden per maand.">
             <a:extLst xmlns:a="http://schemas.openxmlformats.org/drawingml/2006/main">
               <a:ext uri="{FF2B5EF4-FFF2-40B4-BE49-F238E27FC236}">
-                <a16:creationId xmlns:a16="http://schemas.microsoft.com/office/drawing/2014/main" id="{D6A612A6-74A0-43F8-8B6C-295830D589F9}"/>
+                <a16:creationId xmlns:a16="http://schemas.microsoft.com/office/drawing/2014/main" id="{DB8EBB06-9A75-4F72-BE9A-8FFA44B9C7E4}"/>
               </a:ext>
             </a:extLst>
           </p:cNvPr>
@@ -9930,7 +9966,7 @@
     </p:spTree>
     <p:extLst>
       <p:ext uri="{BB962C8B-B14F-4D97-AF65-F5344CB8AC3E}">
-        <p14:creationId xmlns:p14="http://schemas.microsoft.com/office/powerpoint/2010/main" val="681818106"/>
+        <p14:creationId xmlns:p14="http://schemas.microsoft.com/office/powerpoint/2010/main" val="1982070626"/>
       </p:ext>
     </p:extLst>
   </p:cSld>
@@ -9961,7 +9997,7 @@
           <p:cNvPr id="8" name="Opgave 7 · Deelvragen a en b">
             <a:extLst xmlns:a="http://schemas.openxmlformats.org/drawingml/2006/main">
               <a:ext uri="{FF2B5EF4-FFF2-40B4-BE49-F238E27FC236}">
-                <a16:creationId xmlns:a16="http://schemas.microsoft.com/office/drawing/2014/main" id="{7383D234-DB8E-4D31-87EA-E6851CAF87F2}"/>
+                <a16:creationId xmlns:a16="http://schemas.microsoft.com/office/drawing/2014/main" id="{4F34B950-9767-4B49-AF72-91834C631EEF}"/>
               </a:ext>
             </a:extLst>
           </p:cNvPr>
@@ -10018,7 +10054,7 @@
           <p:cNvPr id="2" name="">
             <a:extLst xmlns:a="http://schemas.openxmlformats.org/drawingml/2006/main">
               <a:ext uri="{FF2B5EF4-FFF2-40B4-BE49-F238E27FC236}">
-                <a16:creationId xmlns:a16="http://schemas.microsoft.com/office/drawing/2014/main" id="{5265DCF2-4A6B-4DBE-A925-63762BB0335E}"/>
+                <a16:creationId xmlns:a16="http://schemas.microsoft.com/office/drawing/2014/main" id="{1F49129B-9059-484D-BB19-15BA8688673B}"/>
               </a:ext>
             </a:extLst>
           </p:cNvPr>
@@ -10047,7 +10083,7 @@
           <p:cNvPr id="3" name="§2.1.1 Kostenstructuren · Opgave 7 · Boekpagina 8">
             <a:extLst xmlns:a="http://schemas.openxmlformats.org/drawingml/2006/main">
               <a:ext uri="{FF2B5EF4-FFF2-40B4-BE49-F238E27FC236}">
-                <a16:creationId xmlns:a16="http://schemas.microsoft.com/office/drawing/2014/main" id="{9279FCBF-9B7C-417A-A1A2-5AD13ACFFE5D}"/>
+                <a16:creationId xmlns:a16="http://schemas.microsoft.com/office/drawing/2014/main" id="{2CDF696E-8664-422F-9523-AFF5346A3794}"/>
               </a:ext>
             </a:extLst>
           </p:cNvPr>
@@ -10104,7 +10140,7 @@
           <p:cNvPr id="4" name="14">
             <a:extLst xmlns:a="http://schemas.openxmlformats.org/drawingml/2006/main">
               <a:ext uri="{FF2B5EF4-FFF2-40B4-BE49-F238E27FC236}">
-                <a16:creationId xmlns:a16="http://schemas.microsoft.com/office/drawing/2014/main" id="{D6758A59-DA4E-419B-94D0-3721B1B45D69}"/>
+                <a16:creationId xmlns:a16="http://schemas.microsoft.com/office/drawing/2014/main" id="{10949273-4C0D-4307-8D93-343465326E87}"/>
               </a:ext>
             </a:extLst>
           </p:cNvPr>
@@ -10161,7 +10197,7 @@
           <p:cNvPr id="5" name="a) Neem de classificatietabel over en vul alle leg">
             <a:extLst xmlns:a="http://schemas.openxmlformats.org/drawingml/2006/main">
               <a:ext uri="{FF2B5EF4-FFF2-40B4-BE49-F238E27FC236}">
-                <a16:creationId xmlns:a16="http://schemas.microsoft.com/office/drawing/2014/main" id="{55BFDBED-6E48-4B56-9F26-3D9B30E55225}"/>
+                <a16:creationId xmlns:a16="http://schemas.microsoft.com/office/drawing/2014/main" id="{3169BC5B-004B-4674-BFD3-03F365FDCB9C}"/>
               </a:ext>
             </a:extLst>
           </p:cNvPr>
@@ -10611,7 +10647,7 @@
           <p:cNvPr id="7" name="b) Stel de functies voor TCK, TVK en TK op.">
             <a:extLst xmlns:a="http://schemas.openxmlformats.org/drawingml/2006/main">
               <a:ext uri="{FF2B5EF4-FFF2-40B4-BE49-F238E27FC236}">
-                <a16:creationId xmlns:a16="http://schemas.microsoft.com/office/drawing/2014/main" id="{BB31B459-6515-46B8-BEAA-AB21535638A6}"/>
+                <a16:creationId xmlns:a16="http://schemas.microsoft.com/office/drawing/2014/main" id="{548C6C6D-78BA-44DB-ACCB-B7B87553CA88}"/>
               </a:ext>
             </a:extLst>
           </p:cNvPr>
@@ -10666,7 +10702,7 @@
     </p:spTree>
     <p:extLst>
       <p:ext uri="{BB962C8B-B14F-4D97-AF65-F5344CB8AC3E}">
-        <p14:creationId xmlns:p14="http://schemas.microsoft.com/office/powerpoint/2010/main" val="870432337"/>
+        <p14:creationId xmlns:p14="http://schemas.microsoft.com/office/powerpoint/2010/main" val="1555327517"/>
       </p:ext>
     </p:extLst>
   </p:cSld>
@@ -10697,7 +10733,7 @@
           <p:cNvPr id="10" name="Opgave 7 · Deelvragen c, d en e">
             <a:extLst xmlns:a="http://schemas.openxmlformats.org/drawingml/2006/main">
               <a:ext uri="{FF2B5EF4-FFF2-40B4-BE49-F238E27FC236}">
-                <a16:creationId xmlns:a16="http://schemas.microsoft.com/office/drawing/2014/main" id="{CB7C1D8A-82B2-44A6-A316-91A7B0770557}"/>
+                <a16:creationId xmlns:a16="http://schemas.microsoft.com/office/drawing/2014/main" id="{F93DC323-9B86-4DDF-927B-9A57EDD30EA5}"/>
               </a:ext>
             </a:extLst>
           </p:cNvPr>
@@ -10754,7 +10790,7 @@
           <p:cNvPr id="2" name="">
             <a:extLst xmlns:a="http://schemas.openxmlformats.org/drawingml/2006/main">
               <a:ext uri="{FF2B5EF4-FFF2-40B4-BE49-F238E27FC236}">
-                <a16:creationId xmlns:a16="http://schemas.microsoft.com/office/drawing/2014/main" id="{4D5F27AE-07B6-431C-8536-57050F036558}"/>
+                <a16:creationId xmlns:a16="http://schemas.microsoft.com/office/drawing/2014/main" id="{166C0A70-98D7-4805-9EC0-640BE9BFB5B2}"/>
               </a:ext>
             </a:extLst>
           </p:cNvPr>
@@ -10783,7 +10819,7 @@
           <p:cNvPr id="3" name="§2.1.1 Kostenstructuren · Opgave 7 · Boekpagina 8">
             <a:extLst xmlns:a="http://schemas.openxmlformats.org/drawingml/2006/main">
               <a:ext uri="{FF2B5EF4-FFF2-40B4-BE49-F238E27FC236}">
-                <a16:creationId xmlns:a16="http://schemas.microsoft.com/office/drawing/2014/main" id="{901FCE7B-6FFA-48BA-95BA-504D4014A459}"/>
+                <a16:creationId xmlns:a16="http://schemas.microsoft.com/office/drawing/2014/main" id="{46F2DC6C-458A-4106-9F2B-9336D5D827E3}"/>
               </a:ext>
             </a:extLst>
           </p:cNvPr>
@@ -10840,7 +10876,7 @@
           <p:cNvPr id="4" name="15">
             <a:extLst xmlns:a="http://schemas.openxmlformats.org/drawingml/2006/main">
               <a:ext uri="{FF2B5EF4-FFF2-40B4-BE49-F238E27FC236}">
-                <a16:creationId xmlns:a16="http://schemas.microsoft.com/office/drawing/2014/main" id="{2B393FB3-7A0F-4D56-B714-7CF7A90CEDE4}"/>
+                <a16:creationId xmlns:a16="http://schemas.microsoft.com/office/drawing/2014/main" id="{B0544381-E9D6-4A9F-8C3D-344C22CC9941}"/>
               </a:ext>
             </a:extLst>
           </p:cNvPr>
@@ -10897,7 +10933,7 @@
           <p:cNvPr id="5" name="c) Bereken bij Q = 500 de GCK, GVK en GTK.&#10;Noteer ">
             <a:extLst xmlns:a="http://schemas.openxmlformats.org/drawingml/2006/main">
               <a:ext uri="{FF2B5EF4-FFF2-40B4-BE49-F238E27FC236}">
-                <a16:creationId xmlns:a16="http://schemas.microsoft.com/office/drawing/2014/main" id="{47C704C0-0B8C-4DB8-9536-D7FE895AB3B5}"/>
+                <a16:creationId xmlns:a16="http://schemas.microsoft.com/office/drawing/2014/main" id="{5FB86959-39B4-4570-B2B5-FD49932D4D18}"/>
               </a:ext>
             </a:extLst>
           </p:cNvPr>
@@ -10977,7 +11013,7 @@
           <p:cNvPr id="6" name="">
             <a:extLst xmlns:a="http://schemas.openxmlformats.org/drawingml/2006/main">
               <a:ext uri="{FF2B5EF4-FFF2-40B4-BE49-F238E27FC236}">
-                <a16:creationId xmlns:a16="http://schemas.microsoft.com/office/drawing/2014/main" id="{23988F1A-4322-4A16-9226-86E176832D48}"/>
+                <a16:creationId xmlns:a16="http://schemas.microsoft.com/office/drawing/2014/main" id="{7D235E06-426C-48DA-8A21-9296ED38EF9A}"/>
               </a:ext>
             </a:extLst>
           </p:cNvPr>
@@ -11006,7 +11042,7 @@
           <p:cNvPr id="7" name="d) Bereken bij Q = 1.000 de GCK, GVK en GTK.&#10;Notee">
             <a:extLst xmlns:a="http://schemas.openxmlformats.org/drawingml/2006/main">
               <a:ext uri="{FF2B5EF4-FFF2-40B4-BE49-F238E27FC236}">
-                <a16:creationId xmlns:a16="http://schemas.microsoft.com/office/drawing/2014/main" id="{CC12CBC5-861F-40C6-890A-63089F3D0FB2}"/>
+                <a16:creationId xmlns:a16="http://schemas.microsoft.com/office/drawing/2014/main" id="{8BE1CBC2-4C7A-475C-9AE2-A96D6A129B5F}"/>
               </a:ext>
             </a:extLst>
           </p:cNvPr>
@@ -11086,7 +11122,7 @@
           <p:cNvPr id="8" name="">
             <a:extLst xmlns:a="http://schemas.openxmlformats.org/drawingml/2006/main">
               <a:ext uri="{FF2B5EF4-FFF2-40B4-BE49-F238E27FC236}">
-                <a16:creationId xmlns:a16="http://schemas.microsoft.com/office/drawing/2014/main" id="{32310BF9-A0CA-4200-BCB4-547B25ECA9AE}"/>
+                <a16:creationId xmlns:a16="http://schemas.microsoft.com/office/drawing/2014/main" id="{61926743-0E7A-472B-BFCF-6F0C62FA2B98}"/>
               </a:ext>
             </a:extLst>
           </p:cNvPr>
@@ -11115,7 +11151,7 @@
           <p:cNvPr id="9" name="e) Vergelijk eerst TCK, TVK en TK bij beide hoevee">
             <a:extLst xmlns:a="http://schemas.openxmlformats.org/drawingml/2006/main">
               <a:ext uri="{FF2B5EF4-FFF2-40B4-BE49-F238E27FC236}">
-                <a16:creationId xmlns:a16="http://schemas.microsoft.com/office/drawing/2014/main" id="{A446FA8C-63D5-4229-AC7B-DB0E3C40E47C}"/>
+                <a16:creationId xmlns:a16="http://schemas.microsoft.com/office/drawing/2014/main" id="{5385698A-B74C-4CEE-BCD2-F636FBF38E72}"/>
               </a:ext>
             </a:extLst>
           </p:cNvPr>
@@ -11170,7 +11206,7 @@
     </p:spTree>
     <p:extLst>
       <p:ext uri="{BB962C8B-B14F-4D97-AF65-F5344CB8AC3E}">
-        <p14:creationId xmlns:p14="http://schemas.microsoft.com/office/powerpoint/2010/main" val="1239496868"/>
+        <p14:creationId xmlns:p14="http://schemas.microsoft.com/office/powerpoint/2010/main" val="621644062"/>
       </p:ext>
     </p:extLst>
   </p:cSld>
@@ -11201,7 +11237,7 @@
           <p:cNvPr id="7" name="Opgave 7a · Kosten indelen">
             <a:extLst xmlns:a="http://schemas.openxmlformats.org/drawingml/2006/main">
               <a:ext uri="{FF2B5EF4-FFF2-40B4-BE49-F238E27FC236}">
-                <a16:creationId xmlns:a16="http://schemas.microsoft.com/office/drawing/2014/main" id="{658DB59A-7273-4394-B293-4A2A36F32558}"/>
+                <a16:creationId xmlns:a16="http://schemas.microsoft.com/office/drawing/2014/main" id="{C0481B94-48E5-4848-9CAB-504A0EB802FA}"/>
               </a:ext>
             </a:extLst>
           </p:cNvPr>
@@ -11258,7 +11294,7 @@
           <p:cNvPr id="2" name="">
             <a:extLst xmlns:a="http://schemas.openxmlformats.org/drawingml/2006/main">
               <a:ext uri="{FF2B5EF4-FFF2-40B4-BE49-F238E27FC236}">
-                <a16:creationId xmlns:a16="http://schemas.microsoft.com/office/drawing/2014/main" id="{4B567772-8736-4FCE-B530-39D501136811}"/>
+                <a16:creationId xmlns:a16="http://schemas.microsoft.com/office/drawing/2014/main" id="{18F2BF6D-4CE9-4B72-9E90-36C86A7EF08E}"/>
               </a:ext>
             </a:extLst>
           </p:cNvPr>
@@ -11287,7 +11323,7 @@
           <p:cNvPr id="3" name="§2.1.1 Kostenstructuren · Opgave 7 · Boekpagina 8">
             <a:extLst xmlns:a="http://schemas.openxmlformats.org/drawingml/2006/main">
               <a:ext uri="{FF2B5EF4-FFF2-40B4-BE49-F238E27FC236}">
-                <a16:creationId xmlns:a16="http://schemas.microsoft.com/office/drawing/2014/main" id="{8B7F099D-A34A-4D5E-BC34-A23631C032C6}"/>
+                <a16:creationId xmlns:a16="http://schemas.microsoft.com/office/drawing/2014/main" id="{DB729D17-C358-440C-9E6F-95465CD55729}"/>
               </a:ext>
             </a:extLst>
           </p:cNvPr>
@@ -11344,7 +11380,7 @@
           <p:cNvPr id="4" name="16">
             <a:extLst xmlns:a="http://schemas.openxmlformats.org/drawingml/2006/main">
               <a:ext uri="{FF2B5EF4-FFF2-40B4-BE49-F238E27FC236}">
-                <a16:creationId xmlns:a16="http://schemas.microsoft.com/office/drawing/2014/main" id="{78D51B67-DB56-4319-A087-0937DC415807}"/>
+                <a16:creationId xmlns:a16="http://schemas.microsoft.com/office/drawing/2014/main" id="{46394B8B-5FD1-41C8-A28B-3E30CB3FD3B9}"/>
               </a:ext>
             </a:extLst>
           </p:cNvPr>
@@ -11794,7 +11830,7 @@
           <p:cNvPr id="6" name="Eén energierekening kan constante én variabele kos">
             <a:extLst xmlns:a="http://schemas.openxmlformats.org/drawingml/2006/main">
               <a:ext uri="{FF2B5EF4-FFF2-40B4-BE49-F238E27FC236}">
-                <a16:creationId xmlns:a16="http://schemas.microsoft.com/office/drawing/2014/main" id="{6C4F9C51-9857-4AE0-8E37-F96253D93BB6}"/>
+                <a16:creationId xmlns:a16="http://schemas.microsoft.com/office/drawing/2014/main" id="{FEA660B2-F5F5-465F-B828-788ECD0FDBD8}"/>
               </a:ext>
             </a:extLst>
           </p:cNvPr>
@@ -11849,7 +11885,7 @@
     </p:spTree>
     <p:extLst>
       <p:ext uri="{BB962C8B-B14F-4D97-AF65-F5344CB8AC3E}">
-        <p14:creationId xmlns:p14="http://schemas.microsoft.com/office/powerpoint/2010/main" val="1387040049"/>
+        <p14:creationId xmlns:p14="http://schemas.microsoft.com/office/powerpoint/2010/main" val="1115670396"/>
       </p:ext>
     </p:extLst>
   </p:cSld>
@@ -11880,7 +11916,7 @@
           <p:cNvPr id="13" name="Opgave 7b · De kostenfuncties">
             <a:extLst xmlns:a="http://schemas.openxmlformats.org/drawingml/2006/main">
               <a:ext uri="{FF2B5EF4-FFF2-40B4-BE49-F238E27FC236}">
-                <a16:creationId xmlns:a16="http://schemas.microsoft.com/office/drawing/2014/main" id="{8DCD6855-4290-427F-BECB-9653D64657EF}"/>
+                <a16:creationId xmlns:a16="http://schemas.microsoft.com/office/drawing/2014/main" id="{0337C20F-060C-474F-B1A0-08103A6E8D21}"/>
               </a:ext>
             </a:extLst>
           </p:cNvPr>
@@ -11937,7 +11973,7 @@
           <p:cNvPr id="2" name="">
             <a:extLst xmlns:a="http://schemas.openxmlformats.org/drawingml/2006/main">
               <a:ext uri="{FF2B5EF4-FFF2-40B4-BE49-F238E27FC236}">
-                <a16:creationId xmlns:a16="http://schemas.microsoft.com/office/drawing/2014/main" id="{F22EB90C-AC43-470F-B964-BC478FA6EA82}"/>
+                <a16:creationId xmlns:a16="http://schemas.microsoft.com/office/drawing/2014/main" id="{9B9BA502-F146-4829-A881-C3985379F82D}"/>
               </a:ext>
             </a:extLst>
           </p:cNvPr>
@@ -11966,7 +12002,7 @@
           <p:cNvPr id="3" name="§2.1.1 Kostenstructuren · Opgave 7 · Boekpagina 8">
             <a:extLst xmlns:a="http://schemas.openxmlformats.org/drawingml/2006/main">
               <a:ext uri="{FF2B5EF4-FFF2-40B4-BE49-F238E27FC236}">
-                <a16:creationId xmlns:a16="http://schemas.microsoft.com/office/drawing/2014/main" id="{1DB61F45-A3FD-457C-9AA3-763A960C8EBF}"/>
+                <a16:creationId xmlns:a16="http://schemas.microsoft.com/office/drawing/2014/main" id="{2665BCB2-3BB8-43EA-BEBD-6FCF312E462C}"/>
               </a:ext>
             </a:extLst>
           </p:cNvPr>
@@ -12023,7 +12059,7 @@
           <p:cNvPr id="4" name="17">
             <a:extLst xmlns:a="http://schemas.openxmlformats.org/drawingml/2006/main">
               <a:ext uri="{FF2B5EF4-FFF2-40B4-BE49-F238E27FC236}">
-                <a16:creationId xmlns:a16="http://schemas.microsoft.com/office/drawing/2014/main" id="{2FAF8BC3-3205-4199-A873-60F21541FBE5}"/>
+                <a16:creationId xmlns:a16="http://schemas.microsoft.com/office/drawing/2014/main" id="{D75518D3-7A55-49E0-8FEF-8FE7D36037B5}"/>
               </a:ext>
             </a:extLst>
           </p:cNvPr>
@@ -12080,7 +12116,7 @@
           <p:cNvPr id="5" name="Vaste maandbedragen">
             <a:extLst xmlns:a="http://schemas.openxmlformats.org/drawingml/2006/main">
               <a:ext uri="{FF2B5EF4-FFF2-40B4-BE49-F238E27FC236}">
-                <a16:creationId xmlns:a16="http://schemas.microsoft.com/office/drawing/2014/main" id="{02BF207C-0250-406B-BF19-ACC65CE248AD}"/>
+                <a16:creationId xmlns:a16="http://schemas.microsoft.com/office/drawing/2014/main" id="{824B0287-AFD9-4725-8556-44FA3B6B58A5}"/>
               </a:ext>
             </a:extLst>
           </p:cNvPr>
@@ -12137,7 +12173,7 @@
           <p:cNvPr id="6" name="TCK = 440 + 60 = 500">
             <a:extLst xmlns:a="http://schemas.openxmlformats.org/drawingml/2006/main">
               <a:ext uri="{FF2B5EF4-FFF2-40B4-BE49-F238E27FC236}">
-                <a16:creationId xmlns:a16="http://schemas.microsoft.com/office/drawing/2014/main" id="{E73BC1A8-01CF-40CA-BD21-F672C23A4D57}"/>
+                <a16:creationId xmlns:a16="http://schemas.microsoft.com/office/drawing/2014/main" id="{336F7E7C-E6DB-4771-90B7-B7512E66880D}"/>
               </a:ext>
             </a:extLst>
           </p:cNvPr>
@@ -12194,7 +12230,7 @@
           <p:cNvPr id="7" name="Variabele kosten per brood">
             <a:extLst xmlns:a="http://schemas.openxmlformats.org/drawingml/2006/main">
               <a:ext uri="{FF2B5EF4-FFF2-40B4-BE49-F238E27FC236}">
-                <a16:creationId xmlns:a16="http://schemas.microsoft.com/office/drawing/2014/main" id="{5E3D0497-3945-4BF3-8C8F-755AF7F417F8}"/>
+                <a16:creationId xmlns:a16="http://schemas.microsoft.com/office/drawing/2014/main" id="{A3EFF7A2-8756-454A-B850-CEBFBB3C282C}"/>
               </a:ext>
             </a:extLst>
           </p:cNvPr>
@@ -12251,7 +12287,7 @@
           <p:cNvPr id="8" name="€ 0,70 + € 0,10 = € 0,80 per brood">
             <a:extLst xmlns:a="http://schemas.openxmlformats.org/drawingml/2006/main">
               <a:ext uri="{FF2B5EF4-FFF2-40B4-BE49-F238E27FC236}">
-                <a16:creationId xmlns:a16="http://schemas.microsoft.com/office/drawing/2014/main" id="{5BA92327-BB5E-461B-9F3A-60E110998AF8}"/>
+                <a16:creationId xmlns:a16="http://schemas.microsoft.com/office/drawing/2014/main" id="{4AC37D58-38E6-4D12-B61E-215B0E73FFEC}"/>
               </a:ext>
             </a:extLst>
           </p:cNvPr>
@@ -12308,7 +12344,7 @@
           <p:cNvPr id="9" name="TVK = 0,80Q">
             <a:extLst xmlns:a="http://schemas.openxmlformats.org/drawingml/2006/main">
               <a:ext uri="{FF2B5EF4-FFF2-40B4-BE49-F238E27FC236}">
-                <a16:creationId xmlns:a16="http://schemas.microsoft.com/office/drawing/2014/main" id="{9661524E-7483-4CFA-AFBE-53F3442ED5E5}"/>
+                <a16:creationId xmlns:a16="http://schemas.microsoft.com/office/drawing/2014/main" id="{1ED64C4D-40CB-4D62-9B73-5DF5AF83486D}"/>
               </a:ext>
             </a:extLst>
           </p:cNvPr>
@@ -12365,7 +12401,7 @@
           <p:cNvPr id="10" name="">
             <a:extLst xmlns:a="http://schemas.openxmlformats.org/drawingml/2006/main">
               <a:ext uri="{FF2B5EF4-FFF2-40B4-BE49-F238E27FC236}">
-                <a16:creationId xmlns:a16="http://schemas.microsoft.com/office/drawing/2014/main" id="{288B21EF-CDB4-416F-935C-B0C00E4358BF}"/>
+                <a16:creationId xmlns:a16="http://schemas.microsoft.com/office/drawing/2014/main" id="{D2AD5978-82C3-448B-99D8-2B3D9949A235}"/>
               </a:ext>
             </a:extLst>
           </p:cNvPr>
@@ -12394,7 +12430,7 @@
           <p:cNvPr id="11" name="TK = TCK + TVK = 500 + 0,80Q">
             <a:extLst xmlns:a="http://schemas.openxmlformats.org/drawingml/2006/main">
               <a:ext uri="{FF2B5EF4-FFF2-40B4-BE49-F238E27FC236}">
-                <a16:creationId xmlns:a16="http://schemas.microsoft.com/office/drawing/2014/main" id="{7A2BD3C1-63C5-4ECE-8ECB-5541136A1EF1}"/>
+                <a16:creationId xmlns:a16="http://schemas.microsoft.com/office/drawing/2014/main" id="{2C2809F3-352D-43EB-A1D0-80DF621FF630}"/>
               </a:ext>
             </a:extLst>
           </p:cNvPr>
@@ -12451,7 +12487,7 @@
           <p:cNvPr id="12" name="TCK, TVK en TK: € per maand. Q: broden per maand, ">
             <a:extLst xmlns:a="http://schemas.openxmlformats.org/drawingml/2006/main">
               <a:ext uri="{FF2B5EF4-FFF2-40B4-BE49-F238E27FC236}">
-                <a16:creationId xmlns:a16="http://schemas.microsoft.com/office/drawing/2014/main" id="{EA4B59E7-1BD6-4806-A6C7-B14E638FD4D5}"/>
+                <a16:creationId xmlns:a16="http://schemas.microsoft.com/office/drawing/2014/main" id="{45B397C9-0C7F-453E-80B3-CB6BAEF27B26}"/>
               </a:ext>
             </a:extLst>
           </p:cNvPr>
@@ -12506,7 +12542,7 @@
     </p:spTree>
     <p:extLst>
       <p:ext uri="{BB962C8B-B14F-4D97-AF65-F5344CB8AC3E}">
-        <p14:creationId xmlns:p14="http://schemas.microsoft.com/office/powerpoint/2010/main" val="1774486230"/>
+        <p14:creationId xmlns:p14="http://schemas.microsoft.com/office/powerpoint/2010/main" val="1665317273"/>
       </p:ext>
     </p:extLst>
   </p:cSld>
@@ -12537,7 +12573,7 @@
           <p:cNvPr id="10" name="Opgave 7c · 500 broden">
             <a:extLst xmlns:a="http://schemas.openxmlformats.org/drawingml/2006/main">
               <a:ext uri="{FF2B5EF4-FFF2-40B4-BE49-F238E27FC236}">
-                <a16:creationId xmlns:a16="http://schemas.microsoft.com/office/drawing/2014/main" id="{4EB780A7-D432-4783-9135-1BCF69D093E5}"/>
+                <a16:creationId xmlns:a16="http://schemas.microsoft.com/office/drawing/2014/main" id="{21115098-5785-4AD3-BB27-E17B9FAEE7E0}"/>
               </a:ext>
             </a:extLst>
           </p:cNvPr>
@@ -12594,7 +12630,7 @@
           <p:cNvPr id="2" name="">
             <a:extLst xmlns:a="http://schemas.openxmlformats.org/drawingml/2006/main">
               <a:ext uri="{FF2B5EF4-FFF2-40B4-BE49-F238E27FC236}">
-                <a16:creationId xmlns:a16="http://schemas.microsoft.com/office/drawing/2014/main" id="{53ED463E-2E43-47DE-B70E-C9B9791A0C3E}"/>
+                <a16:creationId xmlns:a16="http://schemas.microsoft.com/office/drawing/2014/main" id="{D58F3ECA-DEED-44BB-8CB2-3E5A69C868FC}"/>
               </a:ext>
             </a:extLst>
           </p:cNvPr>
@@ -12623,7 +12659,7 @@
           <p:cNvPr id="3" name="§2.1.1 Kostenstructuren · Opgave 7 · Boekpagina 8">
             <a:extLst xmlns:a="http://schemas.openxmlformats.org/drawingml/2006/main">
               <a:ext uri="{FF2B5EF4-FFF2-40B4-BE49-F238E27FC236}">
-                <a16:creationId xmlns:a16="http://schemas.microsoft.com/office/drawing/2014/main" id="{8FA42FB9-4D39-462A-A95E-3A65C7BEA65E}"/>
+                <a16:creationId xmlns:a16="http://schemas.microsoft.com/office/drawing/2014/main" id="{03AECA01-45AA-4264-98C7-853848F817EE}"/>
               </a:ext>
             </a:extLst>
           </p:cNvPr>
@@ -12680,7 +12716,7 @@
           <p:cNvPr id="4" name="18">
             <a:extLst xmlns:a="http://schemas.openxmlformats.org/drawingml/2006/main">
               <a:ext uri="{FF2B5EF4-FFF2-40B4-BE49-F238E27FC236}">
-                <a16:creationId xmlns:a16="http://schemas.microsoft.com/office/drawing/2014/main" id="{3B7D3D65-49C1-4CEF-8E85-0501271D2105}"/>
+                <a16:creationId xmlns:a16="http://schemas.microsoft.com/office/drawing/2014/main" id="{F31A320C-B5E7-4D3D-B512-76E9D6299CFB}"/>
               </a:ext>
             </a:extLst>
           </p:cNvPr>
@@ -12737,7 +12773,7 @@
           <p:cNvPr id="5" name="Eerst de totalen (€ per maand)">
             <a:extLst xmlns:a="http://schemas.openxmlformats.org/drawingml/2006/main">
               <a:ext uri="{FF2B5EF4-FFF2-40B4-BE49-F238E27FC236}">
-                <a16:creationId xmlns:a16="http://schemas.microsoft.com/office/drawing/2014/main" id="{D265CE36-B416-4A6F-A767-D00AEB80D393}"/>
+                <a16:creationId xmlns:a16="http://schemas.microsoft.com/office/drawing/2014/main" id="{35B527CB-64EC-43DB-915F-11EAC9B98CA6}"/>
               </a:ext>
             </a:extLst>
           </p:cNvPr>
@@ -12794,7 +12830,7 @@
           <p:cNvPr id="6" name="TCK = € 500&#10;TVK = 0,80 × 500 = € 400&#10;TK = 500 + 40">
             <a:extLst xmlns:a="http://schemas.openxmlformats.org/drawingml/2006/main">
               <a:ext uri="{FF2B5EF4-FFF2-40B4-BE49-F238E27FC236}">
-                <a16:creationId xmlns:a16="http://schemas.microsoft.com/office/drawing/2014/main" id="{DB006B1A-8BFE-4570-977A-BD58B5C9F42D}"/>
+                <a16:creationId xmlns:a16="http://schemas.microsoft.com/office/drawing/2014/main" id="{1087CB48-FECA-4107-9D34-9CB38B2CEB4E}"/>
               </a:ext>
             </a:extLst>
           </p:cNvPr>
@@ -12897,7 +12933,7 @@
           <p:cNvPr id="7" name="">
             <a:extLst xmlns:a="http://schemas.openxmlformats.org/drawingml/2006/main">
               <a:ext uri="{FF2B5EF4-FFF2-40B4-BE49-F238E27FC236}">
-                <a16:creationId xmlns:a16="http://schemas.microsoft.com/office/drawing/2014/main" id="{CC100EBA-707E-40D9-A13F-6B324C916414}"/>
+                <a16:creationId xmlns:a16="http://schemas.microsoft.com/office/drawing/2014/main" id="{D3C6792A-9BC9-4A5A-A2AD-8EC52A09AB8E}"/>
               </a:ext>
             </a:extLst>
           </p:cNvPr>
@@ -12926,7 +12962,7 @@
           <p:cNvPr id="8" name="Daarna delen door het aantal broden">
             <a:extLst xmlns:a="http://schemas.openxmlformats.org/drawingml/2006/main">
               <a:ext uri="{FF2B5EF4-FFF2-40B4-BE49-F238E27FC236}">
-                <a16:creationId xmlns:a16="http://schemas.microsoft.com/office/drawing/2014/main" id="{8DCB5660-EC40-4F13-9454-5B49D5C3811B}"/>
+                <a16:creationId xmlns:a16="http://schemas.microsoft.com/office/drawing/2014/main" id="{FB24CFCB-06DC-4B39-BAA2-56CA3D84DE97}"/>
               </a:ext>
             </a:extLst>
           </p:cNvPr>
@@ -12983,7 +13019,7 @@
           <p:cNvPr id="9" name="GCK = 500 / 500 = € 1,00 per brood&#10;GVK = 400 / 500">
             <a:extLst xmlns:a="http://schemas.openxmlformats.org/drawingml/2006/main">
               <a:ext uri="{FF2B5EF4-FFF2-40B4-BE49-F238E27FC236}">
-                <a16:creationId xmlns:a16="http://schemas.microsoft.com/office/drawing/2014/main" id="{F46C3AFA-0AD4-47D0-B44E-6647897FDC14}"/>
+                <a16:creationId xmlns:a16="http://schemas.microsoft.com/office/drawing/2014/main" id="{8CF4924A-B9CF-4128-85A8-0AA8E2EF8D87}"/>
               </a:ext>
             </a:extLst>
           </p:cNvPr>
@@ -13084,7 +13120,7 @@
     </p:spTree>
     <p:extLst>
       <p:ext uri="{BB962C8B-B14F-4D97-AF65-F5344CB8AC3E}">
-        <p14:creationId xmlns:p14="http://schemas.microsoft.com/office/powerpoint/2010/main" val="1392041170"/>
+        <p14:creationId xmlns:p14="http://schemas.microsoft.com/office/powerpoint/2010/main" val="1363278048"/>
       </p:ext>
     </p:extLst>
   </p:cSld>
@@ -13115,7 +13151,7 @@
           <p:cNvPr id="10" name="Opgave 7d · 1.000 broden">
             <a:extLst xmlns:a="http://schemas.openxmlformats.org/drawingml/2006/main">
               <a:ext uri="{FF2B5EF4-FFF2-40B4-BE49-F238E27FC236}">
-                <a16:creationId xmlns:a16="http://schemas.microsoft.com/office/drawing/2014/main" id="{F6E6EC66-ECAC-41DD-8DC7-412D7DBD09D0}"/>
+                <a16:creationId xmlns:a16="http://schemas.microsoft.com/office/drawing/2014/main" id="{747EF722-635E-4302-9261-EC2F6F47582D}"/>
               </a:ext>
             </a:extLst>
           </p:cNvPr>
@@ -13172,7 +13208,7 @@
           <p:cNvPr id="2" name="">
             <a:extLst xmlns:a="http://schemas.openxmlformats.org/drawingml/2006/main">
               <a:ext uri="{FF2B5EF4-FFF2-40B4-BE49-F238E27FC236}">
-                <a16:creationId xmlns:a16="http://schemas.microsoft.com/office/drawing/2014/main" id="{1ACBEF4C-B50F-4527-8DC4-18BB68765653}"/>
+                <a16:creationId xmlns:a16="http://schemas.microsoft.com/office/drawing/2014/main" id="{95904856-29FC-4806-A020-1143613B2084}"/>
               </a:ext>
             </a:extLst>
           </p:cNvPr>
@@ -13201,7 +13237,7 @@
           <p:cNvPr id="3" name="§2.1.1 Kostenstructuren · Opgave 7 · Boekpagina 8">
             <a:extLst xmlns:a="http://schemas.openxmlformats.org/drawingml/2006/main">
               <a:ext uri="{FF2B5EF4-FFF2-40B4-BE49-F238E27FC236}">
-                <a16:creationId xmlns:a16="http://schemas.microsoft.com/office/drawing/2014/main" id="{2FFDF0AA-BE79-4B15-804A-53A22C47AD9D}"/>
+                <a16:creationId xmlns:a16="http://schemas.microsoft.com/office/drawing/2014/main" id="{294F0ABA-E85C-486F-9812-EDF10B477C0C}"/>
               </a:ext>
             </a:extLst>
           </p:cNvPr>
@@ -13258,7 +13294,7 @@
           <p:cNvPr id="4" name="19">
             <a:extLst xmlns:a="http://schemas.openxmlformats.org/drawingml/2006/main">
               <a:ext uri="{FF2B5EF4-FFF2-40B4-BE49-F238E27FC236}">
-                <a16:creationId xmlns:a16="http://schemas.microsoft.com/office/drawing/2014/main" id="{D331D085-3CD9-4894-9E4A-1140A66B3A99}"/>
+                <a16:creationId xmlns:a16="http://schemas.microsoft.com/office/drawing/2014/main" id="{A88404E8-CF37-4DB3-9317-77CA9E72FF6A}"/>
               </a:ext>
             </a:extLst>
           </p:cNvPr>
@@ -13315,7 +13351,7 @@
           <p:cNvPr id="5" name="Eerst de totalen (€ per maand)">
             <a:extLst xmlns:a="http://schemas.openxmlformats.org/drawingml/2006/main">
               <a:ext uri="{FF2B5EF4-FFF2-40B4-BE49-F238E27FC236}">
-                <a16:creationId xmlns:a16="http://schemas.microsoft.com/office/drawing/2014/main" id="{B3AFBC48-F82F-4E5C-B11A-C2D8A66E84E3}"/>
+                <a16:creationId xmlns:a16="http://schemas.microsoft.com/office/drawing/2014/main" id="{B8E7E6A9-6F75-4FEC-AF3A-9D5A728D3AEE}"/>
               </a:ext>
             </a:extLst>
           </p:cNvPr>
@@ -13372,7 +13408,7 @@
           <p:cNvPr id="6" name="TCK = € 500&#10;TVK = 0,80 × 1.000 = € 800&#10;TK = 500 + ">
             <a:extLst xmlns:a="http://schemas.openxmlformats.org/drawingml/2006/main">
               <a:ext uri="{FF2B5EF4-FFF2-40B4-BE49-F238E27FC236}">
-                <a16:creationId xmlns:a16="http://schemas.microsoft.com/office/drawing/2014/main" id="{DFA1E9E1-814E-46B6-9EBF-9D45CC0D26C1}"/>
+                <a16:creationId xmlns:a16="http://schemas.microsoft.com/office/drawing/2014/main" id="{03470E08-8764-4BAF-BC37-7C860577A277}"/>
               </a:ext>
             </a:extLst>
           </p:cNvPr>
@@ -13475,7 +13511,7 @@
           <p:cNvPr id="7" name="">
             <a:extLst xmlns:a="http://schemas.openxmlformats.org/drawingml/2006/main">
               <a:ext uri="{FF2B5EF4-FFF2-40B4-BE49-F238E27FC236}">
-                <a16:creationId xmlns:a16="http://schemas.microsoft.com/office/drawing/2014/main" id="{43EF8C03-770D-4448-8371-8D7402E04EA7}"/>
+                <a16:creationId xmlns:a16="http://schemas.microsoft.com/office/drawing/2014/main" id="{41D2AA12-EF23-447D-AB57-DA90C0C35252}"/>
               </a:ext>
             </a:extLst>
           </p:cNvPr>
@@ -13504,7 +13540,7 @@
           <p:cNvPr id="8" name="Daarna delen door het aantal broden">
             <a:extLst xmlns:a="http://schemas.openxmlformats.org/drawingml/2006/main">
               <a:ext uri="{FF2B5EF4-FFF2-40B4-BE49-F238E27FC236}">
-                <a16:creationId xmlns:a16="http://schemas.microsoft.com/office/drawing/2014/main" id="{36961A81-5975-4606-B0D8-860026E9D03C}"/>
+                <a16:creationId xmlns:a16="http://schemas.microsoft.com/office/drawing/2014/main" id="{208E9BA3-A45E-431C-AFF1-08237FDCB364}"/>
               </a:ext>
             </a:extLst>
           </p:cNvPr>
@@ -13561,7 +13597,7 @@
           <p:cNvPr id="9" name="GCK = 500 / 1.000 = € 0,50 per brood&#10;GVK = 800 / 1">
             <a:extLst xmlns:a="http://schemas.openxmlformats.org/drawingml/2006/main">
               <a:ext uri="{FF2B5EF4-FFF2-40B4-BE49-F238E27FC236}">
-                <a16:creationId xmlns:a16="http://schemas.microsoft.com/office/drawing/2014/main" id="{20BE043E-0474-4A6D-A237-331ACDC612B0}"/>
+                <a16:creationId xmlns:a16="http://schemas.microsoft.com/office/drawing/2014/main" id="{6DD4344F-2EC4-4BDF-8348-6B8145F2B4DB}"/>
               </a:ext>
             </a:extLst>
           </p:cNvPr>
@@ -13662,7 +13698,7 @@
     </p:spTree>
     <p:extLst>
       <p:ext uri="{BB962C8B-B14F-4D97-AF65-F5344CB8AC3E}">
-        <p14:creationId xmlns:p14="http://schemas.microsoft.com/office/powerpoint/2010/main" val="1303764716"/>
+        <p14:creationId xmlns:p14="http://schemas.microsoft.com/office/powerpoint/2010/main" val="283972677"/>
       </p:ext>
     </p:extLst>
   </p:cSld>
@@ -13693,7 +13729,7 @@
           <p:cNvPr id="16" name="Wat kun je na deze les?">
             <a:extLst xmlns:a="http://schemas.openxmlformats.org/drawingml/2006/main">
               <a:ext uri="{FF2B5EF4-FFF2-40B4-BE49-F238E27FC236}">
-                <a16:creationId xmlns:a16="http://schemas.microsoft.com/office/drawing/2014/main" id="{67D25EEA-133B-469C-9C21-A78D539CADB5}"/>
+                <a16:creationId xmlns:a16="http://schemas.microsoft.com/office/drawing/2014/main" id="{02BD5C0E-2CCD-4B9A-868E-6526C2B42701}"/>
               </a:ext>
             </a:extLst>
           </p:cNvPr>
@@ -13750,7 +13786,7 @@
           <p:cNvPr id="2" name="">
             <a:extLst xmlns:a="http://schemas.openxmlformats.org/drawingml/2006/main">
               <a:ext uri="{FF2B5EF4-FFF2-40B4-BE49-F238E27FC236}">
-                <a16:creationId xmlns:a16="http://schemas.microsoft.com/office/drawing/2014/main" id="{57395119-1A52-4441-A608-32DDF7C94238}"/>
+                <a16:creationId xmlns:a16="http://schemas.microsoft.com/office/drawing/2014/main" id="{F2C00054-4BE0-4471-BB66-FD291AF787E1}"/>
               </a:ext>
             </a:extLst>
           </p:cNvPr>
@@ -13779,7 +13815,7 @@
           <p:cNvPr id="3" name="§2.1.1 Kostenstructuren">
             <a:extLst xmlns:a="http://schemas.openxmlformats.org/drawingml/2006/main">
               <a:ext uri="{FF2B5EF4-FFF2-40B4-BE49-F238E27FC236}">
-                <a16:creationId xmlns:a16="http://schemas.microsoft.com/office/drawing/2014/main" id="{AA1866C7-BF93-4F94-9695-8375551D4456}"/>
+                <a16:creationId xmlns:a16="http://schemas.microsoft.com/office/drawing/2014/main" id="{A7EFE032-5532-475C-84E0-1808673BEFD1}"/>
               </a:ext>
             </a:extLst>
           </p:cNvPr>
@@ -13836,7 +13872,7 @@
           <p:cNvPr id="4" name="2">
             <a:extLst xmlns:a="http://schemas.openxmlformats.org/drawingml/2006/main">
               <a:ext uri="{FF2B5EF4-FFF2-40B4-BE49-F238E27FC236}">
-                <a16:creationId xmlns:a16="http://schemas.microsoft.com/office/drawing/2014/main" id="{F3054E77-F58B-41F9-94A8-9C1C60BED387}"/>
+                <a16:creationId xmlns:a16="http://schemas.microsoft.com/office/drawing/2014/main" id="{B9A516E6-81D3-4E6C-9BFE-EC3388142F75}"/>
               </a:ext>
             </a:extLst>
           </p:cNvPr>
@@ -13893,7 +13929,7 @@
           <p:cNvPr id="5" name="Kosten indelen">
             <a:extLst xmlns:a="http://schemas.openxmlformats.org/drawingml/2006/main">
               <a:ext uri="{FF2B5EF4-FFF2-40B4-BE49-F238E27FC236}">
-                <a16:creationId xmlns:a16="http://schemas.microsoft.com/office/drawing/2014/main" id="{DA2F413E-42FE-4838-A8D8-74375A463214}"/>
+                <a16:creationId xmlns:a16="http://schemas.microsoft.com/office/drawing/2014/main" id="{08D6327D-C2AC-4C1A-B3BC-FA1A56490D94}"/>
               </a:ext>
             </a:extLst>
           </p:cNvPr>
@@ -13950,7 +13986,7 @@
           <p:cNvPr id="6" name="Je legt uit welke totale bedragen veranderen bij m">
             <a:extLst xmlns:a="http://schemas.openxmlformats.org/drawingml/2006/main">
               <a:ext uri="{FF2B5EF4-FFF2-40B4-BE49-F238E27FC236}">
-                <a16:creationId xmlns:a16="http://schemas.microsoft.com/office/drawing/2014/main" id="{26E52718-8F3A-4979-87EF-5A97A50F8462}"/>
+                <a16:creationId xmlns:a16="http://schemas.microsoft.com/office/drawing/2014/main" id="{18B8F703-5596-4097-AD3C-E6CF0A4180E2}"/>
               </a:ext>
             </a:extLst>
           </p:cNvPr>
@@ -14007,7 +14043,7 @@
           <p:cNvPr id="7" name="">
             <a:extLst xmlns:a="http://schemas.openxmlformats.org/drawingml/2006/main">
               <a:ext uri="{FF2B5EF4-FFF2-40B4-BE49-F238E27FC236}">
-                <a16:creationId xmlns:a16="http://schemas.microsoft.com/office/drawing/2014/main" id="{8D78C250-C49F-48ED-9B7B-45E2ACDF0F20}"/>
+                <a16:creationId xmlns:a16="http://schemas.microsoft.com/office/drawing/2014/main" id="{70A9E337-8F55-4C71-8C31-D9D1EAF7B0CB}"/>
               </a:ext>
             </a:extLst>
           </p:cNvPr>
@@ -14036,7 +14072,7 @@
           <p:cNvPr id="8" name="Kostenfuncties opstellen">
             <a:extLst xmlns:a="http://schemas.openxmlformats.org/drawingml/2006/main">
               <a:ext uri="{FF2B5EF4-FFF2-40B4-BE49-F238E27FC236}">
-                <a16:creationId xmlns:a16="http://schemas.microsoft.com/office/drawing/2014/main" id="{F45D795C-CB3D-4727-AB41-96B40D3B5DCE}"/>
+                <a16:creationId xmlns:a16="http://schemas.microsoft.com/office/drawing/2014/main" id="{8C2C797F-353A-4C9A-A0B5-867440A8922A}"/>
               </a:ext>
             </a:extLst>
           </p:cNvPr>
@@ -14093,7 +14129,7 @@
           <p:cNvPr id="9" name="Je schrijft TCK, TVK en TK als functie van Q.">
             <a:extLst xmlns:a="http://schemas.openxmlformats.org/drawingml/2006/main">
               <a:ext uri="{FF2B5EF4-FFF2-40B4-BE49-F238E27FC236}">
-                <a16:creationId xmlns:a16="http://schemas.microsoft.com/office/drawing/2014/main" id="{51439FE0-7E35-4DB5-A041-4594C5242632}"/>
+                <a16:creationId xmlns:a16="http://schemas.microsoft.com/office/drawing/2014/main" id="{47C28E3F-9B66-48D0-AE52-986AD571A737}"/>
               </a:ext>
             </a:extLst>
           </p:cNvPr>
@@ -14150,7 +14186,7 @@
           <p:cNvPr id="10" name="">
             <a:extLst xmlns:a="http://schemas.openxmlformats.org/drawingml/2006/main">
               <a:ext uri="{FF2B5EF4-FFF2-40B4-BE49-F238E27FC236}">
-                <a16:creationId xmlns:a16="http://schemas.microsoft.com/office/drawing/2014/main" id="{F75F3044-469C-4B34-A711-5447C543A293}"/>
+                <a16:creationId xmlns:a16="http://schemas.microsoft.com/office/drawing/2014/main" id="{06229D1F-37FB-4C81-9AC3-B8B778ED0747}"/>
               </a:ext>
             </a:extLst>
           </p:cNvPr>
@@ -14179,7 +14215,7 @@
           <p:cNvPr id="11" name="Kosten per product berekenen">
             <a:extLst xmlns:a="http://schemas.openxmlformats.org/drawingml/2006/main">
               <a:ext uri="{FF2B5EF4-FFF2-40B4-BE49-F238E27FC236}">
-                <a16:creationId xmlns:a16="http://schemas.microsoft.com/office/drawing/2014/main" id="{D93A4DB0-9064-47CC-B9C4-B3A497DADB81}"/>
+                <a16:creationId xmlns:a16="http://schemas.microsoft.com/office/drawing/2014/main" id="{4FDB456B-AA9F-4A44-9489-7E2A58E3E044}"/>
               </a:ext>
             </a:extLst>
           </p:cNvPr>
@@ -14236,7 +14272,7 @@
           <p:cNvPr id="12" name="Je berekent GCK, GVK en GTK met de juiste eenheid.">
             <a:extLst xmlns:a="http://schemas.openxmlformats.org/drawingml/2006/main">
               <a:ext uri="{FF2B5EF4-FFF2-40B4-BE49-F238E27FC236}">
-                <a16:creationId xmlns:a16="http://schemas.microsoft.com/office/drawing/2014/main" id="{9A0F646A-7874-4BD7-A4C1-419755FB44CE}"/>
+                <a16:creationId xmlns:a16="http://schemas.microsoft.com/office/drawing/2014/main" id="{12E198CC-27D7-4883-B86E-E3293B0ED5CD}"/>
               </a:ext>
             </a:extLst>
           </p:cNvPr>
@@ -14293,7 +14329,7 @@
           <p:cNvPr id="13" name="">
             <a:extLst xmlns:a="http://schemas.openxmlformats.org/drawingml/2006/main">
               <a:ext uri="{FF2B5EF4-FFF2-40B4-BE49-F238E27FC236}">
-                <a16:creationId xmlns:a16="http://schemas.microsoft.com/office/drawing/2014/main" id="{441B4179-606F-4535-8D67-8B59D027F0EE}"/>
+                <a16:creationId xmlns:a16="http://schemas.microsoft.com/office/drawing/2014/main" id="{46CFD913-7529-4666-9AAE-52B654A0964B}"/>
               </a:ext>
             </a:extLst>
           </p:cNvPr>
@@ -14322,7 +14358,7 @@
           <p:cNvPr id="14" name="Een verandering verklaren">
             <a:extLst xmlns:a="http://schemas.openxmlformats.org/drawingml/2006/main">
               <a:ext uri="{FF2B5EF4-FFF2-40B4-BE49-F238E27FC236}">
-                <a16:creationId xmlns:a16="http://schemas.microsoft.com/office/drawing/2014/main" id="{7BBEC662-6B55-47C8-8D14-30B695DAA496}"/>
+                <a16:creationId xmlns:a16="http://schemas.microsoft.com/office/drawing/2014/main" id="{40A03391-5E8E-4798-894F-3DF47A94E7C2}"/>
               </a:ext>
             </a:extLst>
           </p:cNvPr>
@@ -14379,7 +14415,7 @@
           <p:cNvPr id="15" name="Je legt uit waarom TK kan stijgen terwijl GTK daal">
             <a:extLst xmlns:a="http://schemas.openxmlformats.org/drawingml/2006/main">
               <a:ext uri="{FF2B5EF4-FFF2-40B4-BE49-F238E27FC236}">
-                <a16:creationId xmlns:a16="http://schemas.microsoft.com/office/drawing/2014/main" id="{3E0A4EB4-D833-4A64-BBE1-C5307F710DB2}"/>
+                <a16:creationId xmlns:a16="http://schemas.microsoft.com/office/drawing/2014/main" id="{10E6A96B-0FA2-44B6-8171-A21EC69B54D5}"/>
               </a:ext>
             </a:extLst>
           </p:cNvPr>
@@ -14434,7 +14470,7 @@
     </p:spTree>
     <p:extLst>
       <p:ext uri="{BB962C8B-B14F-4D97-AF65-F5344CB8AC3E}">
-        <p14:creationId xmlns:p14="http://schemas.microsoft.com/office/powerpoint/2010/main" val="1521679844"/>
+        <p14:creationId xmlns:p14="http://schemas.microsoft.com/office/powerpoint/2010/main" val="1148934514"/>
       </p:ext>
     </p:extLst>
   </p:cSld>
@@ -14465,7 +14501,7 @@
           <p:cNvPr id="12" name="Opgave 7e · Eerst de totalen vergelijken">
             <a:extLst xmlns:a="http://schemas.openxmlformats.org/drawingml/2006/main">
               <a:ext uri="{FF2B5EF4-FFF2-40B4-BE49-F238E27FC236}">
-                <a16:creationId xmlns:a16="http://schemas.microsoft.com/office/drawing/2014/main" id="{E12B8549-D19B-4D81-840B-A45439D8E059}"/>
+                <a16:creationId xmlns:a16="http://schemas.microsoft.com/office/drawing/2014/main" id="{6301DA2D-1F01-4D54-8067-BF0D53384B5F}"/>
               </a:ext>
             </a:extLst>
           </p:cNvPr>
@@ -14522,7 +14558,7 @@
           <p:cNvPr id="2" name="">
             <a:extLst xmlns:a="http://schemas.openxmlformats.org/drawingml/2006/main">
               <a:ext uri="{FF2B5EF4-FFF2-40B4-BE49-F238E27FC236}">
-                <a16:creationId xmlns:a16="http://schemas.microsoft.com/office/drawing/2014/main" id="{36A2EB8F-82F4-4EC1-A10C-9A5094A87993}"/>
+                <a16:creationId xmlns:a16="http://schemas.microsoft.com/office/drawing/2014/main" id="{ECAE3E6A-8594-4294-BFA7-2D8CADEB7680}"/>
               </a:ext>
             </a:extLst>
           </p:cNvPr>
@@ -14551,7 +14587,7 @@
           <p:cNvPr id="3" name="§2.1.1 Kostenstructuren · Opgave 7 · Boekpagina 8">
             <a:extLst xmlns:a="http://schemas.openxmlformats.org/drawingml/2006/main">
               <a:ext uri="{FF2B5EF4-FFF2-40B4-BE49-F238E27FC236}">
-                <a16:creationId xmlns:a16="http://schemas.microsoft.com/office/drawing/2014/main" id="{103056D1-CF81-4997-B2CB-1FBAAD3DC326}"/>
+                <a16:creationId xmlns:a16="http://schemas.microsoft.com/office/drawing/2014/main" id="{4B457ADA-A3CA-4D5F-BEBC-7E8491072363}"/>
               </a:ext>
             </a:extLst>
           </p:cNvPr>
@@ -14608,7 +14644,7 @@
           <p:cNvPr id="4" name="20">
             <a:extLst xmlns:a="http://schemas.openxmlformats.org/drawingml/2006/main">
               <a:ext uri="{FF2B5EF4-FFF2-40B4-BE49-F238E27FC236}">
-                <a16:creationId xmlns:a16="http://schemas.microsoft.com/office/drawing/2014/main" id="{F1875DB3-9ED1-4419-825E-46721E1B5C03}"/>
+                <a16:creationId xmlns:a16="http://schemas.microsoft.com/office/drawing/2014/main" id="{3FA6F5F7-9374-4301-A319-6DAEF26A3F78}"/>
               </a:ext>
             </a:extLst>
           </p:cNvPr>
@@ -14983,7 +15019,7 @@
           <p:cNvPr id="6" name="TCK blijft gelijk">
             <a:extLst xmlns:a="http://schemas.openxmlformats.org/drawingml/2006/main">
               <a:ext uri="{FF2B5EF4-FFF2-40B4-BE49-F238E27FC236}">
-                <a16:creationId xmlns:a16="http://schemas.microsoft.com/office/drawing/2014/main" id="{D633364F-41EA-437E-B350-67569437E403}"/>
+                <a16:creationId xmlns:a16="http://schemas.microsoft.com/office/drawing/2014/main" id="{18E8AB7D-C78C-402C-91AB-7A36830B8408}"/>
               </a:ext>
             </a:extLst>
           </p:cNvPr>
@@ -15040,7 +15076,7 @@
           <p:cNvPr id="7" name="De ruimte en ovens blijven hetzelfde.">
             <a:extLst xmlns:a="http://schemas.openxmlformats.org/drawingml/2006/main">
               <a:ext uri="{FF2B5EF4-FFF2-40B4-BE49-F238E27FC236}">
-                <a16:creationId xmlns:a16="http://schemas.microsoft.com/office/drawing/2014/main" id="{657C57C5-073C-4035-884D-6FDC62729516}"/>
+                <a16:creationId xmlns:a16="http://schemas.microsoft.com/office/drawing/2014/main" id="{6470A732-192F-428C-92CC-F5BD3666DF62}"/>
               </a:ext>
             </a:extLst>
           </p:cNvPr>
@@ -15097,7 +15133,7 @@
           <p:cNvPr id="8" name="TVK verdubbelt">
             <a:extLst xmlns:a="http://schemas.openxmlformats.org/drawingml/2006/main">
               <a:ext uri="{FF2B5EF4-FFF2-40B4-BE49-F238E27FC236}">
-                <a16:creationId xmlns:a16="http://schemas.microsoft.com/office/drawing/2014/main" id="{384C7960-9936-4188-971C-1DBC37ED84B8}"/>
+                <a16:creationId xmlns:a16="http://schemas.microsoft.com/office/drawing/2014/main" id="{7E3F5BB5-30EA-4175-B1DB-B48539027065}"/>
               </a:ext>
             </a:extLst>
           </p:cNvPr>
@@ -15154,7 +15190,7 @@
           <p:cNvPr id="9" name="Tweemaal zoveel broden vragen tweemaal zoveel vari">
             <a:extLst xmlns:a="http://schemas.openxmlformats.org/drawingml/2006/main">
               <a:ext uri="{FF2B5EF4-FFF2-40B4-BE49-F238E27FC236}">
-                <a16:creationId xmlns:a16="http://schemas.microsoft.com/office/drawing/2014/main" id="{39BC94F1-20C2-480F-BEFA-166FF9B82D00}"/>
+                <a16:creationId xmlns:a16="http://schemas.microsoft.com/office/drawing/2014/main" id="{8ABDDF3C-7F36-49B5-AAFD-F50A8C5BA25F}"/>
               </a:ext>
             </a:extLst>
           </p:cNvPr>
@@ -15211,7 +15247,7 @@
           <p:cNvPr id="10" name="TK stijgt, maar verdubbelt niet">
             <a:extLst xmlns:a="http://schemas.openxmlformats.org/drawingml/2006/main">
               <a:ext uri="{FF2B5EF4-FFF2-40B4-BE49-F238E27FC236}">
-                <a16:creationId xmlns:a16="http://schemas.microsoft.com/office/drawing/2014/main" id="{5C280592-0333-49B7-AA15-685A2A3BABE2}"/>
+                <a16:creationId xmlns:a16="http://schemas.microsoft.com/office/drawing/2014/main" id="{E75967FF-7C35-48FE-A3EC-A875986C0610}"/>
               </a:ext>
             </a:extLst>
           </p:cNvPr>
@@ -15268,7 +15304,7 @@
           <p:cNvPr id="11" name="Alleen het variabele deel verdubbelt.">
             <a:extLst xmlns:a="http://schemas.openxmlformats.org/drawingml/2006/main">
               <a:ext uri="{FF2B5EF4-FFF2-40B4-BE49-F238E27FC236}">
-                <a16:creationId xmlns:a16="http://schemas.microsoft.com/office/drawing/2014/main" id="{55EB9EEF-154C-4788-8058-20201CCEF7AD}"/>
+                <a16:creationId xmlns:a16="http://schemas.microsoft.com/office/drawing/2014/main" id="{7C27A131-ACA8-49C0-9C42-834CDE42D68D}"/>
               </a:ext>
             </a:extLst>
           </p:cNvPr>
@@ -15323,7 +15359,7 @@
     </p:spTree>
     <p:extLst>
       <p:ext uri="{BB962C8B-B14F-4D97-AF65-F5344CB8AC3E}">
-        <p14:creationId xmlns:p14="http://schemas.microsoft.com/office/powerpoint/2010/main" val="861521751"/>
+        <p14:creationId xmlns:p14="http://schemas.microsoft.com/office/powerpoint/2010/main" val="69699979"/>
       </p:ext>
     </p:extLst>
   </p:cSld>
@@ -15354,7 +15390,7 @@
           <p:cNvPr id="9" name="Opgave 7e · Waarom halveert GTK niet?">
             <a:extLst xmlns:a="http://schemas.openxmlformats.org/drawingml/2006/main">
               <a:ext uri="{FF2B5EF4-FFF2-40B4-BE49-F238E27FC236}">
-                <a16:creationId xmlns:a16="http://schemas.microsoft.com/office/drawing/2014/main" id="{D1721A77-FD2C-433A-A9E0-38A866793D00}"/>
+                <a16:creationId xmlns:a16="http://schemas.microsoft.com/office/drawing/2014/main" id="{0B6C7907-DE36-4ED2-B327-87CB1E20E792}"/>
               </a:ext>
             </a:extLst>
           </p:cNvPr>
@@ -15411,7 +15447,7 @@
           <p:cNvPr id="2" name="">
             <a:extLst xmlns:a="http://schemas.openxmlformats.org/drawingml/2006/main">
               <a:ext uri="{FF2B5EF4-FFF2-40B4-BE49-F238E27FC236}">
-                <a16:creationId xmlns:a16="http://schemas.microsoft.com/office/drawing/2014/main" id="{7BD887FB-E1B3-4F7F-9AFD-2BBC71AEC56C}"/>
+                <a16:creationId xmlns:a16="http://schemas.microsoft.com/office/drawing/2014/main" id="{23EC8A83-A670-455E-AF1A-83A0878F7F94}"/>
               </a:ext>
             </a:extLst>
           </p:cNvPr>
@@ -15440,7 +15476,7 @@
           <p:cNvPr id="3" name="§2.1.1 Kostenstructuren · Opgave 7 · Boekpagina 8">
             <a:extLst xmlns:a="http://schemas.openxmlformats.org/drawingml/2006/main">
               <a:ext uri="{FF2B5EF4-FFF2-40B4-BE49-F238E27FC236}">
-                <a16:creationId xmlns:a16="http://schemas.microsoft.com/office/drawing/2014/main" id="{8F94FC8D-6C34-4CC5-85C8-16CBA89ADEAF}"/>
+                <a16:creationId xmlns:a16="http://schemas.microsoft.com/office/drawing/2014/main" id="{36D23D4A-A4DD-4653-9854-C86582923376}"/>
               </a:ext>
             </a:extLst>
           </p:cNvPr>
@@ -15497,7 +15533,7 @@
           <p:cNvPr id="4" name="21">
             <a:extLst xmlns:a="http://schemas.openxmlformats.org/drawingml/2006/main">
               <a:ext uri="{FF2B5EF4-FFF2-40B4-BE49-F238E27FC236}">
-                <a16:creationId xmlns:a16="http://schemas.microsoft.com/office/drawing/2014/main" id="{EB02FEF2-4604-41F7-8792-932D0D1A8CFD}"/>
+                <a16:creationId xmlns:a16="http://schemas.microsoft.com/office/drawing/2014/main" id="{4D44A9ED-E3AC-40C5-A192-6719054EBC02}"/>
               </a:ext>
             </a:extLst>
           </p:cNvPr>
@@ -15872,7 +15908,7 @@
           <p:cNvPr id="6" name="Dezelfde € 500 wordt over tweemaal zoveel broden v">
             <a:extLst xmlns:a="http://schemas.openxmlformats.org/drawingml/2006/main">
               <a:ext uri="{FF2B5EF4-FFF2-40B4-BE49-F238E27FC236}">
-                <a16:creationId xmlns:a16="http://schemas.microsoft.com/office/drawing/2014/main" id="{DBCBED5D-1832-4044-82F0-20A6934309DF}"/>
+                <a16:creationId xmlns:a16="http://schemas.microsoft.com/office/drawing/2014/main" id="{5A468FE5-40F9-44E4-9FA6-E960AA7D54F7}"/>
               </a:ext>
             </a:extLst>
           </p:cNvPr>
@@ -15929,7 +15965,7 @@
           <p:cNvPr id="7" name="GCK halveert. GVK blijft € 0,80 per brood.">
             <a:extLst xmlns:a="http://schemas.openxmlformats.org/drawingml/2006/main">
               <a:ext uri="{FF2B5EF4-FFF2-40B4-BE49-F238E27FC236}">
-                <a16:creationId xmlns:a16="http://schemas.microsoft.com/office/drawing/2014/main" id="{B4DF4141-834F-4136-8B7E-1EE0EFB966FB}"/>
+                <a16:creationId xmlns:a16="http://schemas.microsoft.com/office/drawing/2014/main" id="{6526E5BF-D699-4906-B071-6EC583217B6D}"/>
               </a:ext>
             </a:extLst>
           </p:cNvPr>
@@ -15986,7 +16022,7 @@
           <p:cNvPr id="8" name="Alleen het vaste deel van GTK halveert: € 0,50 + €">
             <a:extLst xmlns:a="http://schemas.openxmlformats.org/drawingml/2006/main">
               <a:ext uri="{FF2B5EF4-FFF2-40B4-BE49-F238E27FC236}">
-                <a16:creationId xmlns:a16="http://schemas.microsoft.com/office/drawing/2014/main" id="{7BC4E93C-7013-49AE-A5AC-842088CE01C9}"/>
+                <a16:creationId xmlns:a16="http://schemas.microsoft.com/office/drawing/2014/main" id="{AB4A8D4F-AE3B-4A28-B16F-334F0AE3EB66}"/>
               </a:ext>
             </a:extLst>
           </p:cNvPr>
@@ -16041,7 +16077,7 @@
     </p:spTree>
     <p:extLst>
       <p:ext uri="{BB962C8B-B14F-4D97-AF65-F5344CB8AC3E}">
-        <p14:creationId xmlns:p14="http://schemas.microsoft.com/office/powerpoint/2010/main" val="1261238890"/>
+        <p14:creationId xmlns:p14="http://schemas.microsoft.com/office/powerpoint/2010/main" val="1663837679"/>
       </p:ext>
     </p:extLst>
   </p:cSld>
@@ -16072,7 +16108,7 @@
           <p:cNvPr id="14" name="Antwoordcontrole bij opgave 7">
             <a:extLst xmlns:a="http://schemas.openxmlformats.org/drawingml/2006/main">
               <a:ext uri="{FF2B5EF4-FFF2-40B4-BE49-F238E27FC236}">
-                <a16:creationId xmlns:a16="http://schemas.microsoft.com/office/drawing/2014/main" id="{A5AA3D13-9B46-435E-BF28-BF8F39359A1B}"/>
+                <a16:creationId xmlns:a16="http://schemas.microsoft.com/office/drawing/2014/main" id="{46E5549A-2730-42C6-BAAA-E4B37F60E67E}"/>
               </a:ext>
             </a:extLst>
           </p:cNvPr>
@@ -16129,7 +16165,7 @@
           <p:cNvPr id="2" name="">
             <a:extLst xmlns:a="http://schemas.openxmlformats.org/drawingml/2006/main">
               <a:ext uri="{FF2B5EF4-FFF2-40B4-BE49-F238E27FC236}">
-                <a16:creationId xmlns:a16="http://schemas.microsoft.com/office/drawing/2014/main" id="{575049F3-827E-4D7B-A655-D310DA610903}"/>
+                <a16:creationId xmlns:a16="http://schemas.microsoft.com/office/drawing/2014/main" id="{AB0D7305-A11B-4CE3-8964-2DA2EFB033DE}"/>
               </a:ext>
             </a:extLst>
           </p:cNvPr>
@@ -16158,7 +16194,7 @@
           <p:cNvPr id="3" name="§2.1.1 Kostenstructuren">
             <a:extLst xmlns:a="http://schemas.openxmlformats.org/drawingml/2006/main">
               <a:ext uri="{FF2B5EF4-FFF2-40B4-BE49-F238E27FC236}">
-                <a16:creationId xmlns:a16="http://schemas.microsoft.com/office/drawing/2014/main" id="{3A30A2D5-49C7-4BE8-A573-2F381DD6340C}"/>
+                <a16:creationId xmlns:a16="http://schemas.microsoft.com/office/drawing/2014/main" id="{1EFEEBFD-0A06-40D6-A615-27856A35A5A4}"/>
               </a:ext>
             </a:extLst>
           </p:cNvPr>
@@ -16215,7 +16251,7 @@
           <p:cNvPr id="4" name="22">
             <a:extLst xmlns:a="http://schemas.openxmlformats.org/drawingml/2006/main">
               <a:ext uri="{FF2B5EF4-FFF2-40B4-BE49-F238E27FC236}">
-                <a16:creationId xmlns:a16="http://schemas.microsoft.com/office/drawing/2014/main" id="{70850C72-70F0-4A1C-B000-1A2753700F10}"/>
+                <a16:creationId xmlns:a16="http://schemas.microsoft.com/office/drawing/2014/main" id="{4720BA13-A708-4D2F-8AC6-60573D8F2024}"/>
               </a:ext>
             </a:extLst>
           </p:cNvPr>
@@ -16272,7 +16308,7 @@
           <p:cNvPr id="5" name="Indeling">
             <a:extLst xmlns:a="http://schemas.openxmlformats.org/drawingml/2006/main">
               <a:ext uri="{FF2B5EF4-FFF2-40B4-BE49-F238E27FC236}">
-                <a16:creationId xmlns:a16="http://schemas.microsoft.com/office/drawing/2014/main" id="{BB350AC7-E0D9-42FB-B6B3-0A03D0F8D554}"/>
+                <a16:creationId xmlns:a16="http://schemas.microsoft.com/office/drawing/2014/main" id="{D911FD08-4594-4F23-8850-9C330569CD0C}"/>
               </a:ext>
             </a:extLst>
           </p:cNvPr>
@@ -16329,7 +16365,7 @@
           <p:cNvPr id="6" name="Alle vier kostenposten hebben een soort én een red">
             <a:extLst xmlns:a="http://schemas.openxmlformats.org/drawingml/2006/main">
               <a:ext uri="{FF2B5EF4-FFF2-40B4-BE49-F238E27FC236}">
-                <a16:creationId xmlns:a16="http://schemas.microsoft.com/office/drawing/2014/main" id="{D31E7831-A5DF-4A29-9F73-8FC32EF43AE4}"/>
+                <a16:creationId xmlns:a16="http://schemas.microsoft.com/office/drawing/2014/main" id="{D9D7D052-61D9-4490-B453-9883F586E0E6}"/>
               </a:ext>
             </a:extLst>
           </p:cNvPr>
@@ -16386,7 +16422,7 @@
           <p:cNvPr id="7" name="Berekeningen">
             <a:extLst xmlns:a="http://schemas.openxmlformats.org/drawingml/2006/main">
               <a:ext uri="{FF2B5EF4-FFF2-40B4-BE49-F238E27FC236}">
-                <a16:creationId xmlns:a16="http://schemas.microsoft.com/office/drawing/2014/main" id="{1D265D39-265B-49D0-8D80-AEB4DC87C1B5}"/>
+                <a16:creationId xmlns:a16="http://schemas.microsoft.com/office/drawing/2014/main" id="{2BEB1350-8FE5-470D-993A-A0ABCA2A95E5}"/>
               </a:ext>
             </a:extLst>
           </p:cNvPr>
@@ -16443,7 +16479,7 @@
           <p:cNvPr id="8" name="500 + 0,80Q levert TK in euro per maand.">
             <a:extLst xmlns:a="http://schemas.openxmlformats.org/drawingml/2006/main">
               <a:ext uri="{FF2B5EF4-FFF2-40B4-BE49-F238E27FC236}">
-                <a16:creationId xmlns:a16="http://schemas.microsoft.com/office/drawing/2014/main" id="{3877719D-8F3C-422F-9C55-7EB89A97B6EA}"/>
+                <a16:creationId xmlns:a16="http://schemas.microsoft.com/office/drawing/2014/main" id="{19DF4F9C-1AE0-4375-859F-8AE39FFFBA07}"/>
               </a:ext>
             </a:extLst>
           </p:cNvPr>
@@ -16500,7 +16536,7 @@
           <p:cNvPr id="9" name="Eenheden">
             <a:extLst xmlns:a="http://schemas.openxmlformats.org/drawingml/2006/main">
               <a:ext uri="{FF2B5EF4-FFF2-40B4-BE49-F238E27FC236}">
-                <a16:creationId xmlns:a16="http://schemas.microsoft.com/office/drawing/2014/main" id="{1B7B9491-9110-4C0D-BB5F-181D5FAF7EE5}"/>
+                <a16:creationId xmlns:a16="http://schemas.microsoft.com/office/drawing/2014/main" id="{67210A86-D1F5-4CFC-8004-BC0F43DF4FFA}"/>
               </a:ext>
             </a:extLst>
           </p:cNvPr>
@@ -16557,7 +16593,7 @@
           <p:cNvPr id="10" name="GCK, GVK en GTK staan in euro per brood.">
             <a:extLst xmlns:a="http://schemas.openxmlformats.org/drawingml/2006/main">
               <a:ext uri="{FF2B5EF4-FFF2-40B4-BE49-F238E27FC236}">
-                <a16:creationId xmlns:a16="http://schemas.microsoft.com/office/drawing/2014/main" id="{212FED1A-37CC-4024-BEBD-34828258A10E}"/>
+                <a16:creationId xmlns:a16="http://schemas.microsoft.com/office/drawing/2014/main" id="{17F80648-7857-4211-BFCA-7685E177FD2B}"/>
               </a:ext>
             </a:extLst>
           </p:cNvPr>
@@ -16614,7 +16650,7 @@
           <p:cNvPr id="11" name="Verklaring">
             <a:extLst xmlns:a="http://schemas.openxmlformats.org/drawingml/2006/main">
               <a:ext uri="{FF2B5EF4-FFF2-40B4-BE49-F238E27FC236}">
-                <a16:creationId xmlns:a16="http://schemas.microsoft.com/office/drawing/2014/main" id="{4CCFC630-93B4-489D-8DDB-07F7A4618CE1}"/>
+                <a16:creationId xmlns:a16="http://schemas.microsoft.com/office/drawing/2014/main" id="{9CA37CD5-5E91-4896-AFE1-96411A9AEEFC}"/>
               </a:ext>
             </a:extLst>
           </p:cNvPr>
@@ -16671,7 +16707,7 @@
           <p:cNvPr id="12" name="Je verklaart waarom alleen GCK halveert.">
             <a:extLst xmlns:a="http://schemas.openxmlformats.org/drawingml/2006/main">
               <a:ext uri="{FF2B5EF4-FFF2-40B4-BE49-F238E27FC236}">
-                <a16:creationId xmlns:a16="http://schemas.microsoft.com/office/drawing/2014/main" id="{56990D33-46A0-455B-B577-2BCA70BA1FA9}"/>
+                <a16:creationId xmlns:a16="http://schemas.microsoft.com/office/drawing/2014/main" id="{2CB195C6-5F63-4874-83BF-E8A77873599B}"/>
               </a:ext>
             </a:extLst>
           </p:cNvPr>
@@ -16728,7 +16764,7 @@
           <p:cNvPr id="13" name="Verbeter één ontbrekende stap of onjuiste uitleg i">
             <a:extLst xmlns:a="http://schemas.openxmlformats.org/drawingml/2006/main">
               <a:ext uri="{FF2B5EF4-FFF2-40B4-BE49-F238E27FC236}">
-                <a16:creationId xmlns:a16="http://schemas.microsoft.com/office/drawing/2014/main" id="{241F8617-FA74-4A88-B316-40AD7B9D5CFB}"/>
+                <a16:creationId xmlns:a16="http://schemas.microsoft.com/office/drawing/2014/main" id="{9BFE32B9-1DF1-4C94-90E4-B00BE2FBE5D0}"/>
               </a:ext>
             </a:extLst>
           </p:cNvPr>
@@ -16783,7 +16819,7 @@
     </p:spTree>
     <p:extLst>
       <p:ext uri="{BB962C8B-B14F-4D97-AF65-F5344CB8AC3E}">
-        <p14:creationId xmlns:p14="http://schemas.microsoft.com/office/powerpoint/2010/main" val="344485593"/>
+        <p14:creationId xmlns:p14="http://schemas.microsoft.com/office/powerpoint/2010/main" val="577639050"/>
       </p:ext>
     </p:extLst>
   </p:cSld>
@@ -16814,7 +16850,7 @@
           <p:cNvPr id="29" name="Deze les: §2.1.1 Kostenstructuren">
             <a:extLst xmlns:a="http://schemas.openxmlformats.org/drawingml/2006/main">
               <a:ext uri="{FF2B5EF4-FFF2-40B4-BE49-F238E27FC236}">
-                <a16:creationId xmlns:a16="http://schemas.microsoft.com/office/drawing/2014/main" id="{681A20F7-06F3-4DBC-B2F6-7949E8819936}"/>
+                <a16:creationId xmlns:a16="http://schemas.microsoft.com/office/drawing/2014/main" id="{C5951151-372D-481A-9515-09B7960808A0}"/>
               </a:ext>
             </a:extLst>
           </p:cNvPr>
@@ -16871,7 +16907,7 @@
           <p:cNvPr id="2" name="">
             <a:extLst xmlns:a="http://schemas.openxmlformats.org/drawingml/2006/main">
               <a:ext uri="{FF2B5EF4-FFF2-40B4-BE49-F238E27FC236}">
-                <a16:creationId xmlns:a16="http://schemas.microsoft.com/office/drawing/2014/main" id="{2A66589F-5742-4CE5-885F-89789F488FE6}"/>
+                <a16:creationId xmlns:a16="http://schemas.microsoft.com/office/drawing/2014/main" id="{290BD812-91F2-4EDF-ADB7-85EEB8A08168}"/>
               </a:ext>
             </a:extLst>
           </p:cNvPr>
@@ -16900,7 +16936,7 @@
           <p:cNvPr id="3" name="§2.1.1 Kostenstructuren">
             <a:extLst xmlns:a="http://schemas.openxmlformats.org/drawingml/2006/main">
               <a:ext uri="{FF2B5EF4-FFF2-40B4-BE49-F238E27FC236}">
-                <a16:creationId xmlns:a16="http://schemas.microsoft.com/office/drawing/2014/main" id="{6B1466D8-EB86-48D5-94EA-89F007183C80}"/>
+                <a16:creationId xmlns:a16="http://schemas.microsoft.com/office/drawing/2014/main" id="{DEDD79A9-667E-4546-B6D8-9DA2B426252C}"/>
               </a:ext>
             </a:extLst>
           </p:cNvPr>
@@ -16957,7 +16993,7 @@
           <p:cNvPr id="4" name="23">
             <a:extLst xmlns:a="http://schemas.openxmlformats.org/drawingml/2006/main">
               <a:ext uri="{FF2B5EF4-FFF2-40B4-BE49-F238E27FC236}">
-                <a16:creationId xmlns:a16="http://schemas.microsoft.com/office/drawing/2014/main" id="{C4714ACE-9075-4629-B97B-40ACDF062622}"/>
+                <a16:creationId xmlns:a16="http://schemas.microsoft.com/office/drawing/2014/main" id="{107C0EA1-0A86-4157-8F18-309AA42492F6}"/>
               </a:ext>
             </a:extLst>
           </p:cNvPr>
@@ -17014,7 +17050,7 @@
           <p:cNvPr id="5" name="phase">
             <a:extLst xmlns:a="http://schemas.openxmlformats.org/drawingml/2006/main">
               <a:ext uri="{FF2B5EF4-FFF2-40B4-BE49-F238E27FC236}">
-                <a16:creationId xmlns:a16="http://schemas.microsoft.com/office/drawing/2014/main" id="{2C9E3BB3-007E-42E4-BE4F-5321E348013A}"/>
+                <a16:creationId xmlns:a16="http://schemas.microsoft.com/office/drawing/2014/main" id="{363CED3C-9148-47E3-93A2-FF6673F92278}"/>
               </a:ext>
             </a:extLst>
           </p:cNvPr>
@@ -17071,7 +17107,7 @@
           <p:cNvPr id="6" name="Lesroute">
             <a:extLst xmlns:a="http://schemas.openxmlformats.org/drawingml/2006/main">
               <a:ext uri="{FF2B5EF4-FFF2-40B4-BE49-F238E27FC236}">
-                <a16:creationId xmlns:a16="http://schemas.microsoft.com/office/drawing/2014/main" id="{C8217F5D-557E-4252-91A7-013D9E73A161}"/>
+                <a16:creationId xmlns:a16="http://schemas.microsoft.com/office/drawing/2014/main" id="{DE6AB62F-7051-47DC-8C8E-0ED7DD5A1241}"/>
               </a:ext>
             </a:extLst>
           </p:cNvPr>
@@ -17128,7 +17164,7 @@
           <p:cNvPr id="7" name="route-number-1">
             <a:extLst xmlns:a="http://schemas.openxmlformats.org/drawingml/2006/main">
               <a:ext uri="{FF2B5EF4-FFF2-40B4-BE49-F238E27FC236}">
-                <a16:creationId xmlns:a16="http://schemas.microsoft.com/office/drawing/2014/main" id="{1E97A439-F487-49B4-B8D7-05671E0FF277}"/>
+                <a16:creationId xmlns:a16="http://schemas.microsoft.com/office/drawing/2014/main" id="{39E91DD5-5197-4588-96A1-6C2240D46E7F}"/>
               </a:ext>
             </a:extLst>
           </p:cNvPr>
@@ -17185,7 +17221,7 @@
           <p:cNvPr id="8" name="route-1">
             <a:extLst xmlns:a="http://schemas.openxmlformats.org/drawingml/2006/main">
               <a:ext uri="{FF2B5EF4-FFF2-40B4-BE49-F238E27FC236}">
-                <a16:creationId xmlns:a16="http://schemas.microsoft.com/office/drawing/2014/main" id="{30389A28-672A-4972-9E4D-9BFD9DF4377F}"/>
+                <a16:creationId xmlns:a16="http://schemas.microsoft.com/office/drawing/2014/main" id="{75E4897D-E5EF-4C3F-95B4-BECFE4FA2985}"/>
               </a:ext>
             </a:extLst>
           </p:cNvPr>
@@ -17242,7 +17278,7 @@
           <p:cNvPr id="9" name="route-number-2">
             <a:extLst xmlns:a="http://schemas.openxmlformats.org/drawingml/2006/main">
               <a:ext uri="{FF2B5EF4-FFF2-40B4-BE49-F238E27FC236}">
-                <a16:creationId xmlns:a16="http://schemas.microsoft.com/office/drawing/2014/main" id="{DB13C6E3-F2B2-4E14-AFC6-338A55E617E4}"/>
+                <a16:creationId xmlns:a16="http://schemas.microsoft.com/office/drawing/2014/main" id="{3B51FDBD-83AD-4EE8-B9DB-4AE667A8A5FE}"/>
               </a:ext>
             </a:extLst>
           </p:cNvPr>
@@ -17299,7 +17335,7 @@
           <p:cNvPr id="10" name="route-2">
             <a:extLst xmlns:a="http://schemas.openxmlformats.org/drawingml/2006/main">
               <a:ext uri="{FF2B5EF4-FFF2-40B4-BE49-F238E27FC236}">
-                <a16:creationId xmlns:a16="http://schemas.microsoft.com/office/drawing/2014/main" id="{73C62689-A994-4475-8FC3-44F62FEAB577}"/>
+                <a16:creationId xmlns:a16="http://schemas.microsoft.com/office/drawing/2014/main" id="{4E2FC645-07B7-40F8-8EDD-B6478AE73777}"/>
               </a:ext>
             </a:extLst>
           </p:cNvPr>
@@ -17356,7 +17392,7 @@
           <p:cNvPr id="11" name="route-number-3">
             <a:extLst xmlns:a="http://schemas.openxmlformats.org/drawingml/2006/main">
               <a:ext uri="{FF2B5EF4-FFF2-40B4-BE49-F238E27FC236}">
-                <a16:creationId xmlns:a16="http://schemas.microsoft.com/office/drawing/2014/main" id="{E23EAFC2-B024-4672-B028-4C1920DAEE63}"/>
+                <a16:creationId xmlns:a16="http://schemas.microsoft.com/office/drawing/2014/main" id="{FEB29087-5445-46E5-AC97-11F68259A5DA}"/>
               </a:ext>
             </a:extLst>
           </p:cNvPr>
@@ -17413,7 +17449,7 @@
           <p:cNvPr id="12" name="route-3">
             <a:extLst xmlns:a="http://schemas.openxmlformats.org/drawingml/2006/main">
               <a:ext uri="{FF2B5EF4-FFF2-40B4-BE49-F238E27FC236}">
-                <a16:creationId xmlns:a16="http://schemas.microsoft.com/office/drawing/2014/main" id="{F8834B45-2C2F-4999-9C0B-6505D1B92C95}"/>
+                <a16:creationId xmlns:a16="http://schemas.microsoft.com/office/drawing/2014/main" id="{7E99F2B4-B336-47E2-BCDA-F484BEFFA237}"/>
               </a:ext>
             </a:extLst>
           </p:cNvPr>
@@ -17470,7 +17506,7 @@
           <p:cNvPr id="13" name="route-number-4">
             <a:extLst xmlns:a="http://schemas.openxmlformats.org/drawingml/2006/main">
               <a:ext uri="{FF2B5EF4-FFF2-40B4-BE49-F238E27FC236}">
-                <a16:creationId xmlns:a16="http://schemas.microsoft.com/office/drawing/2014/main" id="{A98AD91C-428A-4742-B6AD-1808A90B023D}"/>
+                <a16:creationId xmlns:a16="http://schemas.microsoft.com/office/drawing/2014/main" id="{FA88D920-771C-4A39-AD30-AAF4FCF44FBA}"/>
               </a:ext>
             </a:extLst>
           </p:cNvPr>
@@ -17527,7 +17563,7 @@
           <p:cNvPr id="14" name="route-4">
             <a:extLst xmlns:a="http://schemas.openxmlformats.org/drawingml/2006/main">
               <a:ext uri="{FF2B5EF4-FFF2-40B4-BE49-F238E27FC236}">
-                <a16:creationId xmlns:a16="http://schemas.microsoft.com/office/drawing/2014/main" id="{4DCBE837-FD74-4A38-ACCE-D81F5D92F474}"/>
+                <a16:creationId xmlns:a16="http://schemas.microsoft.com/office/drawing/2014/main" id="{FFDE3FAC-F309-49A3-BF8C-B5E878077CA0}"/>
               </a:ext>
             </a:extLst>
           </p:cNvPr>
@@ -17584,7 +17620,7 @@
           <p:cNvPr id="15" name="route-number-5">
             <a:extLst xmlns:a="http://schemas.openxmlformats.org/drawingml/2006/main">
               <a:ext uri="{FF2B5EF4-FFF2-40B4-BE49-F238E27FC236}">
-                <a16:creationId xmlns:a16="http://schemas.microsoft.com/office/drawing/2014/main" id="{D4576EE1-4B0C-41D5-8EA2-08ED19606042}"/>
+                <a16:creationId xmlns:a16="http://schemas.microsoft.com/office/drawing/2014/main" id="{7025BD55-227A-4E40-8EC4-541C49824875}"/>
               </a:ext>
             </a:extLst>
           </p:cNvPr>
@@ -17641,7 +17677,7 @@
           <p:cNvPr id="16" name="route-5">
             <a:extLst xmlns:a="http://schemas.openxmlformats.org/drawingml/2006/main">
               <a:ext uri="{FF2B5EF4-FFF2-40B4-BE49-F238E27FC236}">
-                <a16:creationId xmlns:a16="http://schemas.microsoft.com/office/drawing/2014/main" id="{41E58B91-99FC-4EC9-8380-69DA9C2EB9CB}"/>
+                <a16:creationId xmlns:a16="http://schemas.microsoft.com/office/drawing/2014/main" id="{C37A89E5-DD2D-4602-9A95-5D70F85D69A1}"/>
               </a:ext>
             </a:extLst>
           </p:cNvPr>
@@ -17698,7 +17734,7 @@
           <p:cNvPr id="17" name="route-number-6">
             <a:extLst xmlns:a="http://schemas.openxmlformats.org/drawingml/2006/main">
               <a:ext uri="{FF2B5EF4-FFF2-40B4-BE49-F238E27FC236}">
-                <a16:creationId xmlns:a16="http://schemas.microsoft.com/office/drawing/2014/main" id="{C280E839-CAB7-4145-A06A-EE7647AB7BB3}"/>
+                <a16:creationId xmlns:a16="http://schemas.microsoft.com/office/drawing/2014/main" id="{89D371FE-9ABE-46FB-BE92-F9624537434E}"/>
               </a:ext>
             </a:extLst>
           </p:cNvPr>
@@ -17755,7 +17791,7 @@
           <p:cNvPr id="18" name="route-6">
             <a:extLst xmlns:a="http://schemas.openxmlformats.org/drawingml/2006/main">
               <a:ext uri="{FF2B5EF4-FFF2-40B4-BE49-F238E27FC236}">
-                <a16:creationId xmlns:a16="http://schemas.microsoft.com/office/drawing/2014/main" id="{2272B9D9-E390-4308-B1F9-49FF077C2B95}"/>
+                <a16:creationId xmlns:a16="http://schemas.microsoft.com/office/drawing/2014/main" id="{8D31926B-FBF5-4C29-B54E-1CC273A55C85}"/>
               </a:ext>
             </a:extLst>
           </p:cNvPr>
@@ -17812,7 +17848,7 @@
           <p:cNvPr id="19" name="route-number-7">
             <a:extLst xmlns:a="http://schemas.openxmlformats.org/drawingml/2006/main">
               <a:ext uri="{FF2B5EF4-FFF2-40B4-BE49-F238E27FC236}">
-                <a16:creationId xmlns:a16="http://schemas.microsoft.com/office/drawing/2014/main" id="{65784F20-7A2E-4F6F-8E06-6C433CEAF762}"/>
+                <a16:creationId xmlns:a16="http://schemas.microsoft.com/office/drawing/2014/main" id="{15FFA1A1-1FD3-469B-BD81-D782A93CCA18}"/>
               </a:ext>
             </a:extLst>
           </p:cNvPr>
@@ -17869,7 +17905,7 @@
           <p:cNvPr id="20" name="route-7">
             <a:extLst xmlns:a="http://schemas.openxmlformats.org/drawingml/2006/main">
               <a:ext uri="{FF2B5EF4-FFF2-40B4-BE49-F238E27FC236}">
-                <a16:creationId xmlns:a16="http://schemas.microsoft.com/office/drawing/2014/main" id="{8AFC6BD6-C463-44D5-9B02-9BE4475E2843}"/>
+                <a16:creationId xmlns:a16="http://schemas.microsoft.com/office/drawing/2014/main" id="{616BD5FD-E136-4A76-8A0E-E3E3BC8D843B}"/>
               </a:ext>
             </a:extLst>
           </p:cNvPr>
@@ -17926,7 +17962,7 @@
           <p:cNvPr id="21" name="Lesdoelen">
             <a:extLst xmlns:a="http://schemas.openxmlformats.org/drawingml/2006/main">
               <a:ext uri="{FF2B5EF4-FFF2-40B4-BE49-F238E27FC236}">
-                <a16:creationId xmlns:a16="http://schemas.microsoft.com/office/drawing/2014/main" id="{26A425E8-D918-4B5D-A278-F6039F3E619F}"/>
+                <a16:creationId xmlns:a16="http://schemas.microsoft.com/office/drawing/2014/main" id="{1A21803C-F9F1-40ED-B180-E7CF49FDFE12}"/>
               </a:ext>
             </a:extLst>
           </p:cNvPr>
@@ -17983,7 +18019,7 @@
           <p:cNvPr id="22" name="overview-goals">
             <a:extLst xmlns:a="http://schemas.openxmlformats.org/drawingml/2006/main">
               <a:ext uri="{FF2B5EF4-FFF2-40B4-BE49-F238E27FC236}">
-                <a16:creationId xmlns:a16="http://schemas.microsoft.com/office/drawing/2014/main" id="{5635101A-CE05-4FBF-9DE2-4A42F32AAFAD}"/>
+                <a16:creationId xmlns:a16="http://schemas.microsoft.com/office/drawing/2014/main" id="{288F5C6E-ABC4-4761-ADE7-89868D68B8C8}"/>
               </a:ext>
             </a:extLst>
           </p:cNvPr>
@@ -18086,7 +18122,7 @@
           <p:cNvPr id="23" name="">
             <a:extLst xmlns:a="http://schemas.openxmlformats.org/drawingml/2006/main">
               <a:ext uri="{FF2B5EF4-FFF2-40B4-BE49-F238E27FC236}">
-                <a16:creationId xmlns:a16="http://schemas.microsoft.com/office/drawing/2014/main" id="{34F21D7D-D982-4F5D-B5D7-DF7A6839B43A}"/>
+                <a16:creationId xmlns:a16="http://schemas.microsoft.com/office/drawing/2014/main" id="{3156E3A1-072D-418C-AA2D-908F20DAA466}"/>
               </a:ext>
             </a:extLst>
           </p:cNvPr>
@@ -18115,7 +18151,7 @@
           <p:cNvPr id="24" name="Startopdracht">
             <a:extLst xmlns:a="http://schemas.openxmlformats.org/drawingml/2006/main">
               <a:ext uri="{FF2B5EF4-FFF2-40B4-BE49-F238E27FC236}">
-                <a16:creationId xmlns:a16="http://schemas.microsoft.com/office/drawing/2014/main" id="{486B929C-DD52-4012-A395-698E83D721D5}"/>
+                <a16:creationId xmlns:a16="http://schemas.microsoft.com/office/drawing/2014/main" id="{99BE59C8-61E0-43BC-8C02-0E437BEFD96A}"/>
               </a:ext>
             </a:extLst>
           </p:cNvPr>
@@ -18172,7 +18208,7 @@
           <p:cNvPr id="25" name="overview-start">
             <a:extLst xmlns:a="http://schemas.openxmlformats.org/drawingml/2006/main">
               <a:ext uri="{FF2B5EF4-FFF2-40B4-BE49-F238E27FC236}">
-                <a16:creationId xmlns:a16="http://schemas.microsoft.com/office/drawing/2014/main" id="{4D3CD428-EAFC-4FAD-9826-5C2E6FE786CE}"/>
+                <a16:creationId xmlns:a16="http://schemas.microsoft.com/office/drawing/2014/main" id="{13468D58-369B-49CB-B6D8-E993CE64007E}"/>
               </a:ext>
             </a:extLst>
           </p:cNvPr>
@@ -18201,48 +18237,48 @@
           <a:lstStyle xmlns:a="http://schemas.openxmlformats.org/drawingml/2006/main"/>
           <a:p xmlns:a="http://schemas.openxmlformats.org/drawingml/2006/main">
             <a:pPr algn="l">
-              <a:defRPr sz="2475" b="0">
-                <a:solidFill>
-                  <a:srgbClr val="183247"/>
-                </a:solidFill>
-                <a:latin typeface="Arial"/>
-                <a:ea typeface="Arial"/>
-                <a:cs typeface="Arial"/>
-              </a:defRPr>
-            </a:pPr>
-            <a:r>
-              <a:rPr sz="2475" b="0">
-                <a:solidFill>
-                  <a:srgbClr val="183247"/>
-                </a:solidFill>
-                <a:latin typeface="Arial"/>
-                <a:ea typeface="Arial"/>
-                <a:cs typeface="Arial"/>
-              </a:rPr>
-              <a:t>Pagina 6</a:t>
-            </a:r>
-          </a:p>
-          <a:p xmlns:a="http://schemas.openxmlformats.org/drawingml/2006/main">
-            <a:pPr algn="l">
-              <a:defRPr sz="2475" b="0">
-                <a:solidFill>
-                  <a:srgbClr val="183247"/>
-                </a:solidFill>
-                <a:latin typeface="Arial"/>
-                <a:ea typeface="Arial"/>
-                <a:cs typeface="Arial"/>
-              </a:defRPr>
-            </a:pPr>
-            <a:r>
-              <a:rPr sz="2475" b="0">
-                <a:solidFill>
-                  <a:srgbClr val="183247"/>
-                </a:solidFill>
-                <a:latin typeface="Arial"/>
-                <a:ea typeface="Arial"/>
-                <a:cs typeface="Arial"/>
-              </a:rPr>
-              <a:t>Opgaven 1 en 2</a:t>
+              <a:defRPr sz="2250" b="0">
+                <a:solidFill>
+                  <a:srgbClr val="183247"/>
+                </a:solidFill>
+                <a:latin typeface="Arial"/>
+                <a:ea typeface="Arial"/>
+                <a:cs typeface="Arial"/>
+              </a:defRPr>
+            </a:pPr>
+            <a:r>
+              <a:rPr sz="2250" b="0">
+                <a:solidFill>
+                  <a:srgbClr val="183247"/>
+                </a:solidFill>
+                <a:latin typeface="Arial"/>
+                <a:ea typeface="Arial"/>
+                <a:cs typeface="Arial"/>
+              </a:rPr>
+              <a:t>Pagina 6 · Opgaven 1 en 2</a:t>
+            </a:r>
+          </a:p>
+          <a:p xmlns:a="http://schemas.openxmlformats.org/drawingml/2006/main">
+            <a:pPr algn="l">
+              <a:defRPr sz="2250" b="0">
+                <a:solidFill>
+                  <a:srgbClr val="183247"/>
+                </a:solidFill>
+                <a:latin typeface="Arial"/>
+                <a:ea typeface="Arial"/>
+                <a:cs typeface="Arial"/>
+              </a:defRPr>
+            </a:pPr>
+            <a:r>
+              <a:rPr sz="2250" b="0">
+                <a:solidFill>
+                  <a:srgbClr val="183247"/>
+                </a:solidFill>
+                <a:latin typeface="Arial"/>
+                <a:ea typeface="Arial"/>
+                <a:cs typeface="Arial"/>
+              </a:rPr>
+              <a:t>2: verkennen, theorie p. 2–4</a:t>
             </a:r>
           </a:p>
         </p:txBody>
@@ -18252,7 +18288,7 @@
           <p:cNvPr id="26" name="">
             <a:extLst xmlns:a="http://schemas.openxmlformats.org/drawingml/2006/main">
               <a:ext uri="{FF2B5EF4-FFF2-40B4-BE49-F238E27FC236}">
-                <a16:creationId xmlns:a16="http://schemas.microsoft.com/office/drawing/2014/main" id="{A00ED713-89A0-44BD-BABC-F4FA50C47617}"/>
+                <a16:creationId xmlns:a16="http://schemas.microsoft.com/office/drawing/2014/main" id="{75E851B4-FEE1-450A-A774-C1B268989D9B}"/>
               </a:ext>
             </a:extLst>
           </p:cNvPr>
@@ -18281,7 +18317,7 @@
           <p:cNvPr id="27" name="Huiswerk">
             <a:extLst xmlns:a="http://schemas.openxmlformats.org/drawingml/2006/main">
               <a:ext uri="{FF2B5EF4-FFF2-40B4-BE49-F238E27FC236}">
-                <a16:creationId xmlns:a16="http://schemas.microsoft.com/office/drawing/2014/main" id="{B5A2CFE5-B6E8-416D-9129-CA9FAC2A2620}"/>
+                <a16:creationId xmlns:a16="http://schemas.microsoft.com/office/drawing/2014/main" id="{735E54F7-FB67-4F1B-A5E5-4357A099E77B}"/>
               </a:ext>
             </a:extLst>
           </p:cNvPr>
@@ -18338,7 +18374,7 @@
           <p:cNvPr id="28" name="overview-homework">
             <a:extLst xmlns:a="http://schemas.openxmlformats.org/drawingml/2006/main">
               <a:ext uri="{FF2B5EF4-FFF2-40B4-BE49-F238E27FC236}">
-                <a16:creationId xmlns:a16="http://schemas.microsoft.com/office/drawing/2014/main" id="{D9301EAE-9CC4-4E06-B389-C6E347D24CAB}"/>
+                <a16:creationId xmlns:a16="http://schemas.microsoft.com/office/drawing/2014/main" id="{23B2F2AC-9C0C-4299-8A90-F37B9403E928}"/>
               </a:ext>
             </a:extLst>
           </p:cNvPr>
@@ -18485,7 +18521,7 @@
     </p:spTree>
     <p:extLst>
       <p:ext uri="{BB962C8B-B14F-4D97-AF65-F5344CB8AC3E}">
-        <p14:creationId xmlns:p14="http://schemas.microsoft.com/office/powerpoint/2010/main" val="320027801"/>
+        <p14:creationId xmlns:p14="http://schemas.microsoft.com/office/powerpoint/2010/main" val="105814414"/>
       </p:ext>
     </p:extLst>
   </p:cSld>
@@ -18516,7 +18552,7 @@
           <p:cNvPr id="8" name="Constante en variabele kosten">
             <a:extLst xmlns:a="http://schemas.openxmlformats.org/drawingml/2006/main">
               <a:ext uri="{FF2B5EF4-FFF2-40B4-BE49-F238E27FC236}">
-                <a16:creationId xmlns:a16="http://schemas.microsoft.com/office/drawing/2014/main" id="{32776765-06B3-468D-8857-494367C45520}"/>
+                <a16:creationId xmlns:a16="http://schemas.microsoft.com/office/drawing/2014/main" id="{CAFC1600-0CDD-49D1-9CB5-0DCD08CD80FD}"/>
               </a:ext>
             </a:extLst>
           </p:cNvPr>
@@ -18573,7 +18609,7 @@
           <p:cNvPr id="2" name="">
             <a:extLst xmlns:a="http://schemas.openxmlformats.org/drawingml/2006/main">
               <a:ext uri="{FF2B5EF4-FFF2-40B4-BE49-F238E27FC236}">
-                <a16:creationId xmlns:a16="http://schemas.microsoft.com/office/drawing/2014/main" id="{93E8B6AC-7138-45ED-B69C-10DC0F221D43}"/>
+                <a16:creationId xmlns:a16="http://schemas.microsoft.com/office/drawing/2014/main" id="{15DC26F2-94DF-4496-90E2-0053E5852672}"/>
               </a:ext>
             </a:extLst>
           </p:cNvPr>
@@ -18602,7 +18638,7 @@
           <p:cNvPr id="3" name="§2.1.1 Kostenstructuren">
             <a:extLst xmlns:a="http://schemas.openxmlformats.org/drawingml/2006/main">
               <a:ext uri="{FF2B5EF4-FFF2-40B4-BE49-F238E27FC236}">
-                <a16:creationId xmlns:a16="http://schemas.microsoft.com/office/drawing/2014/main" id="{3BEE0129-58AB-4853-B23E-5125C004D4F0}"/>
+                <a16:creationId xmlns:a16="http://schemas.microsoft.com/office/drawing/2014/main" id="{B767EC35-4A5A-4163-80CC-65527E583788}"/>
               </a:ext>
             </a:extLst>
           </p:cNvPr>
@@ -18659,7 +18695,7 @@
           <p:cNvPr id="4" name="3">
             <a:extLst xmlns:a="http://schemas.openxmlformats.org/drawingml/2006/main">
               <a:ext uri="{FF2B5EF4-FFF2-40B4-BE49-F238E27FC236}">
-                <a16:creationId xmlns:a16="http://schemas.microsoft.com/office/drawing/2014/main" id="{98F89560-8D9C-47A5-AE57-2B28A8FA8FEE}"/>
+                <a16:creationId xmlns:a16="http://schemas.microsoft.com/office/drawing/2014/main" id="{87CD305C-35C8-4FAE-9C45-EC625F8243AD}"/>
               </a:ext>
             </a:extLst>
           </p:cNvPr>
@@ -18716,7 +18752,7 @@
           <p:cNvPr id="5" name="Fles &amp; Co: dezelfde maand, maximaal 600 flessen">
             <a:extLst xmlns:a="http://schemas.openxmlformats.org/drawingml/2006/main">
               <a:ext uri="{FF2B5EF4-FFF2-40B4-BE49-F238E27FC236}">
-                <a16:creationId xmlns:a16="http://schemas.microsoft.com/office/drawing/2014/main" id="{D56F9923-AD12-41FE-8080-E8054DEC8C3A}"/>
+                <a16:creationId xmlns:a16="http://schemas.microsoft.com/office/drawing/2014/main" id="{CC6E20BE-D4E7-43AC-85EC-0660A9171E3B}"/>
               </a:ext>
             </a:extLst>
           </p:cNvPr>
@@ -19091,7 +19127,7 @@
           <p:cNvPr id="7" name="De indeling hangt af van het totale bedrag als Q v">
             <a:extLst xmlns:a="http://schemas.openxmlformats.org/drawingml/2006/main">
               <a:ext uri="{FF2B5EF4-FFF2-40B4-BE49-F238E27FC236}">
-                <a16:creationId xmlns:a16="http://schemas.microsoft.com/office/drawing/2014/main" id="{678453DD-DC35-4EBC-9361-7B956952C5B3}"/>
+                <a16:creationId xmlns:a16="http://schemas.microsoft.com/office/drawing/2014/main" id="{8A6A207A-A822-4506-B71C-5D9F4B669D80}"/>
               </a:ext>
             </a:extLst>
           </p:cNvPr>
@@ -19146,7 +19182,7 @@
     </p:spTree>
     <p:extLst>
       <p:ext uri="{BB962C8B-B14F-4D97-AF65-F5344CB8AC3E}">
-        <p14:creationId xmlns:p14="http://schemas.microsoft.com/office/powerpoint/2010/main" val="862146424"/>
+        <p14:creationId xmlns:p14="http://schemas.microsoft.com/office/powerpoint/2010/main" val="1793110814"/>
       </p:ext>
     </p:extLst>
   </p:cSld>
@@ -19177,7 +19213,7 @@
           <p:cNvPr id="16" name="Van kostenpost naar kostenfunctie">
             <a:extLst xmlns:a="http://schemas.openxmlformats.org/drawingml/2006/main">
               <a:ext uri="{FF2B5EF4-FFF2-40B4-BE49-F238E27FC236}">
-                <a16:creationId xmlns:a16="http://schemas.microsoft.com/office/drawing/2014/main" id="{F70992EE-4F5D-4404-A326-7498994D789C}"/>
+                <a16:creationId xmlns:a16="http://schemas.microsoft.com/office/drawing/2014/main" id="{7A32DC86-8FC3-4BBE-953F-00D1CD81D9D8}"/>
               </a:ext>
             </a:extLst>
           </p:cNvPr>
@@ -19234,7 +19270,7 @@
           <p:cNvPr id="2" name="">
             <a:extLst xmlns:a="http://schemas.openxmlformats.org/drawingml/2006/main">
               <a:ext uri="{FF2B5EF4-FFF2-40B4-BE49-F238E27FC236}">
-                <a16:creationId xmlns:a16="http://schemas.microsoft.com/office/drawing/2014/main" id="{9380A957-5CD1-44BC-8DA3-F18CF417FE56}"/>
+                <a16:creationId xmlns:a16="http://schemas.microsoft.com/office/drawing/2014/main" id="{F06B26EE-B591-409E-BEA7-5097832ECCF8}"/>
               </a:ext>
             </a:extLst>
           </p:cNvPr>
@@ -19263,7 +19299,7 @@
           <p:cNvPr id="3" name="§2.1.1 Kostenstructuren">
             <a:extLst xmlns:a="http://schemas.openxmlformats.org/drawingml/2006/main">
               <a:ext uri="{FF2B5EF4-FFF2-40B4-BE49-F238E27FC236}">
-                <a16:creationId xmlns:a16="http://schemas.microsoft.com/office/drawing/2014/main" id="{5D530B08-4BBE-4630-87AC-044A0FA036E7}"/>
+                <a16:creationId xmlns:a16="http://schemas.microsoft.com/office/drawing/2014/main" id="{62B81634-0637-4722-A326-8E0CABE6733E}"/>
               </a:ext>
             </a:extLst>
           </p:cNvPr>
@@ -19320,7 +19356,7 @@
           <p:cNvPr id="4" name="4">
             <a:extLst xmlns:a="http://schemas.openxmlformats.org/drawingml/2006/main">
               <a:ext uri="{FF2B5EF4-FFF2-40B4-BE49-F238E27FC236}">
-                <a16:creationId xmlns:a16="http://schemas.microsoft.com/office/drawing/2014/main" id="{2F8E9B4D-0D82-4476-BCA3-F2E75FC622F9}"/>
+                <a16:creationId xmlns:a16="http://schemas.microsoft.com/office/drawing/2014/main" id="{6DBD8239-9458-43D6-9CAD-CCAABDEF5F3D}"/>
               </a:ext>
             </a:extLst>
           </p:cNvPr>
@@ -19377,7 +19413,7 @@
           <p:cNvPr id="5" name="Q = aantal flessen per maand">
             <a:extLst xmlns:a="http://schemas.openxmlformats.org/drawingml/2006/main">
               <a:ext uri="{FF2B5EF4-FFF2-40B4-BE49-F238E27FC236}">
-                <a16:creationId xmlns:a16="http://schemas.microsoft.com/office/drawing/2014/main" id="{563948DD-6036-4621-9BA4-841B133BAA4F}"/>
+                <a16:creationId xmlns:a16="http://schemas.microsoft.com/office/drawing/2014/main" id="{E0100A8A-A892-47C1-BDFB-2018FD1FEE6C}"/>
               </a:ext>
             </a:extLst>
           </p:cNvPr>
@@ -19434,7 +19470,7 @@
           <p:cNvPr id="6" name="Totale constante kosten">
             <a:extLst xmlns:a="http://schemas.openxmlformats.org/drawingml/2006/main">
               <a:ext uri="{FF2B5EF4-FFF2-40B4-BE49-F238E27FC236}">
-                <a16:creationId xmlns:a16="http://schemas.microsoft.com/office/drawing/2014/main" id="{D9D18AA5-3B3D-4CD0-B7C3-1C0C801573C5}"/>
+                <a16:creationId xmlns:a16="http://schemas.microsoft.com/office/drawing/2014/main" id="{BF748C86-9C23-4296-98F7-59E96260E71B}"/>
               </a:ext>
             </a:extLst>
           </p:cNvPr>
@@ -19491,7 +19527,7 @@
           <p:cNvPr id="7" name="TCK = 300">
             <a:extLst xmlns:a="http://schemas.openxmlformats.org/drawingml/2006/main">
               <a:ext uri="{FF2B5EF4-FFF2-40B4-BE49-F238E27FC236}">
-                <a16:creationId xmlns:a16="http://schemas.microsoft.com/office/drawing/2014/main" id="{93284734-480F-4342-8077-9A3DC1BA9A07}"/>
+                <a16:creationId xmlns:a16="http://schemas.microsoft.com/office/drawing/2014/main" id="{057CBF57-964E-4CC3-9D6E-63776FFA8864}"/>
               </a:ext>
             </a:extLst>
           </p:cNvPr>
@@ -19548,7 +19584,7 @@
           <p:cNvPr id="8" name="">
             <a:extLst xmlns:a="http://schemas.openxmlformats.org/drawingml/2006/main">
               <a:ext uri="{FF2B5EF4-FFF2-40B4-BE49-F238E27FC236}">
-                <a16:creationId xmlns:a16="http://schemas.microsoft.com/office/drawing/2014/main" id="{58E54B71-1501-4FFE-916B-9553A9194C77}"/>
+                <a16:creationId xmlns:a16="http://schemas.microsoft.com/office/drawing/2014/main" id="{B38898FB-1E8A-4505-A01F-EE986EC55244}"/>
               </a:ext>
             </a:extLst>
           </p:cNvPr>
@@ -19577,7 +19613,7 @@
           <p:cNvPr id="9" name="Totale variabele kosten">
             <a:extLst xmlns:a="http://schemas.openxmlformats.org/drawingml/2006/main">
               <a:ext uri="{FF2B5EF4-FFF2-40B4-BE49-F238E27FC236}">
-                <a16:creationId xmlns:a16="http://schemas.microsoft.com/office/drawing/2014/main" id="{AFC855CA-05B3-4051-918B-1074F8C3614A}"/>
+                <a16:creationId xmlns:a16="http://schemas.microsoft.com/office/drawing/2014/main" id="{01ED2E4D-F81A-47ED-A5AA-7B65A43CEC0C}"/>
               </a:ext>
             </a:extLst>
           </p:cNvPr>
@@ -19634,7 +19670,7 @@
           <p:cNvPr id="10" name="TVK = 2 × Q = 2Q">
             <a:extLst xmlns:a="http://schemas.openxmlformats.org/drawingml/2006/main">
               <a:ext uri="{FF2B5EF4-FFF2-40B4-BE49-F238E27FC236}">
-                <a16:creationId xmlns:a16="http://schemas.microsoft.com/office/drawing/2014/main" id="{EEDB1F48-1C5E-4E69-B95E-944ACD7367B9}"/>
+                <a16:creationId xmlns:a16="http://schemas.microsoft.com/office/drawing/2014/main" id="{74EFB1C3-DED0-4414-A1E3-884135B2EEC5}"/>
               </a:ext>
             </a:extLst>
           </p:cNvPr>
@@ -19691,7 +19727,7 @@
           <p:cNvPr id="11" name="">
             <a:extLst xmlns:a="http://schemas.openxmlformats.org/drawingml/2006/main">
               <a:ext uri="{FF2B5EF4-FFF2-40B4-BE49-F238E27FC236}">
-                <a16:creationId xmlns:a16="http://schemas.microsoft.com/office/drawing/2014/main" id="{E5948DEA-1E96-4BEF-B424-2299AA8D43E3}"/>
+                <a16:creationId xmlns:a16="http://schemas.microsoft.com/office/drawing/2014/main" id="{705AC4C3-7169-4757-B771-821F52C862F0}"/>
               </a:ext>
             </a:extLst>
           </p:cNvPr>
@@ -19720,7 +19756,7 @@
           <p:cNvPr id="12" name="Totale kosten">
             <a:extLst xmlns:a="http://schemas.openxmlformats.org/drawingml/2006/main">
               <a:ext uri="{FF2B5EF4-FFF2-40B4-BE49-F238E27FC236}">
-                <a16:creationId xmlns:a16="http://schemas.microsoft.com/office/drawing/2014/main" id="{35FCA3DA-D9D2-4450-BF0C-7D68BE84DD75}"/>
+                <a16:creationId xmlns:a16="http://schemas.microsoft.com/office/drawing/2014/main" id="{4265E28F-3092-4F60-9317-D50DF6CDA212}"/>
               </a:ext>
             </a:extLst>
           </p:cNvPr>
@@ -19777,7 +19813,7 @@
           <p:cNvPr id="13" name="TK = TCK + TVK = 300 + 2Q">
             <a:extLst xmlns:a="http://schemas.openxmlformats.org/drawingml/2006/main">
               <a:ext uri="{FF2B5EF4-FFF2-40B4-BE49-F238E27FC236}">
-                <a16:creationId xmlns:a16="http://schemas.microsoft.com/office/drawing/2014/main" id="{1389C1D8-F3FA-4285-9289-5C00C4C8A44C}"/>
+                <a16:creationId xmlns:a16="http://schemas.microsoft.com/office/drawing/2014/main" id="{19F6B2F7-1CF4-4653-8769-57D70BFAD33A}"/>
               </a:ext>
             </a:extLst>
           </p:cNvPr>
@@ -19834,7 +19870,7 @@
           <p:cNvPr id="14" name="">
             <a:extLst xmlns:a="http://schemas.openxmlformats.org/drawingml/2006/main">
               <a:ext uri="{FF2B5EF4-FFF2-40B4-BE49-F238E27FC236}">
-                <a16:creationId xmlns:a16="http://schemas.microsoft.com/office/drawing/2014/main" id="{5CBA1394-F20B-4447-875F-5E921BAE3693}"/>
+                <a16:creationId xmlns:a16="http://schemas.microsoft.com/office/drawing/2014/main" id="{0D500602-270D-4B1B-A735-58B79951A505}"/>
               </a:ext>
             </a:extLst>
           </p:cNvPr>
@@ -19863,7 +19899,7 @@
           <p:cNvPr id="15" name="Totaal: € per maand">
             <a:extLst xmlns:a="http://schemas.openxmlformats.org/drawingml/2006/main">
               <a:ext uri="{FF2B5EF4-FFF2-40B4-BE49-F238E27FC236}">
-                <a16:creationId xmlns:a16="http://schemas.microsoft.com/office/drawing/2014/main" id="{87731DED-AE21-492F-A0D3-6145AC315DDA}"/>
+                <a16:creationId xmlns:a16="http://schemas.microsoft.com/office/drawing/2014/main" id="{1BFC65D5-5A15-4EF6-9EB4-3CDCC5811D54}"/>
               </a:ext>
             </a:extLst>
           </p:cNvPr>
@@ -19918,7 +19954,7 @@
     </p:spTree>
     <p:extLst>
       <p:ext uri="{BB962C8B-B14F-4D97-AF65-F5344CB8AC3E}">
-        <p14:creationId xmlns:p14="http://schemas.microsoft.com/office/powerpoint/2010/main" val="1302203464"/>
+        <p14:creationId xmlns:p14="http://schemas.microsoft.com/office/powerpoint/2010/main" val="1918558136"/>
       </p:ext>
     </p:extLst>
   </p:cSld>
@@ -19949,7 +19985,7 @@
           <p:cNvPr id="10" name="Kosten in een grafiek">
             <a:extLst xmlns:a="http://schemas.openxmlformats.org/drawingml/2006/main">
               <a:ext uri="{FF2B5EF4-FFF2-40B4-BE49-F238E27FC236}">
-                <a16:creationId xmlns:a16="http://schemas.microsoft.com/office/drawing/2014/main" id="{72A79F98-2CF8-45A3-8249-6A476058B10F}"/>
+                <a16:creationId xmlns:a16="http://schemas.microsoft.com/office/drawing/2014/main" id="{351B373B-015F-4B14-852B-CB9AE49D470D}"/>
               </a:ext>
             </a:extLst>
           </p:cNvPr>
@@ -20006,7 +20042,7 @@
           <p:cNvPr id="2" name="">
             <a:extLst xmlns:a="http://schemas.openxmlformats.org/drawingml/2006/main">
               <a:ext uri="{FF2B5EF4-FFF2-40B4-BE49-F238E27FC236}">
-                <a16:creationId xmlns:a16="http://schemas.microsoft.com/office/drawing/2014/main" id="{122223D0-479A-4B16-9812-69CBA15FD4DD}"/>
+                <a16:creationId xmlns:a16="http://schemas.microsoft.com/office/drawing/2014/main" id="{F34E5139-EA77-4213-969F-3EB2B294B763}"/>
               </a:ext>
             </a:extLst>
           </p:cNvPr>
@@ -20035,7 +20071,7 @@
           <p:cNvPr id="3" name="§2.1.1 Kostenstructuren">
             <a:extLst xmlns:a="http://schemas.openxmlformats.org/drawingml/2006/main">
               <a:ext uri="{FF2B5EF4-FFF2-40B4-BE49-F238E27FC236}">
-                <a16:creationId xmlns:a16="http://schemas.microsoft.com/office/drawing/2014/main" id="{3CCB35DA-246E-46F5-8680-702565DBC489}"/>
+                <a16:creationId xmlns:a16="http://schemas.microsoft.com/office/drawing/2014/main" id="{0A064C45-BD53-475F-80F8-3315D21BE899}"/>
               </a:ext>
             </a:extLst>
           </p:cNvPr>
@@ -20092,7 +20128,7 @@
           <p:cNvPr id="4" name="5">
             <a:extLst xmlns:a="http://schemas.openxmlformats.org/drawingml/2006/main">
               <a:ext uri="{FF2B5EF4-FFF2-40B4-BE49-F238E27FC236}">
-                <a16:creationId xmlns:a16="http://schemas.microsoft.com/office/drawing/2014/main" id="{804F7302-B1D8-4307-9694-B964348A986C}"/>
+                <a16:creationId xmlns:a16="http://schemas.microsoft.com/office/drawing/2014/main" id="{33CA0175-3741-4C43-8934-E7F424E32377}"/>
               </a:ext>
             </a:extLst>
           </p:cNvPr>
@@ -20149,7 +20185,7 @@
           <p:cNvPr id="5" name="Fles &amp; Co">
             <a:extLst xmlns:a="http://schemas.openxmlformats.org/drawingml/2006/main">
               <a:ext uri="{FF2B5EF4-FFF2-40B4-BE49-F238E27FC236}">
-                <a16:creationId xmlns:a16="http://schemas.microsoft.com/office/drawing/2014/main" id="{737750BA-9733-46D4-AB61-E5F4E16AD98F}"/>
+                <a16:creationId xmlns:a16="http://schemas.microsoft.com/office/drawing/2014/main" id="{34FDEC38-913B-4790-BFF6-66BA01B34E50}"/>
               </a:ext>
             </a:extLst>
           </p:cNvPr>
@@ -20213,7 +20249,7 @@
         </p:xfrm>
         <a:graphic xmlns:a="http://schemas.openxmlformats.org/drawingml/2006/main">
           <a:graphicData uri="http://schemas.openxmlformats.org/drawingml/2006/chart">
-            <c:chart xmlns:r="http://schemas.openxmlformats.org/officeDocument/2006/relationships" xmlns:c="http://schemas.openxmlformats.org/drawingml/2006/chart" r:id="R7dc39b37d8154184"/>
+            <c:chart xmlns:r="http://schemas.openxmlformats.org/officeDocument/2006/relationships" xmlns:c="http://schemas.openxmlformats.org/drawingml/2006/chart" r:id="Rda890c528dc749b0"/>
           </a:graphicData>
         </a:graphic>
       </p:graphicFrame>
@@ -20222,7 +20258,7 @@
           <p:cNvPr id="7" name="Wat zie je?">
             <a:extLst xmlns:a="http://schemas.openxmlformats.org/drawingml/2006/main">
               <a:ext uri="{FF2B5EF4-FFF2-40B4-BE49-F238E27FC236}">
-                <a16:creationId xmlns:a16="http://schemas.microsoft.com/office/drawing/2014/main" id="{EBF8D8A2-F423-4C96-84A9-84C87BCE0A5A}"/>
+                <a16:creationId xmlns:a16="http://schemas.microsoft.com/office/drawing/2014/main" id="{966DE7A7-BB51-4C15-800E-0B92A0B9B637}"/>
               </a:ext>
             </a:extLst>
           </p:cNvPr>
@@ -20279,7 +20315,7 @@
           <p:cNvPr id="8" name="TCK: horizontaal&#10;&#10;TVK: vanaf nul">
             <a:extLst xmlns:a="http://schemas.openxmlformats.org/drawingml/2006/main">
               <a:ext uri="{FF2B5EF4-FFF2-40B4-BE49-F238E27FC236}">
-                <a16:creationId xmlns:a16="http://schemas.microsoft.com/office/drawing/2014/main" id="{CE339FDE-C4FC-4916-83CD-2B7156B946CA}"/>
+                <a16:creationId xmlns:a16="http://schemas.microsoft.com/office/drawing/2014/main" id="{3E6A42CB-938F-4878-B293-11EA34EBC89F}"/>
               </a:ext>
             </a:extLst>
           </p:cNvPr>
@@ -20364,7 +20400,7 @@
           <p:cNvPr id="9" name="Elke extra fles&#10;kost € 2 materiaal.">
             <a:extLst xmlns:a="http://schemas.openxmlformats.org/drawingml/2006/main">
               <a:ext uri="{FF2B5EF4-FFF2-40B4-BE49-F238E27FC236}">
-                <a16:creationId xmlns:a16="http://schemas.microsoft.com/office/drawing/2014/main" id="{2E567668-4A37-48C1-BF0C-E0F351187286}"/>
+                <a16:creationId xmlns:a16="http://schemas.microsoft.com/office/drawing/2014/main" id="{7ED37963-0E91-4350-BFCC-C30418DD1426}"/>
               </a:ext>
             </a:extLst>
           </p:cNvPr>
@@ -20442,7 +20478,7 @@
     </p:spTree>
     <p:extLst>
       <p:ext uri="{BB962C8B-B14F-4D97-AF65-F5344CB8AC3E}">
-        <p14:creationId xmlns:p14="http://schemas.microsoft.com/office/powerpoint/2010/main" val="1621866555"/>
+        <p14:creationId xmlns:p14="http://schemas.microsoft.com/office/powerpoint/2010/main" val="2009163742"/>
       </p:ext>
     </p:extLst>
   </p:cSld>
@@ -20473,7 +20509,7 @@
           <p:cNvPr id="10" name="Totale kosten zijn de som van beide">
             <a:extLst xmlns:a="http://schemas.openxmlformats.org/drawingml/2006/main">
               <a:ext uri="{FF2B5EF4-FFF2-40B4-BE49-F238E27FC236}">
-                <a16:creationId xmlns:a16="http://schemas.microsoft.com/office/drawing/2014/main" id="{F8B2C821-940A-4865-BF46-C5FD9913815C}"/>
+                <a16:creationId xmlns:a16="http://schemas.microsoft.com/office/drawing/2014/main" id="{3A2CE1ED-2C80-4649-B56A-1F963E982446}"/>
               </a:ext>
             </a:extLst>
           </p:cNvPr>
@@ -20530,7 +20566,7 @@
           <p:cNvPr id="2" name="">
             <a:extLst xmlns:a="http://schemas.openxmlformats.org/drawingml/2006/main">
               <a:ext uri="{FF2B5EF4-FFF2-40B4-BE49-F238E27FC236}">
-                <a16:creationId xmlns:a16="http://schemas.microsoft.com/office/drawing/2014/main" id="{55DBACBF-EE06-4F8D-BA35-617A193FC925}"/>
+                <a16:creationId xmlns:a16="http://schemas.microsoft.com/office/drawing/2014/main" id="{BB667F5E-444B-4A43-851D-871189F2B05C}"/>
               </a:ext>
             </a:extLst>
           </p:cNvPr>
@@ -20559,7 +20595,7 @@
           <p:cNvPr id="3" name="§2.1.1 Kostenstructuren">
             <a:extLst xmlns:a="http://schemas.openxmlformats.org/drawingml/2006/main">
               <a:ext uri="{FF2B5EF4-FFF2-40B4-BE49-F238E27FC236}">
-                <a16:creationId xmlns:a16="http://schemas.microsoft.com/office/drawing/2014/main" id="{B1DCD3F3-FA01-4B8E-B59C-6A54C5FEF202}"/>
+                <a16:creationId xmlns:a16="http://schemas.microsoft.com/office/drawing/2014/main" id="{756A2555-EBCE-4FBA-AB5F-222BBEFC0C3B}"/>
               </a:ext>
             </a:extLst>
           </p:cNvPr>
@@ -20616,7 +20652,7 @@
           <p:cNvPr id="4" name="6">
             <a:extLst xmlns:a="http://schemas.openxmlformats.org/drawingml/2006/main">
               <a:ext uri="{FF2B5EF4-FFF2-40B4-BE49-F238E27FC236}">
-                <a16:creationId xmlns:a16="http://schemas.microsoft.com/office/drawing/2014/main" id="{D77E3C6D-5C5A-4FF9-BE17-2B7380DBEF49}"/>
+                <a16:creationId xmlns:a16="http://schemas.microsoft.com/office/drawing/2014/main" id="{E14F694C-848F-41C1-B7A4-64485775B894}"/>
               </a:ext>
             </a:extLst>
           </p:cNvPr>
@@ -20673,7 +20709,7 @@
           <p:cNvPr id="5" name="Fles &amp; Co">
             <a:extLst xmlns:a="http://schemas.openxmlformats.org/drawingml/2006/main">
               <a:ext uri="{FF2B5EF4-FFF2-40B4-BE49-F238E27FC236}">
-                <a16:creationId xmlns:a16="http://schemas.microsoft.com/office/drawing/2014/main" id="{D173B3F2-A6C5-4DCC-8B43-9E4794479CEE}"/>
+                <a16:creationId xmlns:a16="http://schemas.microsoft.com/office/drawing/2014/main" id="{9AAB12B8-A316-4D01-B5EF-25578134E41C}"/>
               </a:ext>
             </a:extLst>
           </p:cNvPr>
@@ -20737,7 +20773,7 @@
         </p:xfrm>
         <a:graphic xmlns:a="http://schemas.openxmlformats.org/drawingml/2006/main">
           <a:graphicData uri="http://schemas.openxmlformats.org/drawingml/2006/chart">
-            <c:chart xmlns:r="http://schemas.openxmlformats.org/officeDocument/2006/relationships" xmlns:c="http://schemas.openxmlformats.org/drawingml/2006/chart" r:id="R41ece709f0414556"/>
+            <c:chart xmlns:r="http://schemas.openxmlformats.org/officeDocument/2006/relationships" xmlns:c="http://schemas.openxmlformats.org/drawingml/2006/chart" r:id="R37134fedf7f2478d"/>
           </a:graphicData>
         </a:graphic>
       </p:graphicFrame>
@@ -20746,7 +20782,7 @@
           <p:cNvPr id="7" name="Bij Q = 400">
             <a:extLst xmlns:a="http://schemas.openxmlformats.org/drawingml/2006/main">
               <a:ext uri="{FF2B5EF4-FFF2-40B4-BE49-F238E27FC236}">
-                <a16:creationId xmlns:a16="http://schemas.microsoft.com/office/drawing/2014/main" id="{8D484C0B-3D3E-4F40-955A-E89EF000A124}"/>
+                <a16:creationId xmlns:a16="http://schemas.microsoft.com/office/drawing/2014/main" id="{4903B666-5DFA-4341-BA13-74E8E672958A}"/>
               </a:ext>
             </a:extLst>
           </p:cNvPr>
@@ -20803,7 +20839,7 @@
           <p:cNvPr id="8" name="TVK = € 800&#10;TCK = € 300&#10;TK = € 1.100">
             <a:extLst xmlns:a="http://schemas.openxmlformats.org/drawingml/2006/main">
               <a:ext uri="{FF2B5EF4-FFF2-40B4-BE49-F238E27FC236}">
-                <a16:creationId xmlns:a16="http://schemas.microsoft.com/office/drawing/2014/main" id="{866923F4-CD9A-4D56-995A-2166270FC618}"/>
+                <a16:creationId xmlns:a16="http://schemas.microsoft.com/office/drawing/2014/main" id="{7FC1E488-ABD0-47B2-8B83-B352104DA6E8}"/>
               </a:ext>
             </a:extLst>
           </p:cNvPr>
@@ -20906,7 +20942,7 @@
           <p:cNvPr id="9" name="Het verschil tussen&#10;TK en TVK is&#10;steeds € 300.">
             <a:extLst xmlns:a="http://schemas.openxmlformats.org/drawingml/2006/main">
               <a:ext uri="{FF2B5EF4-FFF2-40B4-BE49-F238E27FC236}">
-                <a16:creationId xmlns:a16="http://schemas.microsoft.com/office/drawing/2014/main" id="{C3870A9B-F785-46C4-982F-F02428335F1C}"/>
+                <a16:creationId xmlns:a16="http://schemas.microsoft.com/office/drawing/2014/main" id="{346CBBD9-F320-4011-B0D7-83DA379518BF}"/>
               </a:ext>
             </a:extLst>
           </p:cNvPr>
@@ -21007,7 +21043,7 @@
     </p:spTree>
     <p:extLst>
       <p:ext uri="{BB962C8B-B14F-4D97-AF65-F5344CB8AC3E}">
-        <p14:creationId xmlns:p14="http://schemas.microsoft.com/office/powerpoint/2010/main" val="612427283"/>
+        <p14:creationId xmlns:p14="http://schemas.microsoft.com/office/powerpoint/2010/main" val="360857120"/>
       </p:ext>
     </p:extLst>
   </p:cSld>
@@ -21038,7 +21074,7 @@
           <p:cNvPr id="9" name="Gemiddelde kosten: het bedrag per product">
             <a:extLst xmlns:a="http://schemas.openxmlformats.org/drawingml/2006/main">
               <a:ext uri="{FF2B5EF4-FFF2-40B4-BE49-F238E27FC236}">
-                <a16:creationId xmlns:a16="http://schemas.microsoft.com/office/drawing/2014/main" id="{BBFBBEE6-A7A3-49E4-82C3-4EA1FDB4DFB8}"/>
+                <a16:creationId xmlns:a16="http://schemas.microsoft.com/office/drawing/2014/main" id="{97E494D7-F8F1-49FC-A8BD-D2391AE2CD41}"/>
               </a:ext>
             </a:extLst>
           </p:cNvPr>
@@ -21095,7 +21131,7 @@
           <p:cNvPr id="2" name="">
             <a:extLst xmlns:a="http://schemas.openxmlformats.org/drawingml/2006/main">
               <a:ext uri="{FF2B5EF4-FFF2-40B4-BE49-F238E27FC236}">
-                <a16:creationId xmlns:a16="http://schemas.microsoft.com/office/drawing/2014/main" id="{09E4F484-180C-473D-9978-ABE1E1D63ED3}"/>
+                <a16:creationId xmlns:a16="http://schemas.microsoft.com/office/drawing/2014/main" id="{218B6C52-9453-4E65-976A-EB90815A48AE}"/>
               </a:ext>
             </a:extLst>
           </p:cNvPr>
@@ -21124,7 +21160,7 @@
           <p:cNvPr id="3" name="§2.1.1 Kostenstructuren">
             <a:extLst xmlns:a="http://schemas.openxmlformats.org/drawingml/2006/main">
               <a:ext uri="{FF2B5EF4-FFF2-40B4-BE49-F238E27FC236}">
-                <a16:creationId xmlns:a16="http://schemas.microsoft.com/office/drawing/2014/main" id="{9EF3CC1A-C680-4F88-90F1-73F680C9C6B0}"/>
+                <a16:creationId xmlns:a16="http://schemas.microsoft.com/office/drawing/2014/main" id="{672F6320-9A05-4BBF-B257-A99A5F83FB2C}"/>
               </a:ext>
             </a:extLst>
           </p:cNvPr>
@@ -21181,7 +21217,7 @@
           <p:cNvPr id="4" name="7">
             <a:extLst xmlns:a="http://schemas.openxmlformats.org/drawingml/2006/main">
               <a:ext uri="{FF2B5EF4-FFF2-40B4-BE49-F238E27FC236}">
-                <a16:creationId xmlns:a16="http://schemas.microsoft.com/office/drawing/2014/main" id="{F62D81AA-E652-4EF3-8A97-912E3D739DAF}"/>
+                <a16:creationId xmlns:a16="http://schemas.microsoft.com/office/drawing/2014/main" id="{5FB978E2-AD5A-49D1-84E8-40E66AE17DFC}"/>
               </a:ext>
             </a:extLst>
           </p:cNvPr>
@@ -21238,7 +21274,7 @@
           <p:cNvPr id="5" name="Gemiddeld = het bijbehorende totaal delen door Q">
             <a:extLst xmlns:a="http://schemas.openxmlformats.org/drawingml/2006/main">
               <a:ext uri="{FF2B5EF4-FFF2-40B4-BE49-F238E27FC236}">
-                <a16:creationId xmlns:a16="http://schemas.microsoft.com/office/drawing/2014/main" id="{1B12EC06-B816-4C4F-84E8-A2225BBBE01B}"/>
+                <a16:creationId xmlns:a16="http://schemas.microsoft.com/office/drawing/2014/main" id="{5B5539C0-283D-4705-8F1F-317A0E3244B0}"/>
               </a:ext>
             </a:extLst>
           </p:cNvPr>
@@ -21614,7 +21650,7 @@
           <p:cNvPr id="7" name="GTK = GCK + GVK">
             <a:extLst xmlns:a="http://schemas.openxmlformats.org/drawingml/2006/main">
               <a:ext uri="{FF2B5EF4-FFF2-40B4-BE49-F238E27FC236}">
-                <a16:creationId xmlns:a16="http://schemas.microsoft.com/office/drawing/2014/main" id="{5EE927D9-87AF-45BD-A5D1-DC1E1116FC81}"/>
+                <a16:creationId xmlns:a16="http://schemas.microsoft.com/office/drawing/2014/main" id="{5C93B16A-A45B-4EFC-AC35-6A7FE6E9C1C9}"/>
               </a:ext>
             </a:extLst>
           </p:cNvPr>
@@ -21671,7 +21707,7 @@
           <p:cNvPr id="8" name="€ per fles&#10;Alleen bij Q &gt; 0">
             <a:extLst xmlns:a="http://schemas.openxmlformats.org/drawingml/2006/main">
               <a:ext uri="{FF2B5EF4-FFF2-40B4-BE49-F238E27FC236}">
-                <a16:creationId xmlns:a16="http://schemas.microsoft.com/office/drawing/2014/main" id="{57EEA467-6DD7-4D5F-AE07-C2B9873B95DC}"/>
+                <a16:creationId xmlns:a16="http://schemas.microsoft.com/office/drawing/2014/main" id="{D7B40737-EAC4-4E49-9840-D2278277651B}"/>
               </a:ext>
             </a:extLst>
           </p:cNvPr>
@@ -21749,7 +21785,7 @@
     </p:spTree>
     <p:extLst>
       <p:ext uri="{BB962C8B-B14F-4D97-AF65-F5344CB8AC3E}">
-        <p14:creationId xmlns:p14="http://schemas.microsoft.com/office/powerpoint/2010/main" val="366234787"/>
+        <p14:creationId xmlns:p14="http://schemas.microsoft.com/office/powerpoint/2010/main" val="2015230515"/>
       </p:ext>
     </p:extLst>
   </p:cSld>
@@ -21780,7 +21816,7 @@
           <p:cNvPr id="16" name="Gemiddelde kosten bij 200 flessen">
             <a:extLst xmlns:a="http://schemas.openxmlformats.org/drawingml/2006/main">
               <a:ext uri="{FF2B5EF4-FFF2-40B4-BE49-F238E27FC236}">
-                <a16:creationId xmlns:a16="http://schemas.microsoft.com/office/drawing/2014/main" id="{DDA3231B-F150-459C-8CE9-F7166B7C1378}"/>
+                <a16:creationId xmlns:a16="http://schemas.microsoft.com/office/drawing/2014/main" id="{754CE286-D6DF-44EB-9817-113E68C2790D}"/>
               </a:ext>
             </a:extLst>
           </p:cNvPr>
@@ -21837,7 +21873,7 @@
           <p:cNvPr id="2" name="">
             <a:extLst xmlns:a="http://schemas.openxmlformats.org/drawingml/2006/main">
               <a:ext uri="{FF2B5EF4-FFF2-40B4-BE49-F238E27FC236}">
-                <a16:creationId xmlns:a16="http://schemas.microsoft.com/office/drawing/2014/main" id="{D0B17D66-7655-4F35-A529-35740B5C6BA0}"/>
+                <a16:creationId xmlns:a16="http://schemas.microsoft.com/office/drawing/2014/main" id="{96301853-B4F4-426C-AC28-22D87EA34D17}"/>
               </a:ext>
             </a:extLst>
           </p:cNvPr>
@@ -21866,7 +21902,7 @@
           <p:cNvPr id="3" name="§2.1.1 Kostenstructuren">
             <a:extLst xmlns:a="http://schemas.openxmlformats.org/drawingml/2006/main">
               <a:ext uri="{FF2B5EF4-FFF2-40B4-BE49-F238E27FC236}">
-                <a16:creationId xmlns:a16="http://schemas.microsoft.com/office/drawing/2014/main" id="{1891867C-3333-487A-BB83-4D7AD9D81118}"/>
+                <a16:creationId xmlns:a16="http://schemas.microsoft.com/office/drawing/2014/main" id="{F90EB9D8-8526-46CB-B917-6CCF8C74328A}"/>
               </a:ext>
             </a:extLst>
           </p:cNvPr>
@@ -21923,7 +21959,7 @@
           <p:cNvPr id="4" name="8">
             <a:extLst xmlns:a="http://schemas.openxmlformats.org/drawingml/2006/main">
               <a:ext uri="{FF2B5EF4-FFF2-40B4-BE49-F238E27FC236}">
-                <a16:creationId xmlns:a16="http://schemas.microsoft.com/office/drawing/2014/main" id="{084C3143-43D6-4B76-8EA5-70E4AA952DFF}"/>
+                <a16:creationId xmlns:a16="http://schemas.microsoft.com/office/drawing/2014/main" id="{A55E120D-9867-4E42-910F-4BFAEBF9B51E}"/>
               </a:ext>
             </a:extLst>
           </p:cNvPr>
@@ -21980,7 +22016,7 @@
           <p:cNvPr id="5" name="Fles &amp; Co: TCK = € 300, TVK = € 400, TK = € 700 pe">
             <a:extLst xmlns:a="http://schemas.openxmlformats.org/drawingml/2006/main">
               <a:ext uri="{FF2B5EF4-FFF2-40B4-BE49-F238E27FC236}">
-                <a16:creationId xmlns:a16="http://schemas.microsoft.com/office/drawing/2014/main" id="{CCB1ADF9-B1CC-4180-9862-687F8C5A2C56}"/>
+                <a16:creationId xmlns:a16="http://schemas.microsoft.com/office/drawing/2014/main" id="{1AE37BCD-CA80-413C-B0AC-726731498509}"/>
               </a:ext>
             </a:extLst>
           </p:cNvPr>
@@ -22037,7 +22073,7 @@
           <p:cNvPr id="6" name="GCK =">
             <a:extLst xmlns:a="http://schemas.openxmlformats.org/drawingml/2006/main">
               <a:ext uri="{FF2B5EF4-FFF2-40B4-BE49-F238E27FC236}">
-                <a16:creationId xmlns:a16="http://schemas.microsoft.com/office/drawing/2014/main" id="{093F8175-77C9-4BD2-8833-E1285024564E}"/>
+                <a16:creationId xmlns:a16="http://schemas.microsoft.com/office/drawing/2014/main" id="{C743CC69-AA28-4D59-897B-B2B18CAF9928}"/>
               </a:ext>
             </a:extLst>
           </p:cNvPr>
@@ -22094,7 +22130,7 @@
           <p:cNvPr id="7" name="300 / 200">
             <a:extLst xmlns:a="http://schemas.openxmlformats.org/drawingml/2006/main">
               <a:ext uri="{FF2B5EF4-FFF2-40B4-BE49-F238E27FC236}">
-                <a16:creationId xmlns:a16="http://schemas.microsoft.com/office/drawing/2014/main" id="{0CBC3191-052A-414C-895C-D33552B44E0F}"/>
+                <a16:creationId xmlns:a16="http://schemas.microsoft.com/office/drawing/2014/main" id="{07EB5E80-4DB0-4290-BD78-590A3F088F7C}"/>
               </a:ext>
             </a:extLst>
           </p:cNvPr>
@@ -22151,7 +22187,7 @@
           <p:cNvPr id="8" name="= € 1,50 per fles">
             <a:extLst xmlns:a="http://schemas.openxmlformats.org/drawingml/2006/main">
               <a:ext uri="{FF2B5EF4-FFF2-40B4-BE49-F238E27FC236}">
-                <a16:creationId xmlns:a16="http://schemas.microsoft.com/office/drawing/2014/main" id="{7BC3663C-040D-4D95-80A8-3B950D9E5681}"/>
+                <a16:creationId xmlns:a16="http://schemas.microsoft.com/office/drawing/2014/main" id="{0530E1C9-7793-4462-B11C-B862780E9DCB}"/>
               </a:ext>
             </a:extLst>
           </p:cNvPr>
@@ -22208,7 +22244,7 @@
           <p:cNvPr id="9" name="GVK =">
             <a:extLst xmlns:a="http://schemas.openxmlformats.org/drawingml/2006/main">
               <a:ext uri="{FF2B5EF4-FFF2-40B4-BE49-F238E27FC236}">
-                <a16:creationId xmlns:a16="http://schemas.microsoft.com/office/drawing/2014/main" id="{E4EA5AED-722C-469B-A4A6-1D8B5728ED2D}"/>
+                <a16:creationId xmlns:a16="http://schemas.microsoft.com/office/drawing/2014/main" id="{2A7D23D9-60D6-4461-B6D5-F5A483DC157A}"/>
               </a:ext>
             </a:extLst>
           </p:cNvPr>
@@ -22265,7 +22301,7 @@
           <p:cNvPr id="10" name="400 / 200">
             <a:extLst xmlns:a="http://schemas.openxmlformats.org/drawingml/2006/main">
               <a:ext uri="{FF2B5EF4-FFF2-40B4-BE49-F238E27FC236}">
-                <a16:creationId xmlns:a16="http://schemas.microsoft.com/office/drawing/2014/main" id="{0D109519-12A1-4586-8558-153F58CFB893}"/>
+                <a16:creationId xmlns:a16="http://schemas.microsoft.com/office/drawing/2014/main" id="{4163318E-A252-4680-9F3F-15CE876B20D0}"/>
               </a:ext>
             </a:extLst>
           </p:cNvPr>
@@ -22322,7 +22358,7 @@
           <p:cNvPr id="11" name="= € 2,00 per fles">
             <a:extLst xmlns:a="http://schemas.openxmlformats.org/drawingml/2006/main">
               <a:ext uri="{FF2B5EF4-FFF2-40B4-BE49-F238E27FC236}">
-                <a16:creationId xmlns:a16="http://schemas.microsoft.com/office/drawing/2014/main" id="{0041F8AC-F8CC-4070-A4D7-46531A2AA2C8}"/>
+                <a16:creationId xmlns:a16="http://schemas.microsoft.com/office/drawing/2014/main" id="{BCE96A4D-6108-42C9-B926-B390172F4AC7}"/>
               </a:ext>
             </a:extLst>
           </p:cNvPr>
@@ -22379,7 +22415,7 @@
           <p:cNvPr id="12" name="GTK =">
             <a:extLst xmlns:a="http://schemas.openxmlformats.org/drawingml/2006/main">
               <a:ext uri="{FF2B5EF4-FFF2-40B4-BE49-F238E27FC236}">
-                <a16:creationId xmlns:a16="http://schemas.microsoft.com/office/drawing/2014/main" id="{FDA0D3B1-542A-4E61-87A6-B427F6E093DD}"/>
+                <a16:creationId xmlns:a16="http://schemas.microsoft.com/office/drawing/2014/main" id="{E3AB29FF-729B-4DE6-9DC9-4C249924B910}"/>
               </a:ext>
             </a:extLst>
           </p:cNvPr>
@@ -22436,7 +22472,7 @@
           <p:cNvPr id="13" name="700 / 200">
             <a:extLst xmlns:a="http://schemas.openxmlformats.org/drawingml/2006/main">
               <a:ext uri="{FF2B5EF4-FFF2-40B4-BE49-F238E27FC236}">
-                <a16:creationId xmlns:a16="http://schemas.microsoft.com/office/drawing/2014/main" id="{C3E849A5-F2FE-418B-A962-2B4362220165}"/>
+                <a16:creationId xmlns:a16="http://schemas.microsoft.com/office/drawing/2014/main" id="{64FAA781-AE08-4FCB-B062-A51E3342FE90}"/>
               </a:ext>
             </a:extLst>
           </p:cNvPr>
@@ -22493,7 +22529,7 @@
           <p:cNvPr id="14" name="= € 3,50 per fles">
             <a:extLst xmlns:a="http://schemas.openxmlformats.org/drawingml/2006/main">
               <a:ext uri="{FF2B5EF4-FFF2-40B4-BE49-F238E27FC236}">
-                <a16:creationId xmlns:a16="http://schemas.microsoft.com/office/drawing/2014/main" id="{4BFF44F8-A320-4AA5-85D9-9F18213D3021}"/>
+                <a16:creationId xmlns:a16="http://schemas.microsoft.com/office/drawing/2014/main" id="{E64DBEB6-DF9B-4C72-B813-292F50145084}"/>
               </a:ext>
             </a:extLst>
           </p:cNvPr>
@@ -22550,7 +22586,7 @@
           <p:cNvPr id="15" name="Controle: € 1,50 + € 2,00 = € 3,50 per fles">
             <a:extLst xmlns:a="http://schemas.openxmlformats.org/drawingml/2006/main">
               <a:ext uri="{FF2B5EF4-FFF2-40B4-BE49-F238E27FC236}">
-                <a16:creationId xmlns:a16="http://schemas.microsoft.com/office/drawing/2014/main" id="{8ED4F9FA-54EE-42DC-9469-566F90520E96}"/>
+                <a16:creationId xmlns:a16="http://schemas.microsoft.com/office/drawing/2014/main" id="{FB924B97-45B4-4900-A3D0-40694DA03F4F}"/>
               </a:ext>
             </a:extLst>
           </p:cNvPr>
@@ -22605,7 +22641,7 @@
     </p:spTree>
     <p:extLst>
       <p:ext uri="{BB962C8B-B14F-4D97-AF65-F5344CB8AC3E}">
-        <p14:creationId xmlns:p14="http://schemas.microsoft.com/office/powerpoint/2010/main" val="959170576"/>
+        <p14:creationId xmlns:p14="http://schemas.microsoft.com/office/powerpoint/2010/main" val="1049193125"/>
       </p:ext>
     </p:extLst>
   </p:cSld>
@@ -22636,7 +22672,7 @@
           <p:cNvPr id="9" name="Meer flessen, lagere kosten per fles">
             <a:extLst xmlns:a="http://schemas.openxmlformats.org/drawingml/2006/main">
               <a:ext uri="{FF2B5EF4-FFF2-40B4-BE49-F238E27FC236}">
-                <a16:creationId xmlns:a16="http://schemas.microsoft.com/office/drawing/2014/main" id="{9B695D8F-37B3-48CE-B876-B943E7983504}"/>
+                <a16:creationId xmlns:a16="http://schemas.microsoft.com/office/drawing/2014/main" id="{0551CCB4-734E-4F9E-B8D3-A4DE9EAF980F}"/>
               </a:ext>
             </a:extLst>
           </p:cNvPr>
@@ -22693,7 +22729,7 @@
           <p:cNvPr id="2" name="">
             <a:extLst xmlns:a="http://schemas.openxmlformats.org/drawingml/2006/main">
               <a:ext uri="{FF2B5EF4-FFF2-40B4-BE49-F238E27FC236}">
-                <a16:creationId xmlns:a16="http://schemas.microsoft.com/office/drawing/2014/main" id="{83CC76BD-8757-4A65-94E4-18EEC43D1CEA}"/>
+                <a16:creationId xmlns:a16="http://schemas.microsoft.com/office/drawing/2014/main" id="{B145B477-B458-4D2E-B863-92BF5D91BE2C}"/>
               </a:ext>
             </a:extLst>
           </p:cNvPr>
@@ -22722,7 +22758,7 @@
           <p:cNvPr id="3" name="§2.1.1 Kostenstructuren">
             <a:extLst xmlns:a="http://schemas.openxmlformats.org/drawingml/2006/main">
               <a:ext uri="{FF2B5EF4-FFF2-40B4-BE49-F238E27FC236}">
-                <a16:creationId xmlns:a16="http://schemas.microsoft.com/office/drawing/2014/main" id="{B9C88CEA-1D89-4B51-9095-0845CE9CFE81}"/>
+                <a16:creationId xmlns:a16="http://schemas.microsoft.com/office/drawing/2014/main" id="{E5F4FCD3-A51F-472B-900E-D18CB9E53A7F}"/>
               </a:ext>
             </a:extLst>
           </p:cNvPr>
@@ -22779,7 +22815,7 @@
           <p:cNvPr id="4" name="9">
             <a:extLst xmlns:a="http://schemas.openxmlformats.org/drawingml/2006/main">
               <a:ext uri="{FF2B5EF4-FFF2-40B4-BE49-F238E27FC236}">
-                <a16:creationId xmlns:a16="http://schemas.microsoft.com/office/drawing/2014/main" id="{39ABCE53-3B85-48B3-BAF5-61987A4017FF}"/>
+                <a16:creationId xmlns:a16="http://schemas.microsoft.com/office/drawing/2014/main" id="{06594D6E-72D7-48B4-AF8C-8CC4CB61CC33}"/>
               </a:ext>
             </a:extLst>
           </p:cNvPr>
@@ -23154,7 +23190,7 @@
           <p:cNvPr id="6" name="Dezelfde € 300 huur over tweemaal zoveel flessen">
             <a:extLst xmlns:a="http://schemas.openxmlformats.org/drawingml/2006/main">
               <a:ext uri="{FF2B5EF4-FFF2-40B4-BE49-F238E27FC236}">
-                <a16:creationId xmlns:a16="http://schemas.microsoft.com/office/drawing/2014/main" id="{EC548B0A-01B2-473D-A015-1F61FCCBE605}"/>
+                <a16:creationId xmlns:a16="http://schemas.microsoft.com/office/drawing/2014/main" id="{CCE1CE42-F3DB-4DF4-ADF7-4B6FEC95D1FB}"/>
               </a:ext>
             </a:extLst>
           </p:cNvPr>
@@ -23211,7 +23247,7 @@
           <p:cNvPr id="7" name="GCK halveert. Het materiaal blijft € 2 per fles.">
             <a:extLst xmlns:a="http://schemas.openxmlformats.org/drawingml/2006/main">
               <a:ext uri="{FF2B5EF4-FFF2-40B4-BE49-F238E27FC236}">
-                <a16:creationId xmlns:a16="http://schemas.microsoft.com/office/drawing/2014/main" id="{4A4DC835-BCA6-4617-A4CC-7337E9ECD840}"/>
+                <a16:creationId xmlns:a16="http://schemas.microsoft.com/office/drawing/2014/main" id="{6FD3C932-C8CD-4DC0-AAAD-FAAFF1457A55}"/>
               </a:ext>
             </a:extLst>
           </p:cNvPr>
@@ -23268,7 +23304,7 @@
           <p:cNvPr id="8" name="Daarom daalt GTK, maar GTK halveert niet.">
             <a:extLst xmlns:a="http://schemas.openxmlformats.org/drawingml/2006/main">
               <a:ext uri="{FF2B5EF4-FFF2-40B4-BE49-F238E27FC236}">
-                <a16:creationId xmlns:a16="http://schemas.microsoft.com/office/drawing/2014/main" id="{35E49991-B423-4F70-ADB3-994BEDBF5978}"/>
+                <a16:creationId xmlns:a16="http://schemas.microsoft.com/office/drawing/2014/main" id="{812E4F9E-69D6-444B-8740-86ECF1C47056}"/>
               </a:ext>
             </a:extLst>
           </p:cNvPr>
@@ -23323,7 +23359,7 @@
     </p:spTree>
     <p:extLst>
       <p:ext uri="{BB962C8B-B14F-4D97-AF65-F5344CB8AC3E}">
-        <p14:creationId xmlns:p14="http://schemas.microsoft.com/office/powerpoint/2010/main" val="1394708991"/>
+        <p14:creationId xmlns:p14="http://schemas.microsoft.com/office/powerpoint/2010/main" val="751813076"/>
       </p:ext>
     </p:extLst>
   </p:cSld>
@@ -23371,16 +23407,16 @@
         <a:srgbClr val="96607D"/>
       </a:folHlink>
     </a:clrScheme>
-    <a:fontScheme name="Office">
+    <a:fontScheme name="">
       <a:majorFont>
-        <a:latin typeface="Calibri Light"/>
-        <a:ea typeface="Calibri Light"/>
-        <a:cs typeface="Calibri Light"/>
+        <a:latin typeface="Aptos"/>
+        <a:ea typeface=""/>
+        <a:cs typeface=""/>
       </a:majorFont>
       <a:minorFont>
-        <a:latin typeface="Calibri"/>
-        <a:ea typeface="Calibri"/>
-        <a:cs typeface="Calibri"/>
+        <a:latin typeface="Aptos"/>
+        <a:ea typeface=""/>
+        <a:cs typeface=""/>
       </a:minorFont>
     </a:fontScheme>
     <a:fmtScheme name="ChatGPT">

</xml_diff>